<commit_message>
feat: arquitectura hibrida HTTPS relay en Vercel para envio de correos sin bloqueos de firewall en Render
</commit_message>
<xml_diff>
--- a/docs/PRESENTACION_AVANCE_RESIDENCIA_GPON_FINAL.pptx
+++ b/docs/PRESENTACION_AVANCE_RESIDENCIA_GPON_FINAL.pptx
@@ -289,12 +289,12 @@
   <pc:docChgLst>
     <pc:chgData name="Mauricio Nolazco" userId="8e064c700b586176" providerId="LiveId" clId="{48E4426C-FD85-428B-8823-6908DB42E28D}"/>
     <pc:docChg chg="custSel modSld">
-      <pc:chgData name="Mauricio Nolazco" userId="8e064c700b586176" providerId="LiveId" clId="{48E4426C-FD85-428B-8823-6908DB42E28D}" dt="2026-09-24T18:20:28.730" v="556" actId="1076"/>
+      <pc:chgData name="Mauricio Nolazco" userId="8e064c700b586176" providerId="LiveId" clId="{48E4426C-FD85-428B-8823-6908DB42E28D}" dt="2026-09-24T20:21:20.474" v="561" actId="1440"/>
       <pc:docMkLst>
         <pc:docMk/>
       </pc:docMkLst>
       <pc:sldChg chg="addSp delSp modSp mod">
-        <pc:chgData name="Mauricio Nolazco" userId="8e064c700b586176" providerId="LiveId" clId="{48E4426C-FD85-428B-8823-6908DB42E28D}" dt="2026-09-24T18:20:28.730" v="556" actId="1076"/>
+        <pc:chgData name="Mauricio Nolazco" userId="8e064c700b586176" providerId="LiveId" clId="{48E4426C-FD85-428B-8823-6908DB42E28D}" dt="2026-09-24T20:21:20.474" v="561" actId="1440"/>
         <pc:sldMkLst>
           <pc:docMk/>
           <pc:sldMk cId="0" sldId="265"/>
@@ -353,6 +353,14 @@
             <pc:docMk/>
             <pc:sldMk cId="0" sldId="265"/>
             <ac:picMk id="7" creationId="{99B6C722-A896-D03E-68C6-FD926DB1CA26}"/>
+          </ac:picMkLst>
+        </pc:picChg>
+        <pc:picChg chg="add mod">
+          <ac:chgData name="Mauricio Nolazco" userId="8e064c700b586176" providerId="LiveId" clId="{48E4426C-FD85-428B-8823-6908DB42E28D}" dt="2026-09-24T20:21:20.474" v="561" actId="1440"/>
+          <ac:picMkLst>
+            <pc:docMk/>
+            <pc:sldMk cId="0" sldId="265"/>
+            <ac:picMk id="9" creationId="{1E351702-9E63-5341-D8A1-D1F09B0FD65B}"/>
           </ac:picMkLst>
         </pc:picChg>
         <pc:picChg chg="mod modCrop">
@@ -17789,6 +17797,50 @@
           </a:effectLst>
         </p:spPr>
       </p:pic>
+      <p:pic>
+        <p:nvPicPr>
+          <p:cNvPr id="9" name="Imagen 8">
+            <a:extLst>
+              <a:ext uri="{FF2B5EF4-FFF2-40B4-BE49-F238E27FC236}">
+                <a16:creationId xmlns:a16="http://schemas.microsoft.com/office/drawing/2014/main" id="{1E351702-9E63-5341-D8A1-D1F09B0FD65B}"/>
+              </a:ext>
+            </a:extLst>
+          </p:cNvPr>
+          <p:cNvPicPr>
+            <a:picLocks noChangeAspect="1"/>
+          </p:cNvPicPr>
+          <p:nvPr/>
+        </p:nvPicPr>
+        <p:blipFill>
+          <a:blip r:embed="rId10"/>
+          <a:stretch>
+            <a:fillRect/>
+          </a:stretch>
+        </p:blipFill>
+        <p:spPr>
+          <a:xfrm>
+            <a:off x="4604033" y="4141091"/>
+            <a:ext cx="1440000" cy="822928"/>
+          </a:xfrm>
+          <a:prstGeom prst="rect">
+            <a:avLst/>
+          </a:prstGeom>
+          <a:ln w="38100" cap="sq">
+            <a:solidFill>
+              <a:srgbClr val="000000"/>
+            </a:solidFill>
+            <a:prstDash val="solid"/>
+            <a:miter lim="800000"/>
+          </a:ln>
+          <a:effectLst>
+            <a:outerShdw blurRad="50800" dist="38100" dir="2700000" algn="tl" rotWithShape="0">
+              <a:srgbClr val="000000">
+                <a:alpha val="43000"/>
+              </a:srgbClr>
+            </a:outerShdw>
+          </a:effectLst>
+        </p:spPr>
+      </p:pic>
     </p:spTree>
   </p:cSld>
   <p:clrMapOvr>

</xml_diff>

<commit_message>
Nuevo formulario de confirmacion de correo
</commit_message>
<xml_diff>
--- a/docs/PRESENTACION_AVANCE_RESIDENCIA_GPON_FINAL.pptx
+++ b/docs/PRESENTACION_AVANCE_RESIDENCIA_GPON_FINAL.pptx
@@ -5,7 +5,7 @@
     <p:sldMasterId id="2147483648" r:id="rId1"/>
   </p:sldMasterIdLst>
   <p:notesMasterIdLst>
-    <p:notesMasterId r:id="rId17"/>
+    <p:notesMasterId r:id="rId16"/>
   </p:notesMasterIdLst>
   <p:sldIdLst>
     <p:sldId id="256" r:id="rId2"/>
@@ -17,20 +17,19 @@
     <p:sldId id="262" r:id="rId8"/>
     <p:sldId id="263" r:id="rId9"/>
     <p:sldId id="264" r:id="rId10"/>
-    <p:sldId id="265" r:id="rId11"/>
-    <p:sldId id="266" r:id="rId12"/>
-    <p:sldId id="267" r:id="rId13"/>
-    <p:sldId id="268" r:id="rId14"/>
-    <p:sldId id="269" r:id="rId15"/>
-    <p:sldId id="270" r:id="rId16"/>
+    <p:sldId id="266" r:id="rId11"/>
+    <p:sldId id="267" r:id="rId12"/>
+    <p:sldId id="268" r:id="rId13"/>
+    <p:sldId id="269" r:id="rId14"/>
+    <p:sldId id="270" r:id="rId15"/>
   </p:sldIdLst>
   <p:sldSz cx="9144000" cy="6858000" type="screen4x3"/>
   <p:notesSz cx="6858000" cy="9144000"/>
   <p:embeddedFontLst>
     <p:embeddedFont>
       <p:font typeface="Tahoma" panose="020B0604030504040204" pitchFamily="34" charset="0"/>
-      <p:regular r:id="rId18"/>
-      <p:bold r:id="rId19"/>
+      <p:regular r:id="rId17"/>
+      <p:bold r:id="rId18"/>
     </p:embeddedFont>
   </p:embeddedFontLst>
   <p:defaultTextStyle>
@@ -284,117 +283,657 @@
 </p:presentation>
 </file>
 
+<file path=ppt/revisionInfo.xml><?xml version="1.0" encoding="utf-8"?>
+<p1510:revInfo xmlns:a="http://schemas.openxmlformats.org/drawingml/2006/main" xmlns:r="http://schemas.openxmlformats.org/officeDocument/2006/relationships" xmlns:p1510="http://schemas.microsoft.com/office/powerpoint/2015/10/main">
+  <p1510:revLst>
+    <p1510:client id="{DF7FBBA1-13ED-40CA-B0BB-281C67096509}" v="5" dt="2026-10-01T17:54:58.125"/>
+  </p1510:revLst>
+</p1510:revInfo>
+</file>
+
 <file path=ppt/changesInfos/changesInfo1.xml><?xml version="1.0" encoding="utf-8"?>
 <pc:chgInfo xmlns:a="http://schemas.openxmlformats.org/drawingml/2006/main" xmlns:r="http://schemas.openxmlformats.org/officeDocument/2006/relationships" xmlns:ac="http://schemas.microsoft.com/office/drawing/2013/main/command" xmlns:pc="http://schemas.microsoft.com/office/powerpoint/2013/main/command">
   <pc:docChgLst>
     <pc:chgData name="Mauricio Nolazco" userId="8e064c700b586176" providerId="LiveId" clId="{48E4426C-FD85-428B-8823-6908DB42E28D}"/>
-    <pc:docChg chg="custSel modSld">
-      <pc:chgData name="Mauricio Nolazco" userId="8e064c700b586176" providerId="LiveId" clId="{48E4426C-FD85-428B-8823-6908DB42E28D}" dt="2026-09-24T20:21:20.474" v="561" actId="1440"/>
+    <pc:docChg chg="undo custSel delSld modSld">
+      <pc:chgData name="Mauricio Nolazco" userId="8e064c700b586176" providerId="LiveId" clId="{48E4426C-FD85-428B-8823-6908DB42E28D}" dt="2026-10-01T18:33:38.605" v="816" actId="20577"/>
       <pc:docMkLst>
         <pc:docMk/>
       </pc:docMkLst>
+      <pc:sldChg chg="modSp mod">
+        <pc:chgData name="Mauricio Nolazco" userId="8e064c700b586176" providerId="LiveId" clId="{48E4426C-FD85-428B-8823-6908DB42E28D}" dt="2026-10-01T17:48:24.758" v="608" actId="207"/>
+        <pc:sldMkLst>
+          <pc:docMk/>
+          <pc:sldMk cId="0" sldId="256"/>
+        </pc:sldMkLst>
+        <pc:spChg chg="mod">
+          <ac:chgData name="Mauricio Nolazco" userId="8e064c700b586176" providerId="LiveId" clId="{48E4426C-FD85-428B-8823-6908DB42E28D}" dt="2026-10-01T17:48:24.758" v="608" actId="207"/>
+          <ac:spMkLst>
+            <pc:docMk/>
+            <pc:sldMk cId="0" sldId="256"/>
+            <ac:spMk id="91" creationId="{00000000-0000-0000-0000-000000000000}"/>
+          </ac:spMkLst>
+        </pc:spChg>
+        <pc:spChg chg="mod">
+          <ac:chgData name="Mauricio Nolazco" userId="8e064c700b586176" providerId="LiveId" clId="{48E4426C-FD85-428B-8823-6908DB42E28D}" dt="2026-10-01T17:48:20.652" v="607" actId="1076"/>
+          <ac:spMkLst>
+            <pc:docMk/>
+            <pc:sldMk cId="0" sldId="256"/>
+            <ac:spMk id="92" creationId="{00000000-0000-0000-0000-000000000000}"/>
+          </ac:spMkLst>
+        </pc:spChg>
+        <pc:spChg chg="mod">
+          <ac:chgData name="Mauricio Nolazco" userId="8e064c700b586176" providerId="LiveId" clId="{48E4426C-FD85-428B-8823-6908DB42E28D}" dt="2026-10-01T17:43:39.566" v="572" actId="790"/>
+          <ac:spMkLst>
+            <pc:docMk/>
+            <pc:sldMk cId="0" sldId="256"/>
+            <ac:spMk id="93" creationId="{00000000-0000-0000-0000-000000000000}"/>
+          </ac:spMkLst>
+        </pc:spChg>
+      </pc:sldChg>
+      <pc:sldChg chg="modSp mod">
+        <pc:chgData name="Mauricio Nolazco" userId="8e064c700b586176" providerId="LiveId" clId="{48E4426C-FD85-428B-8823-6908DB42E28D}" dt="2026-10-01T17:43:39.566" v="572" actId="790"/>
+        <pc:sldMkLst>
+          <pc:docMk/>
+          <pc:sldMk cId="0" sldId="257"/>
+        </pc:sldMkLst>
+        <pc:spChg chg="mod">
+          <ac:chgData name="Mauricio Nolazco" userId="8e064c700b586176" providerId="LiveId" clId="{48E4426C-FD85-428B-8823-6908DB42E28D}" dt="2026-10-01T17:43:39.566" v="572" actId="790"/>
+          <ac:spMkLst>
+            <pc:docMk/>
+            <pc:sldMk cId="0" sldId="257"/>
+            <ac:spMk id="99" creationId="{00000000-0000-0000-0000-000000000000}"/>
+          </ac:spMkLst>
+        </pc:spChg>
+        <pc:spChg chg="mod">
+          <ac:chgData name="Mauricio Nolazco" userId="8e064c700b586176" providerId="LiveId" clId="{48E4426C-FD85-428B-8823-6908DB42E28D}" dt="2026-10-01T17:43:39.566" v="572" actId="790"/>
+          <ac:spMkLst>
+            <pc:docMk/>
+            <pc:sldMk cId="0" sldId="257"/>
+            <ac:spMk id="100" creationId="{00000000-0000-0000-0000-000000000000}"/>
+          </ac:spMkLst>
+        </pc:spChg>
+        <pc:spChg chg="mod">
+          <ac:chgData name="Mauricio Nolazco" userId="8e064c700b586176" providerId="LiveId" clId="{48E4426C-FD85-428B-8823-6908DB42E28D}" dt="2026-10-01T17:43:39.566" v="572" actId="790"/>
+          <ac:spMkLst>
+            <pc:docMk/>
+            <pc:sldMk cId="0" sldId="257"/>
+            <ac:spMk id="101" creationId="{00000000-0000-0000-0000-000000000000}"/>
+          </ac:spMkLst>
+        </pc:spChg>
+      </pc:sldChg>
+      <pc:sldChg chg="delSp modSp mod">
+        <pc:chgData name="Mauricio Nolazco" userId="8e064c700b586176" providerId="LiveId" clId="{48E4426C-FD85-428B-8823-6908DB42E28D}" dt="2026-10-01T18:26:29.119" v="730" actId="20577"/>
+        <pc:sldMkLst>
+          <pc:docMk/>
+          <pc:sldMk cId="0" sldId="258"/>
+        </pc:sldMkLst>
+        <pc:spChg chg="mod">
+          <ac:chgData name="Mauricio Nolazco" userId="8e064c700b586176" providerId="LiveId" clId="{48E4426C-FD85-428B-8823-6908DB42E28D}" dt="2026-10-01T18:26:29.119" v="730" actId="20577"/>
+          <ac:spMkLst>
+            <pc:docMk/>
+            <pc:sldMk cId="0" sldId="258"/>
+            <ac:spMk id="106" creationId="{00000000-0000-0000-0000-000000000000}"/>
+          </ac:spMkLst>
+        </pc:spChg>
+        <pc:spChg chg="mod">
+          <ac:chgData name="Mauricio Nolazco" userId="8e064c700b586176" providerId="LiveId" clId="{48E4426C-FD85-428B-8823-6908DB42E28D}" dt="2026-10-01T17:43:39.566" v="572" actId="790"/>
+          <ac:spMkLst>
+            <pc:docMk/>
+            <pc:sldMk cId="0" sldId="258"/>
+            <ac:spMk id="108" creationId="{00000000-0000-0000-0000-000000000000}"/>
+          </ac:spMkLst>
+        </pc:spChg>
+        <pc:spChg chg="mod">
+          <ac:chgData name="Mauricio Nolazco" userId="8e064c700b586176" providerId="LiveId" clId="{48E4426C-FD85-428B-8823-6908DB42E28D}" dt="2026-10-01T17:43:39.566" v="572" actId="790"/>
+          <ac:spMkLst>
+            <pc:docMk/>
+            <pc:sldMk cId="0" sldId="258"/>
+            <ac:spMk id="109" creationId="{00000000-0000-0000-0000-000000000000}"/>
+          </ac:spMkLst>
+        </pc:spChg>
+        <pc:spChg chg="del mod">
+          <ac:chgData name="Mauricio Nolazco" userId="8e064c700b586176" providerId="LiveId" clId="{48E4426C-FD85-428B-8823-6908DB42E28D}" dt="2026-10-01T17:48:08.823" v="605" actId="478"/>
+          <ac:spMkLst>
+            <pc:docMk/>
+            <pc:sldMk cId="0" sldId="258"/>
+            <ac:spMk id="111" creationId="{00000000-0000-0000-0000-000000000000}"/>
+          </ac:spMkLst>
+        </pc:spChg>
+      </pc:sldChg>
+      <pc:sldChg chg="delSp modSp mod">
+        <pc:chgData name="Mauricio Nolazco" userId="8e064c700b586176" providerId="LiveId" clId="{48E4426C-FD85-428B-8823-6908DB42E28D}" dt="2026-10-01T17:48:33.691" v="609" actId="478"/>
+        <pc:sldMkLst>
+          <pc:docMk/>
+          <pc:sldMk cId="0" sldId="259"/>
+        </pc:sldMkLst>
+        <pc:spChg chg="mod">
+          <ac:chgData name="Mauricio Nolazco" userId="8e064c700b586176" providerId="LiveId" clId="{48E4426C-FD85-428B-8823-6908DB42E28D}" dt="2026-10-01T17:43:39.566" v="572" actId="790"/>
+          <ac:spMkLst>
+            <pc:docMk/>
+            <pc:sldMk cId="0" sldId="259"/>
+            <ac:spMk id="117" creationId="{00000000-0000-0000-0000-000000000000}"/>
+          </ac:spMkLst>
+        </pc:spChg>
+        <pc:spChg chg="mod">
+          <ac:chgData name="Mauricio Nolazco" userId="8e064c700b586176" providerId="LiveId" clId="{48E4426C-FD85-428B-8823-6908DB42E28D}" dt="2026-10-01T17:43:39.566" v="572" actId="790"/>
+          <ac:spMkLst>
+            <pc:docMk/>
+            <pc:sldMk cId="0" sldId="259"/>
+            <ac:spMk id="118" creationId="{00000000-0000-0000-0000-000000000000}"/>
+          </ac:spMkLst>
+        </pc:spChg>
+        <pc:spChg chg="del mod">
+          <ac:chgData name="Mauricio Nolazco" userId="8e064c700b586176" providerId="LiveId" clId="{48E4426C-FD85-428B-8823-6908DB42E28D}" dt="2026-10-01T17:48:33.691" v="609" actId="478"/>
+          <ac:spMkLst>
+            <pc:docMk/>
+            <pc:sldMk cId="0" sldId="259"/>
+            <ac:spMk id="121" creationId="{00000000-0000-0000-0000-000000000000}"/>
+          </ac:spMkLst>
+        </pc:spChg>
+      </pc:sldChg>
+      <pc:sldChg chg="modSp mod">
+        <pc:chgData name="Mauricio Nolazco" userId="8e064c700b586176" providerId="LiveId" clId="{48E4426C-FD85-428B-8823-6908DB42E28D}" dt="2026-10-01T18:26:41.461" v="732" actId="20577"/>
+        <pc:sldMkLst>
+          <pc:docMk/>
+          <pc:sldMk cId="0" sldId="260"/>
+        </pc:sldMkLst>
+        <pc:spChg chg="mod">
+          <ac:chgData name="Mauricio Nolazco" userId="8e064c700b586176" providerId="LiveId" clId="{48E4426C-FD85-428B-8823-6908DB42E28D}" dt="2026-10-01T18:26:41.461" v="732" actId="20577"/>
+          <ac:spMkLst>
+            <pc:docMk/>
+            <pc:sldMk cId="0" sldId="260"/>
+            <ac:spMk id="127" creationId="{00000000-0000-0000-0000-000000000000}"/>
+          </ac:spMkLst>
+        </pc:spChg>
+        <pc:spChg chg="mod">
+          <ac:chgData name="Mauricio Nolazco" userId="8e064c700b586176" providerId="LiveId" clId="{48E4426C-FD85-428B-8823-6908DB42E28D}" dt="2026-10-01T17:43:39.566" v="572" actId="790"/>
+          <ac:spMkLst>
+            <pc:docMk/>
+            <pc:sldMk cId="0" sldId="260"/>
+            <ac:spMk id="128" creationId="{00000000-0000-0000-0000-000000000000}"/>
+          </ac:spMkLst>
+        </pc:spChg>
+        <pc:spChg chg="mod">
+          <ac:chgData name="Mauricio Nolazco" userId="8e064c700b586176" providerId="LiveId" clId="{48E4426C-FD85-428B-8823-6908DB42E28D}" dt="2026-10-01T17:43:39.566" v="572" actId="790"/>
+          <ac:spMkLst>
+            <pc:docMk/>
+            <pc:sldMk cId="0" sldId="260"/>
+            <ac:spMk id="129" creationId="{00000000-0000-0000-0000-000000000000}"/>
+          </ac:spMkLst>
+        </pc:spChg>
+      </pc:sldChg>
+      <pc:sldChg chg="modSp mod">
+        <pc:chgData name="Mauricio Nolazco" userId="8e064c700b586176" providerId="LiveId" clId="{48E4426C-FD85-428B-8823-6908DB42E28D}" dt="2026-10-01T18:27:22.506" v="767" actId="20577"/>
+        <pc:sldMkLst>
+          <pc:docMk/>
+          <pc:sldMk cId="0" sldId="261"/>
+        </pc:sldMkLst>
+        <pc:spChg chg="mod">
+          <ac:chgData name="Mauricio Nolazco" userId="8e064c700b586176" providerId="LiveId" clId="{48E4426C-FD85-428B-8823-6908DB42E28D}" dt="2026-10-01T18:27:22.506" v="767" actId="20577"/>
+          <ac:spMkLst>
+            <pc:docMk/>
+            <pc:sldMk cId="0" sldId="261"/>
+            <ac:spMk id="135" creationId="{00000000-0000-0000-0000-000000000000}"/>
+          </ac:spMkLst>
+        </pc:spChg>
+        <pc:spChg chg="mod">
+          <ac:chgData name="Mauricio Nolazco" userId="8e064c700b586176" providerId="LiveId" clId="{48E4426C-FD85-428B-8823-6908DB42E28D}" dt="2026-10-01T17:43:39.566" v="572" actId="790"/>
+          <ac:spMkLst>
+            <pc:docMk/>
+            <pc:sldMk cId="0" sldId="261"/>
+            <ac:spMk id="136" creationId="{00000000-0000-0000-0000-000000000000}"/>
+          </ac:spMkLst>
+        </pc:spChg>
+        <pc:spChg chg="mod">
+          <ac:chgData name="Mauricio Nolazco" userId="8e064c700b586176" providerId="LiveId" clId="{48E4426C-FD85-428B-8823-6908DB42E28D}" dt="2026-10-01T17:43:39.566" v="572" actId="790"/>
+          <ac:spMkLst>
+            <pc:docMk/>
+            <pc:sldMk cId="0" sldId="261"/>
+            <ac:spMk id="137" creationId="{00000000-0000-0000-0000-000000000000}"/>
+          </ac:spMkLst>
+        </pc:spChg>
+      </pc:sldChg>
+      <pc:sldChg chg="modSp mod">
+        <pc:chgData name="Mauricio Nolazco" userId="8e064c700b586176" providerId="LiveId" clId="{48E4426C-FD85-428B-8823-6908DB42E28D}" dt="2026-10-01T18:33:38.605" v="816" actId="20577"/>
+        <pc:sldMkLst>
+          <pc:docMk/>
+          <pc:sldMk cId="0" sldId="262"/>
+        </pc:sldMkLst>
+        <pc:spChg chg="mod">
+          <ac:chgData name="Mauricio Nolazco" userId="8e064c700b586176" providerId="LiveId" clId="{48E4426C-FD85-428B-8823-6908DB42E28D}" dt="2026-10-01T17:43:39.566" v="572" actId="790"/>
+          <ac:spMkLst>
+            <pc:docMk/>
+            <pc:sldMk cId="0" sldId="262"/>
+            <ac:spMk id="143" creationId="{00000000-0000-0000-0000-000000000000}"/>
+          </ac:spMkLst>
+        </pc:spChg>
+        <pc:spChg chg="mod">
+          <ac:chgData name="Mauricio Nolazco" userId="8e064c700b586176" providerId="LiveId" clId="{48E4426C-FD85-428B-8823-6908DB42E28D}" dt="2026-10-01T17:43:39.566" v="572" actId="790"/>
+          <ac:spMkLst>
+            <pc:docMk/>
+            <pc:sldMk cId="0" sldId="262"/>
+            <ac:spMk id="144" creationId="{00000000-0000-0000-0000-000000000000}"/>
+          </ac:spMkLst>
+        </pc:spChg>
+        <pc:spChg chg="mod">
+          <ac:chgData name="Mauricio Nolazco" userId="8e064c700b586176" providerId="LiveId" clId="{48E4426C-FD85-428B-8823-6908DB42E28D}" dt="2026-10-01T18:33:38.605" v="816" actId="20577"/>
+          <ac:spMkLst>
+            <pc:docMk/>
+            <pc:sldMk cId="0" sldId="262"/>
+            <ac:spMk id="145" creationId="{00000000-0000-0000-0000-000000000000}"/>
+          </ac:spMkLst>
+        </pc:spChg>
+      </pc:sldChg>
+      <pc:sldChg chg="modSp mod">
+        <pc:chgData name="Mauricio Nolazco" userId="8e064c700b586176" providerId="LiveId" clId="{48E4426C-FD85-428B-8823-6908DB42E28D}" dt="2026-10-01T17:49:31.738" v="610" actId="255"/>
+        <pc:sldMkLst>
+          <pc:docMk/>
+          <pc:sldMk cId="0" sldId="263"/>
+        </pc:sldMkLst>
+        <pc:spChg chg="mod">
+          <ac:chgData name="Mauricio Nolazco" userId="8e064c700b586176" providerId="LiveId" clId="{48E4426C-FD85-428B-8823-6908DB42E28D}" dt="2026-10-01T17:49:31.738" v="610" actId="255"/>
+          <ac:spMkLst>
+            <pc:docMk/>
+            <pc:sldMk cId="0" sldId="263"/>
+            <ac:spMk id="151" creationId="{00000000-0000-0000-0000-000000000000}"/>
+          </ac:spMkLst>
+        </pc:spChg>
+        <pc:spChg chg="mod">
+          <ac:chgData name="Mauricio Nolazco" userId="8e064c700b586176" providerId="LiveId" clId="{48E4426C-FD85-428B-8823-6908DB42E28D}" dt="2026-10-01T17:43:39.566" v="572" actId="790"/>
+          <ac:spMkLst>
+            <pc:docMk/>
+            <pc:sldMk cId="0" sldId="263"/>
+            <ac:spMk id="152" creationId="{00000000-0000-0000-0000-000000000000}"/>
+          </ac:spMkLst>
+        </pc:spChg>
+        <pc:spChg chg="mod">
+          <ac:chgData name="Mauricio Nolazco" userId="8e064c700b586176" providerId="LiveId" clId="{48E4426C-FD85-428B-8823-6908DB42E28D}" dt="2026-10-01T17:43:39.566" v="572" actId="790"/>
+          <ac:spMkLst>
+            <pc:docMk/>
+            <pc:sldMk cId="0" sldId="263"/>
+            <ac:spMk id="153" creationId="{00000000-0000-0000-0000-000000000000}"/>
+          </ac:spMkLst>
+        </pc:spChg>
+      </pc:sldChg>
       <pc:sldChg chg="addSp delSp modSp mod">
-        <pc:chgData name="Mauricio Nolazco" userId="8e064c700b586176" providerId="LiveId" clId="{48E4426C-FD85-428B-8823-6908DB42E28D}" dt="2026-09-24T20:21:20.474" v="561" actId="1440"/>
+        <pc:chgData name="Mauricio Nolazco" userId="8e064c700b586176" providerId="LiveId" clId="{48E4426C-FD85-428B-8823-6908DB42E28D}" dt="2026-10-01T17:57:59.757" v="705" actId="1076"/>
+        <pc:sldMkLst>
+          <pc:docMk/>
+          <pc:sldMk cId="0" sldId="264"/>
+        </pc:sldMkLst>
+        <pc:spChg chg="add mod">
+          <ac:chgData name="Mauricio Nolazco" userId="8e064c700b586176" providerId="LiveId" clId="{48E4426C-FD85-428B-8823-6908DB42E28D}" dt="2026-10-01T17:57:59.757" v="705" actId="1076"/>
+          <ac:spMkLst>
+            <pc:docMk/>
+            <pc:sldMk cId="0" sldId="264"/>
+            <ac:spMk id="2" creationId="{A749F498-D431-C86C-B805-9F6D5C9B938B}"/>
+          </ac:spMkLst>
+        </pc:spChg>
+        <pc:spChg chg="add mod">
+          <ac:chgData name="Mauricio Nolazco" userId="8e064c700b586176" providerId="LiveId" clId="{48E4426C-FD85-428B-8823-6908DB42E28D}" dt="2026-10-01T17:57:07.556" v="691" actId="1076"/>
+          <ac:spMkLst>
+            <pc:docMk/>
+            <pc:sldMk cId="0" sldId="264"/>
+            <ac:spMk id="3" creationId="{F4C40722-6710-9592-D786-497A053D4FC2}"/>
+          </ac:spMkLst>
+        </pc:spChg>
+        <pc:spChg chg="add del mod">
+          <ac:chgData name="Mauricio Nolazco" userId="8e064c700b586176" providerId="LiveId" clId="{48E4426C-FD85-428B-8823-6908DB42E28D}" dt="2026-10-01T17:54:51.262" v="654"/>
+          <ac:spMkLst>
+            <pc:docMk/>
+            <pc:sldMk cId="0" sldId="264"/>
+            <ac:spMk id="4" creationId="{EC40249D-1474-D09B-B331-85E905BB84D6}"/>
+          </ac:spMkLst>
+        </pc:spChg>
+        <pc:spChg chg="add mod">
+          <ac:chgData name="Mauricio Nolazco" userId="8e064c700b586176" providerId="LiveId" clId="{48E4426C-FD85-428B-8823-6908DB42E28D}" dt="2026-10-01T17:57:51.867" v="703" actId="1076"/>
+          <ac:spMkLst>
+            <pc:docMk/>
+            <pc:sldMk cId="0" sldId="264"/>
+            <ac:spMk id="5" creationId="{8ED9B067-6DFA-C3BC-FA82-AC8BDFF41E33}"/>
+          </ac:spMkLst>
+        </pc:spChg>
+        <pc:spChg chg="mod">
+          <ac:chgData name="Mauricio Nolazco" userId="8e064c700b586176" providerId="LiveId" clId="{48E4426C-FD85-428B-8823-6908DB42E28D}" dt="2026-10-01T17:50:34.345" v="616" actId="207"/>
+          <ac:spMkLst>
+            <pc:docMk/>
+            <pc:sldMk cId="0" sldId="264"/>
+            <ac:spMk id="160" creationId="{00000000-0000-0000-0000-000000000000}"/>
+          </ac:spMkLst>
+        </pc:spChg>
+        <pc:spChg chg="mod">
+          <ac:chgData name="Mauricio Nolazco" userId="8e064c700b586176" providerId="LiveId" clId="{48E4426C-FD85-428B-8823-6908DB42E28D}" dt="2026-10-01T17:43:39.566" v="572" actId="790"/>
+          <ac:spMkLst>
+            <pc:docMk/>
+            <pc:sldMk cId="0" sldId="264"/>
+            <ac:spMk id="161" creationId="{00000000-0000-0000-0000-000000000000}"/>
+          </ac:spMkLst>
+        </pc:spChg>
+        <pc:spChg chg="del mod">
+          <ac:chgData name="Mauricio Nolazco" userId="8e064c700b586176" providerId="LiveId" clId="{48E4426C-FD85-428B-8823-6908DB42E28D}" dt="2026-10-01T17:50:38.053" v="617" actId="478"/>
+          <ac:spMkLst>
+            <pc:docMk/>
+            <pc:sldMk cId="0" sldId="264"/>
+            <ac:spMk id="162" creationId="{00000000-0000-0000-0000-000000000000}"/>
+          </ac:spMkLst>
+        </pc:spChg>
+        <pc:picChg chg="add mod modCrop">
+          <ac:chgData name="Mauricio Nolazco" userId="8e064c700b586176" providerId="LiveId" clId="{48E4426C-FD85-428B-8823-6908DB42E28D}" dt="2026-10-01T17:57:53.540" v="704" actId="1076"/>
+          <ac:picMkLst>
+            <pc:docMk/>
+            <pc:sldMk cId="0" sldId="264"/>
+            <ac:picMk id="6" creationId="{EA1A0C59-E598-1339-5263-2944F0B67279}"/>
+          </ac:picMkLst>
+        </pc:picChg>
+        <pc:picChg chg="del mod">
+          <ac:chgData name="Mauricio Nolazco" userId="8e064c700b586176" providerId="LiveId" clId="{48E4426C-FD85-428B-8823-6908DB42E28D}" dt="2026-10-01T17:55:37.271" v="676" actId="478"/>
+          <ac:picMkLst>
+            <pc:docMk/>
+            <pc:sldMk cId="0" sldId="264"/>
+            <ac:picMk id="163" creationId="{00000000-0000-0000-0000-000000000000}"/>
+          </ac:picMkLst>
+        </pc:picChg>
+        <pc:picChg chg="mod">
+          <ac:chgData name="Mauricio Nolazco" userId="8e064c700b586176" providerId="LiveId" clId="{48E4426C-FD85-428B-8823-6908DB42E28D}" dt="2026-10-01T17:56:42.564" v="686" actId="1076"/>
+          <ac:picMkLst>
+            <pc:docMk/>
+            <pc:sldMk cId="0" sldId="264"/>
+            <ac:picMk id="164" creationId="{00000000-0000-0000-0000-000000000000}"/>
+          </ac:picMkLst>
+        </pc:picChg>
+        <pc:picChg chg="mod">
+          <ac:chgData name="Mauricio Nolazco" userId="8e064c700b586176" providerId="LiveId" clId="{48E4426C-FD85-428B-8823-6908DB42E28D}" dt="2026-10-01T17:57:19.834" v="695" actId="1076"/>
+          <ac:picMkLst>
+            <pc:docMk/>
+            <pc:sldMk cId="0" sldId="264"/>
+            <ac:picMk id="165" creationId="{00000000-0000-0000-0000-000000000000}"/>
+          </ac:picMkLst>
+        </pc:picChg>
+        <pc:picChg chg="mod">
+          <ac:chgData name="Mauricio Nolazco" userId="8e064c700b586176" providerId="LiveId" clId="{48E4426C-FD85-428B-8823-6908DB42E28D}" dt="2026-10-01T17:56:52.376" v="689" actId="1076"/>
+          <ac:picMkLst>
+            <pc:docMk/>
+            <pc:sldMk cId="0" sldId="264"/>
+            <ac:picMk id="166" creationId="{00000000-0000-0000-0000-000000000000}"/>
+          </ac:picMkLst>
+        </pc:picChg>
+        <pc:picChg chg="mod">
+          <ac:chgData name="Mauricio Nolazco" userId="8e064c700b586176" providerId="LiveId" clId="{48E4426C-FD85-428B-8823-6908DB42E28D}" dt="2026-10-01T17:56:49.418" v="688" actId="1076"/>
+          <ac:picMkLst>
+            <pc:docMk/>
+            <pc:sldMk cId="0" sldId="264"/>
+            <ac:picMk id="167" creationId="{00000000-0000-0000-0000-000000000000}"/>
+          </ac:picMkLst>
+        </pc:picChg>
+        <pc:picChg chg="mod">
+          <ac:chgData name="Mauricio Nolazco" userId="8e064c700b586176" providerId="LiveId" clId="{48E4426C-FD85-428B-8823-6908DB42E28D}" dt="2026-10-01T17:56:47.083" v="687" actId="1076"/>
+          <ac:picMkLst>
+            <pc:docMk/>
+            <pc:sldMk cId="0" sldId="264"/>
+            <ac:picMk id="168" creationId="{00000000-0000-0000-0000-000000000000}"/>
+          </ac:picMkLst>
+        </pc:picChg>
+        <pc:picChg chg="mod">
+          <ac:chgData name="Mauricio Nolazco" userId="8e064c700b586176" providerId="LiveId" clId="{48E4426C-FD85-428B-8823-6908DB42E28D}" dt="2026-10-01T17:57:15.629" v="694" actId="1076"/>
+          <ac:picMkLst>
+            <pc:docMk/>
+            <pc:sldMk cId="0" sldId="264"/>
+            <ac:picMk id="169" creationId="{00000000-0000-0000-0000-000000000000}"/>
+          </ac:picMkLst>
+        </pc:picChg>
+        <pc:picChg chg="mod">
+          <ac:chgData name="Mauricio Nolazco" userId="8e064c700b586176" providerId="LiveId" clId="{48E4426C-FD85-428B-8823-6908DB42E28D}" dt="2026-10-01T17:57:25.535" v="697" actId="1076"/>
+          <ac:picMkLst>
+            <pc:docMk/>
+            <pc:sldMk cId="0" sldId="264"/>
+            <ac:picMk id="170" creationId="{00000000-0000-0000-0000-000000000000}"/>
+          </ac:picMkLst>
+        </pc:picChg>
+        <pc:picChg chg="mod">
+          <ac:chgData name="Mauricio Nolazco" userId="8e064c700b586176" providerId="LiveId" clId="{48E4426C-FD85-428B-8823-6908DB42E28D}" dt="2026-10-01T17:57:33.156" v="699" actId="1076"/>
+          <ac:picMkLst>
+            <pc:docMk/>
+            <pc:sldMk cId="0" sldId="264"/>
+            <ac:picMk id="171" creationId="{00000000-0000-0000-0000-000000000000}"/>
+          </ac:picMkLst>
+        </pc:picChg>
+        <pc:picChg chg="mod">
+          <ac:chgData name="Mauricio Nolazco" userId="8e064c700b586176" providerId="LiveId" clId="{48E4426C-FD85-428B-8823-6908DB42E28D}" dt="2026-10-01T17:57:13.680" v="693" actId="1076"/>
+          <ac:picMkLst>
+            <pc:docMk/>
+            <pc:sldMk cId="0" sldId="264"/>
+            <ac:picMk id="172" creationId="{00000000-0000-0000-0000-000000000000}"/>
+          </ac:picMkLst>
+        </pc:picChg>
+        <pc:picChg chg="mod">
+          <ac:chgData name="Mauricio Nolazco" userId="8e064c700b586176" providerId="LiveId" clId="{48E4426C-FD85-428B-8823-6908DB42E28D}" dt="2026-10-01T17:57:22.300" v="696" actId="1076"/>
+          <ac:picMkLst>
+            <pc:docMk/>
+            <pc:sldMk cId="0" sldId="264"/>
+            <ac:picMk id="173" creationId="{00000000-0000-0000-0000-000000000000}"/>
+          </ac:picMkLst>
+        </pc:picChg>
+        <pc:picChg chg="mod">
+          <ac:chgData name="Mauricio Nolazco" userId="8e064c700b586176" providerId="LiveId" clId="{48E4426C-FD85-428B-8823-6908DB42E28D}" dt="2026-10-01T17:57:29.841" v="698" actId="1076"/>
+          <ac:picMkLst>
+            <pc:docMk/>
+            <pc:sldMk cId="0" sldId="264"/>
+            <ac:picMk id="174" creationId="{00000000-0000-0000-0000-000000000000}"/>
+          </ac:picMkLst>
+        </pc:picChg>
+      </pc:sldChg>
+      <pc:sldChg chg="addSp delSp modSp del mod">
+        <pc:chgData name="Mauricio Nolazco" userId="8e064c700b586176" providerId="LiveId" clId="{48E4426C-FD85-428B-8823-6908DB42E28D}" dt="2026-10-01T18:32:27.864" v="769" actId="2696"/>
         <pc:sldMkLst>
           <pc:docMk/>
           <pc:sldMk cId="0" sldId="265"/>
         </pc:sldMkLst>
         <pc:spChg chg="del mod">
-          <ac:chgData name="Mauricio Nolazco" userId="8e064c700b586176" providerId="LiveId" clId="{48E4426C-FD85-428B-8823-6908DB42E28D}" dt="2026-09-24T17:36:15.427" v="507"/>
+          <ac:chgData name="Mauricio Nolazco" userId="8e064c700b586176" providerId="LiveId" clId="{48E4426C-FD85-428B-8823-6908DB42E28D}" dt="2026-10-01T18:27:47.503" v="768" actId="478"/>
+          <ac:spMkLst>
+            <pc:docMk/>
+            <pc:sldMk cId="0" sldId="265"/>
+            <ac:spMk id="167" creationId="{00000000-0000-0000-0000-000000000000}"/>
+          </ac:spMkLst>
+        </pc:spChg>
+        <pc:spChg chg="mod">
+          <ac:chgData name="Mauricio Nolazco" userId="8e064c700b586176" providerId="LiveId" clId="{48E4426C-FD85-428B-8823-6908DB42E28D}" dt="2026-10-01T17:43:39.566" v="572" actId="790"/>
+          <ac:spMkLst>
+            <pc:docMk/>
+            <pc:sldMk cId="0" sldId="265"/>
+            <ac:spMk id="168" creationId="{00000000-0000-0000-0000-000000000000}"/>
+          </ac:spMkLst>
+        </pc:spChg>
+        <pc:spChg chg="del mod">
+          <ac:chgData name="Mauricio Nolazco" userId="8e064c700b586176" providerId="LiveId" clId="{48E4426C-FD85-428B-8823-6908DB42E28D}" dt="2026-10-01T17:43:39.566" v="572" actId="790"/>
           <ac:spMkLst>
             <pc:docMk/>
             <pc:sldMk cId="0" sldId="265"/>
             <ac:spMk id="170" creationId="{00000000-0000-0000-0000-000000000000}"/>
           </ac:spMkLst>
         </pc:spChg>
-        <pc:picChg chg="add mod">
-          <ac:chgData name="Mauricio Nolazco" userId="8e064c700b586176" providerId="LiveId" clId="{48E4426C-FD85-428B-8823-6908DB42E28D}" dt="2026-09-24T18:20:21.477" v="552" actId="1076"/>
+      </pc:sldChg>
+      <pc:sldChg chg="addSp delSp modSp mod">
+        <pc:chgData name="Mauricio Nolazco" userId="8e064c700b586176" providerId="LiveId" clId="{48E4426C-FD85-428B-8823-6908DB42E28D}" dt="2026-10-01T18:33:03.239" v="784" actId="478"/>
+        <pc:sldMkLst>
+          <pc:docMk/>
+          <pc:sldMk cId="0" sldId="266"/>
+        </pc:sldMkLst>
+        <pc:spChg chg="add mod">
+          <ac:chgData name="Mauricio Nolazco" userId="8e064c700b586176" providerId="LiveId" clId="{48E4426C-FD85-428B-8823-6908DB42E28D}" dt="2026-10-01T18:32:55.962" v="782" actId="20577"/>
+          <ac:spMkLst>
+            <pc:docMk/>
+            <pc:sldMk cId="0" sldId="266"/>
+            <ac:spMk id="4" creationId="{5B702F44-2088-B063-4BD6-B60713F5764E}"/>
+          </ac:spMkLst>
+        </pc:spChg>
+        <pc:spChg chg="del mod">
+          <ac:chgData name="Mauricio Nolazco" userId="8e064c700b586176" providerId="LiveId" clId="{48E4426C-FD85-428B-8823-6908DB42E28D}" dt="2026-10-01T18:32:36.781" v="770" actId="478"/>
+          <ac:spMkLst>
+            <pc:docMk/>
+            <pc:sldMk cId="0" sldId="266"/>
+            <ac:spMk id="190" creationId="{00000000-0000-0000-0000-000000000000}"/>
+          </ac:spMkLst>
+        </pc:spChg>
+        <pc:spChg chg="mod">
+          <ac:chgData name="Mauricio Nolazco" userId="8e064c700b586176" providerId="LiveId" clId="{48E4426C-FD85-428B-8823-6908DB42E28D}" dt="2026-10-01T17:43:39.566" v="572" actId="790"/>
+          <ac:spMkLst>
+            <pc:docMk/>
+            <pc:sldMk cId="0" sldId="266"/>
+            <ac:spMk id="191" creationId="{00000000-0000-0000-0000-000000000000}"/>
+          </ac:spMkLst>
+        </pc:spChg>
+        <pc:spChg chg="del mod">
+          <ac:chgData name="Mauricio Nolazco" userId="8e064c700b586176" providerId="LiveId" clId="{48E4426C-FD85-428B-8823-6908DB42E28D}" dt="2026-10-01T18:33:03.239" v="784" actId="478"/>
+          <ac:spMkLst>
+            <pc:docMk/>
+            <pc:sldMk cId="0" sldId="266"/>
+            <ac:spMk id="193" creationId="{00000000-0000-0000-0000-000000000000}"/>
+          </ac:spMkLst>
+        </pc:spChg>
+        <pc:picChg chg="add del">
+          <ac:chgData name="Mauricio Nolazco" userId="8e064c700b586176" providerId="LiveId" clId="{48E4426C-FD85-428B-8823-6908DB42E28D}" dt="2026-10-01T18:32:38.871" v="773" actId="22"/>
           <ac:picMkLst>
             <pc:docMk/>
-            <pc:sldMk cId="0" sldId="265"/>
-            <ac:picMk id="2" creationId="{78F6BCC0-3617-36B2-93C5-14655A9D9FF0}"/>
+            <pc:sldMk cId="0" sldId="266"/>
+            <ac:picMk id="2" creationId="{F3FDAA3D-024A-AC38-586C-D4542A3F3D3A}"/>
           </ac:picMkLst>
         </pc:picChg>
-        <pc:picChg chg="add mod">
-          <ac:chgData name="Mauricio Nolazco" userId="8e064c700b586176" providerId="LiveId" clId="{48E4426C-FD85-428B-8823-6908DB42E28D}" dt="2026-09-24T18:20:24.942" v="554" actId="1076"/>
+        <pc:picChg chg="del">
+          <ac:chgData name="Mauricio Nolazco" userId="8e064c700b586176" providerId="LiveId" clId="{48E4426C-FD85-428B-8823-6908DB42E28D}" dt="2026-10-01T18:32:57.824" v="783" actId="478"/>
           <ac:picMkLst>
             <pc:docMk/>
-            <pc:sldMk cId="0" sldId="265"/>
-            <ac:picMk id="3" creationId="{4D5B106B-C4A7-E920-E501-8B97A4ECB477}"/>
-          </ac:picMkLst>
-        </pc:picChg>
-        <pc:picChg chg="add mod">
-          <ac:chgData name="Mauricio Nolazco" userId="8e064c700b586176" providerId="LiveId" clId="{48E4426C-FD85-428B-8823-6908DB42E28D}" dt="2026-09-24T18:20:28.730" v="556" actId="1076"/>
-          <ac:picMkLst>
-            <pc:docMk/>
-            <pc:sldMk cId="0" sldId="265"/>
-            <ac:picMk id="4" creationId="{113E8C31-745F-E560-9EB3-5C6C9391D8C0}"/>
-          </ac:picMkLst>
-        </pc:picChg>
-        <pc:picChg chg="add del mod">
-          <ac:chgData name="Mauricio Nolazco" userId="8e064c700b586176" providerId="LiveId" clId="{48E4426C-FD85-428B-8823-6908DB42E28D}" dt="2026-09-24T17:59:13.324" v="535" actId="478"/>
-          <ac:picMkLst>
-            <pc:docMk/>
-            <pc:sldMk cId="0" sldId="265"/>
-            <ac:picMk id="5" creationId="{7A2D7069-30B0-18D3-FB1E-4780F2CCC048}"/>
-          </ac:picMkLst>
-        </pc:picChg>
-        <pc:picChg chg="add mod">
-          <ac:chgData name="Mauricio Nolazco" userId="8e064c700b586176" providerId="LiveId" clId="{48E4426C-FD85-428B-8823-6908DB42E28D}" dt="2026-09-24T17:59:25.207" v="540" actId="1440"/>
-          <ac:picMkLst>
-            <pc:docMk/>
-            <pc:sldMk cId="0" sldId="265"/>
-            <ac:picMk id="6" creationId="{36A8CCAE-5579-F967-0E3A-F4E67DF59B52}"/>
-          </ac:picMkLst>
-        </pc:picChg>
-        <pc:picChg chg="add mod modCrop">
-          <ac:chgData name="Mauricio Nolazco" userId="8e064c700b586176" providerId="LiveId" clId="{48E4426C-FD85-428B-8823-6908DB42E28D}" dt="2026-09-24T18:20:22.774" v="553" actId="1076"/>
-          <ac:picMkLst>
-            <pc:docMk/>
-            <pc:sldMk cId="0" sldId="265"/>
-            <ac:picMk id="7" creationId="{99B6C722-A896-D03E-68C6-FD926DB1CA26}"/>
-          </ac:picMkLst>
-        </pc:picChg>
-        <pc:picChg chg="add mod">
-          <ac:chgData name="Mauricio Nolazco" userId="8e064c700b586176" providerId="LiveId" clId="{48E4426C-FD85-428B-8823-6908DB42E28D}" dt="2026-09-24T20:21:20.474" v="561" actId="1440"/>
-          <ac:picMkLst>
-            <pc:docMk/>
-            <pc:sldMk cId="0" sldId="265"/>
-            <ac:picMk id="9" creationId="{1E351702-9E63-5341-D8A1-D1F09B0FD65B}"/>
-          </ac:picMkLst>
-        </pc:picChg>
-        <pc:picChg chg="mod modCrop">
-          <ac:chgData name="Mauricio Nolazco" userId="8e064c700b586176" providerId="LiveId" clId="{48E4426C-FD85-428B-8823-6908DB42E28D}" dt="2026-09-24T18:20:10.800" v="548" actId="732"/>
-          <ac:picMkLst>
-            <pc:docMk/>
-            <pc:sldMk cId="0" sldId="265"/>
-            <ac:picMk id="171" creationId="{00000000-0000-0000-0000-000000000000}"/>
+            <pc:sldMk cId="0" sldId="266"/>
+            <ac:picMk id="192" creationId="{00000000-0000-0000-0000-000000000000}"/>
           </ac:picMkLst>
         </pc:picChg>
       </pc:sldChg>
       <pc:sldChg chg="modSp mod">
-        <pc:chgData name="Mauricio Nolazco" userId="8e064c700b586176" providerId="LiveId" clId="{48E4426C-FD85-428B-8823-6908DB42E28D}" dt="2026-09-24T17:35:59.409" v="504" actId="20577"/>
+        <pc:chgData name="Mauricio Nolazco" userId="8e064c700b586176" providerId="LiveId" clId="{48E4426C-FD85-428B-8823-6908DB42E28D}" dt="2026-10-01T17:43:39.566" v="572" actId="790"/>
+        <pc:sldMkLst>
+          <pc:docMk/>
+          <pc:sldMk cId="0" sldId="267"/>
+        </pc:sldMkLst>
+        <pc:spChg chg="mod">
+          <ac:chgData name="Mauricio Nolazco" userId="8e064c700b586176" providerId="LiveId" clId="{48E4426C-FD85-428B-8823-6908DB42E28D}" dt="2026-10-01T17:43:39.566" v="572" actId="790"/>
+          <ac:spMkLst>
+            <pc:docMk/>
+            <pc:sldMk cId="0" sldId="267"/>
+            <ac:spMk id="198" creationId="{00000000-0000-0000-0000-000000000000}"/>
+          </ac:spMkLst>
+        </pc:spChg>
+        <pc:spChg chg="mod">
+          <ac:chgData name="Mauricio Nolazco" userId="8e064c700b586176" providerId="LiveId" clId="{48E4426C-FD85-428B-8823-6908DB42E28D}" dt="2026-10-01T17:43:39.566" v="572" actId="790"/>
+          <ac:spMkLst>
+            <pc:docMk/>
+            <pc:sldMk cId="0" sldId="267"/>
+            <ac:spMk id="199" creationId="{00000000-0000-0000-0000-000000000000}"/>
+          </ac:spMkLst>
+        </pc:spChg>
+        <pc:spChg chg="mod">
+          <ac:chgData name="Mauricio Nolazco" userId="8e064c700b586176" providerId="LiveId" clId="{48E4426C-FD85-428B-8823-6908DB42E28D}" dt="2026-10-01T17:43:39.566" v="572" actId="790"/>
+          <ac:spMkLst>
+            <pc:docMk/>
+            <pc:sldMk cId="0" sldId="267"/>
+            <ac:spMk id="206" creationId="{00000000-0000-0000-0000-000000000000}"/>
+          </ac:spMkLst>
+        </pc:spChg>
+      </pc:sldChg>
+      <pc:sldChg chg="modSp mod">
+        <pc:chgData name="Mauricio Nolazco" userId="8e064c700b586176" providerId="LiveId" clId="{48E4426C-FD85-428B-8823-6908DB42E28D}" dt="2026-10-01T17:43:39.566" v="572" actId="790"/>
         <pc:sldMkLst>
           <pc:docMk/>
           <pc:sldMk cId="0" sldId="268"/>
         </pc:sldMkLst>
         <pc:spChg chg="mod">
-          <ac:chgData name="Mauricio Nolazco" userId="8e064c700b586176" providerId="LiveId" clId="{48E4426C-FD85-428B-8823-6908DB42E28D}" dt="2026-09-24T17:35:59.409" v="504" actId="20577"/>
+          <ac:chgData name="Mauricio Nolazco" userId="8e064c700b586176" providerId="LiveId" clId="{48E4426C-FD85-428B-8823-6908DB42E28D}" dt="2026-10-01T17:43:39.566" v="572" actId="790"/>
           <ac:spMkLst>
             <pc:docMk/>
             <pc:sldMk cId="0" sldId="268"/>
             <ac:spMk id="215" creationId="{00000000-0000-0000-0000-000000000000}"/>
           </ac:spMkLst>
         </pc:spChg>
+        <pc:spChg chg="mod">
+          <ac:chgData name="Mauricio Nolazco" userId="8e064c700b586176" providerId="LiveId" clId="{48E4426C-FD85-428B-8823-6908DB42E28D}" dt="2026-10-01T17:43:39.566" v="572" actId="790"/>
+          <ac:spMkLst>
+            <pc:docMk/>
+            <pc:sldMk cId="0" sldId="268"/>
+            <ac:spMk id="216" creationId="{00000000-0000-0000-0000-000000000000}"/>
+          </ac:spMkLst>
+        </pc:spChg>
+        <pc:spChg chg="mod">
+          <ac:chgData name="Mauricio Nolazco" userId="8e064c700b586176" providerId="LiveId" clId="{48E4426C-FD85-428B-8823-6908DB42E28D}" dt="2026-10-01T17:43:39.566" v="572" actId="790"/>
+          <ac:spMkLst>
+            <pc:docMk/>
+            <pc:sldMk cId="0" sldId="268"/>
+            <ac:spMk id="217" creationId="{00000000-0000-0000-0000-000000000000}"/>
+          </ac:spMkLst>
+        </pc:spChg>
       </pc:sldChg>
       <pc:sldChg chg="modSp mod">
-        <pc:chgData name="Mauricio Nolazco" userId="8e064c700b586176" providerId="LiveId" clId="{48E4426C-FD85-428B-8823-6908DB42E28D}" dt="2026-09-24T17:34:39.450" v="0" actId="20577"/>
+        <pc:chgData name="Mauricio Nolazco" userId="8e064c700b586176" providerId="LiveId" clId="{48E4426C-FD85-428B-8823-6908DB42E28D}" dt="2026-10-01T17:43:39.566" v="572" actId="790"/>
+        <pc:sldMkLst>
+          <pc:docMk/>
+          <pc:sldMk cId="0" sldId="269"/>
+        </pc:sldMkLst>
+        <pc:spChg chg="mod">
+          <ac:chgData name="Mauricio Nolazco" userId="8e064c700b586176" providerId="LiveId" clId="{48E4426C-FD85-428B-8823-6908DB42E28D}" dt="2026-10-01T17:43:39.566" v="572" actId="790"/>
+          <ac:spMkLst>
+            <pc:docMk/>
+            <pc:sldMk cId="0" sldId="269"/>
+            <ac:spMk id="223" creationId="{00000000-0000-0000-0000-000000000000}"/>
+          </ac:spMkLst>
+        </pc:spChg>
+        <pc:spChg chg="mod">
+          <ac:chgData name="Mauricio Nolazco" userId="8e064c700b586176" providerId="LiveId" clId="{48E4426C-FD85-428B-8823-6908DB42E28D}" dt="2026-10-01T17:43:39.566" v="572" actId="790"/>
+          <ac:spMkLst>
+            <pc:docMk/>
+            <pc:sldMk cId="0" sldId="269"/>
+            <ac:spMk id="224" creationId="{00000000-0000-0000-0000-000000000000}"/>
+          </ac:spMkLst>
+        </pc:spChg>
+        <pc:spChg chg="mod">
+          <ac:chgData name="Mauricio Nolazco" userId="8e064c700b586176" providerId="LiveId" clId="{48E4426C-FD85-428B-8823-6908DB42E28D}" dt="2026-10-01T17:43:39.566" v="572" actId="790"/>
+          <ac:spMkLst>
+            <pc:docMk/>
+            <pc:sldMk cId="0" sldId="269"/>
+            <ac:spMk id="225" creationId="{00000000-0000-0000-0000-000000000000}"/>
+          </ac:spMkLst>
+        </pc:spChg>
+      </pc:sldChg>
+      <pc:sldChg chg="modSp mod">
+        <pc:chgData name="Mauricio Nolazco" userId="8e064c700b586176" providerId="LiveId" clId="{48E4426C-FD85-428B-8823-6908DB42E28D}" dt="2026-10-01T17:43:39.566" v="572" actId="790"/>
         <pc:sldMkLst>
           <pc:docMk/>
           <pc:sldMk cId="0" sldId="270"/>
         </pc:sldMkLst>
         <pc:spChg chg="mod">
-          <ac:chgData name="Mauricio Nolazco" userId="8e064c700b586176" providerId="LiveId" clId="{48E4426C-FD85-428B-8823-6908DB42E28D}" dt="2026-09-24T17:34:39.450" v="0" actId="20577"/>
+          <ac:chgData name="Mauricio Nolazco" userId="8e064c700b586176" providerId="LiveId" clId="{48E4426C-FD85-428B-8823-6908DB42E28D}" dt="2026-10-01T17:43:39.566" v="572" actId="790"/>
+          <ac:spMkLst>
+            <pc:docMk/>
+            <pc:sldMk cId="0" sldId="270"/>
+            <ac:spMk id="233" creationId="{00000000-0000-0000-0000-000000000000}"/>
+          </ac:spMkLst>
+        </pc:spChg>
+        <pc:spChg chg="mod">
+          <ac:chgData name="Mauricio Nolazco" userId="8e064c700b586176" providerId="LiveId" clId="{48E4426C-FD85-428B-8823-6908DB42E28D}" dt="2026-10-01T17:43:39.566" v="572" actId="790"/>
+          <ac:spMkLst>
+            <pc:docMk/>
+            <pc:sldMk cId="0" sldId="270"/>
+            <ac:spMk id="234" creationId="{00000000-0000-0000-0000-000000000000}"/>
+          </ac:spMkLst>
+        </pc:spChg>
+        <pc:spChg chg="mod">
+          <ac:chgData name="Mauricio Nolazco" userId="8e064c700b586176" providerId="LiveId" clId="{48E4426C-FD85-428B-8823-6908DB42E28D}" dt="2026-10-01T17:43:39.566" v="572" actId="790"/>
+          <ac:spMkLst>
+            <pc:docMk/>
+            <pc:sldMk cId="0" sldId="270"/>
+            <ac:spMk id="235" creationId="{00000000-0000-0000-0000-000000000000}"/>
+          </ac:spMkLst>
+        </pc:spChg>
+        <pc:spChg chg="mod">
+          <ac:chgData name="Mauricio Nolazco" userId="8e064c700b586176" providerId="LiveId" clId="{48E4426C-FD85-428B-8823-6908DB42E28D}" dt="2026-10-01T17:43:39.566" v="572" actId="790"/>
           <ac:spMkLst>
             <pc:docMk/>
             <pc:sldMk cId="0" sldId="270"/>
@@ -1987,128 +2526,6 @@
   <p:cSld>
     <p:spTree>
       <p:nvGrpSpPr>
-        <p:cNvPr id="1" name="Shape 162"/>
-        <p:cNvGrpSpPr/>
-        <p:nvPr/>
-      </p:nvGrpSpPr>
-      <p:grpSpPr>
-        <a:xfrm>
-          <a:off x="0" y="0"/>
-          <a:ext cx="0" cy="0"/>
-          <a:chOff x="0" y="0"/>
-          <a:chExt cx="0" cy="0"/>
-        </a:xfrm>
-      </p:grpSpPr>
-      <p:sp>
-        <p:nvSpPr>
-          <p:cNvPr id="163" name="Google Shape;163;p10:notes"/>
-          <p:cNvSpPr txBox="1">
-            <a:spLocks noGrp="1"/>
-          </p:cNvSpPr>
-          <p:nvPr>
-            <p:ph type="body" idx="1"/>
-          </p:nvPr>
-        </p:nvSpPr>
-        <p:spPr>
-          <a:xfrm>
-            <a:off x="685800" y="4343400"/>
-            <a:ext cx="5486400" cy="4114800"/>
-          </a:xfrm>
-          <a:prstGeom prst="rect">
-            <a:avLst/>
-          </a:prstGeom>
-          <a:noFill/>
-          <a:ln>
-            <a:noFill/>
-          </a:ln>
-        </p:spPr>
-        <p:txBody>
-          <a:bodyPr spcFirstLastPara="1" wrap="square" lIns="91425" tIns="45700" rIns="91425" bIns="45700" anchor="t" anchorCtr="0">
-            <a:noAutofit/>
-          </a:bodyPr>
-          <a:lstStyle/>
-          <a:p>
-            <a:pPr marL="0" lvl="0" indent="0" algn="l" rtl="0">
-              <a:lnSpc>
-                <a:spcPct val="100000"/>
-              </a:lnSpc>
-              <a:spcBef>
-                <a:spcPts val="0"/>
-              </a:spcBef>
-              <a:spcAft>
-                <a:spcPts val="0"/>
-              </a:spcAft>
-              <a:buSzPts val="1400"/>
-              <a:buNone/>
-            </a:pPr>
-            <a:endParaRPr/>
-          </a:p>
-        </p:txBody>
-      </p:sp>
-      <p:sp>
-        <p:nvSpPr>
-          <p:cNvPr id="164" name="Google Shape;164;p10:notes"/>
-          <p:cNvSpPr>
-            <a:spLocks noGrp="1" noRot="1" noChangeAspect="1"/>
-          </p:cNvSpPr>
-          <p:nvPr>
-            <p:ph type="sldImg" idx="2"/>
-          </p:nvPr>
-        </p:nvSpPr>
-        <p:spPr>
-          <a:xfrm>
-            <a:off x="1143000" y="685800"/>
-            <a:ext cx="4572000" cy="3429000"/>
-          </a:xfrm>
-          <a:custGeom>
-            <a:avLst/>
-            <a:gdLst/>
-            <a:ahLst/>
-            <a:cxnLst/>
-            <a:rect l="l" t="t" r="r" b="b"/>
-            <a:pathLst>
-              <a:path w="120000" h="120000" extrusionOk="0">
-                <a:moveTo>
-                  <a:pt x="0" y="0"/>
-                </a:moveTo>
-                <a:lnTo>
-                  <a:pt x="120000" y="0"/>
-                </a:lnTo>
-                <a:lnTo>
-                  <a:pt x="120000" y="120000"/>
-                </a:lnTo>
-                <a:lnTo>
-                  <a:pt x="0" y="120000"/>
-                </a:lnTo>
-                <a:close/>
-              </a:path>
-            </a:pathLst>
-          </a:custGeom>
-          <a:noFill/>
-          <a:ln w="12700" cap="flat" cmpd="sng">
-            <a:solidFill>
-              <a:srgbClr val="000000"/>
-            </a:solidFill>
-            <a:prstDash val="solid"/>
-            <a:round/>
-            <a:headEnd type="none" w="sm" len="sm"/>
-            <a:tailEnd type="none" w="sm" len="sm"/>
-          </a:ln>
-        </p:spPr>
-      </p:sp>
-    </p:spTree>
-  </p:cSld>
-  <p:clrMapOvr>
-    <a:masterClrMapping/>
-  </p:clrMapOvr>
-</p:notes>
-</file>
-
-<file path=ppt/notesSlides/notesSlide11.xml><?xml version="1.0" encoding="utf-8"?>
-<p:notes xmlns:a="http://schemas.openxmlformats.org/drawingml/2006/main" xmlns:r="http://schemas.openxmlformats.org/officeDocument/2006/relationships" xmlns:p="http://schemas.openxmlformats.org/presentationml/2006/main" showMasterSp="0" showMasterPhAnim="0">
-  <p:cSld>
-    <p:spTree>
-      <p:nvGrpSpPr>
         <p:cNvPr id="1" name="Shape 185"/>
         <p:cNvGrpSpPr/>
         <p:nvPr/>
@@ -2226,7 +2643,7 @@
 </p:notes>
 </file>
 
-<file path=ppt/notesSlides/notesSlide12.xml><?xml version="1.0" encoding="utf-8"?>
+<file path=ppt/notesSlides/notesSlide11.xml><?xml version="1.0" encoding="utf-8"?>
 <p:notes xmlns:a="http://schemas.openxmlformats.org/drawingml/2006/main" xmlns:r="http://schemas.openxmlformats.org/officeDocument/2006/relationships" xmlns:p="http://schemas.openxmlformats.org/presentationml/2006/main" showMasterSp="0" showMasterPhAnim="0">
   <p:cSld>
     <p:spTree>
@@ -2348,7 +2765,7 @@
 </p:notes>
 </file>
 
-<file path=ppt/notesSlides/notesSlide13.xml><?xml version="1.0" encoding="utf-8"?>
+<file path=ppt/notesSlides/notesSlide12.xml><?xml version="1.0" encoding="utf-8"?>
 <p:notes xmlns:a="http://schemas.openxmlformats.org/drawingml/2006/main" xmlns:r="http://schemas.openxmlformats.org/officeDocument/2006/relationships" xmlns:p="http://schemas.openxmlformats.org/presentationml/2006/main" showMasterSp="0" showMasterPhAnim="0">
   <p:cSld>
     <p:spTree>
@@ -2470,7 +2887,7 @@
 </p:notes>
 </file>
 
-<file path=ppt/notesSlides/notesSlide14.xml><?xml version="1.0" encoding="utf-8"?>
+<file path=ppt/notesSlides/notesSlide13.xml><?xml version="1.0" encoding="utf-8"?>
 <p:notes xmlns:a="http://schemas.openxmlformats.org/drawingml/2006/main" xmlns:r="http://schemas.openxmlformats.org/officeDocument/2006/relationships" xmlns:p="http://schemas.openxmlformats.org/presentationml/2006/main" showMasterSp="0" showMasterPhAnim="0">
   <p:cSld>
     <p:spTree>
@@ -2592,7 +3009,7 @@
 </p:notes>
 </file>
 
-<file path=ppt/notesSlides/notesSlide15.xml><?xml version="1.0" encoding="utf-8"?>
+<file path=ppt/notesSlides/notesSlide14.xml><?xml version="1.0" encoding="utf-8"?>
 <p:notes xmlns:a="http://schemas.openxmlformats.org/drawingml/2006/main" xmlns:r="http://schemas.openxmlformats.org/officeDocument/2006/relationships" xmlns:p="http://schemas.openxmlformats.org/presentationml/2006/main" showMasterSp="0" showMasterPhAnim="0">
   <p:cSld>
     <p:spTree>
@@ -17118,7 +17535,7 @@
         <p:spPr>
           <a:xfrm>
             <a:off x="6300192" y="6100724"/>
-            <a:ext cx="2629526" cy="400110"/>
+            <a:ext cx="2629526" cy="307736"/>
           </a:xfrm>
           <a:prstGeom prst="rect">
             <a:avLst/>
@@ -17136,17 +17553,17 @@
           <a:p>
             <a:pPr algn="r"/>
             <a:r>
-              <a:rPr sz="1800" b="0" i="0">
-                <a:solidFill>
-                  <a:srgbClr val="505050"/>
-                </a:solidFill>
-                <a:latin typeface="Calibri"/>
+              <a:rPr lang="es-MX" sz="1400" noProof="0" dirty="0">
+                <a:solidFill>
+                  <a:schemeClr val="tx1"/>
+                </a:solidFill>
+                <a:latin typeface="Arial"/>
               </a:rPr>
-              <a:t>Septiembre de 2026</a:t>
+              <a:t>Octubre de 2026</a:t>
             </a:r>
-            <a:endParaRPr sz="1400" b="0" i="0" u="none" strike="noStrike" cap="none">
+            <a:endParaRPr lang="es-MX" sz="1400" b="0" i="0" u="none" strike="noStrike" cap="none" noProof="0" dirty="0">
               <a:solidFill>
-                <a:srgbClr val="000000"/>
+                <a:schemeClr val="tx1"/>
               </a:solidFill>
               <a:latin typeface="Arial"/>
               <a:ea typeface="Arial"/>
@@ -17164,8 +17581,8 @@
         </p:nvSpPr>
         <p:spPr>
           <a:xfrm>
-            <a:off x="323528" y="1576409"/>
-            <a:ext cx="8606189" cy="4370427"/>
+            <a:off x="323529" y="1849732"/>
+            <a:ext cx="8606189" cy="2436524"/>
           </a:xfrm>
           <a:prstGeom prst="rect">
             <a:avLst/>
@@ -17183,7 +17600,7 @@
           <a:p>
             <a:pPr algn="ctr"/>
             <a:r>
-              <a:rPr sz="1700" b="0" i="0">
+              <a:rPr lang="es-MX" sz="1700" b="0" i="0" noProof="0" dirty="0">
                 <a:solidFill>
                   <a:srgbClr val="505050"/>
                 </a:solidFill>
@@ -17191,7 +17608,7 @@
               </a:rPr>
               <a:t>Carrera:</a:t>
             </a:r>
-            <a:endParaRPr sz="1400" b="0" i="0" u="none" strike="noStrike" cap="none">
+            <a:endParaRPr lang="es-MX" sz="1400" b="0" i="0" u="none" strike="noStrike" cap="none" noProof="0" dirty="0">
               <a:solidFill>
                 <a:srgbClr val="000000"/>
               </a:solidFill>
@@ -17208,7 +17625,7 @@
               </a:spcAft>
             </a:pPr>
             <a:r>
-              <a:rPr sz="1900" b="1" i="0">
+              <a:rPr lang="es-MX" sz="1900" b="1" i="0" noProof="0" dirty="0">
                 <a:solidFill>
                   <a:srgbClr val="000000"/>
                 </a:solidFill>
@@ -17224,19 +17641,37 @@
               </a:spcAft>
             </a:pPr>
             <a:r>
-              <a:rPr sz="2100" b="1" i="0">
-                <a:solidFill>
-                  <a:srgbClr val="76923C"/>
+              <a:rPr lang="es-MX" sz="2100" b="1" i="0" noProof="0" dirty="0">
+                <a:solidFill>
+                  <a:schemeClr val="tx1"/>
                 </a:solidFill>
                 <a:latin typeface="Arial"/>
               </a:rPr>
-              <a:t>“Sistema de Inventario y Mapeo Lógico de Redes GPON / FTTx”</a:t>
+              <a:t>“Sistema de Inventario y Mapeo Lógico de Redes GPON / </a:t>
+            </a:r>
+            <a:r>
+              <a:rPr lang="es-MX" sz="2100" b="1" i="0" noProof="0" dirty="0" err="1">
+                <a:solidFill>
+                  <a:schemeClr val="tx1"/>
+                </a:solidFill>
+                <a:latin typeface="Arial"/>
+              </a:rPr>
+              <a:t>FTTx</a:t>
+            </a:r>
+            <a:r>
+              <a:rPr lang="es-MX" sz="2100" b="1" i="0" noProof="0" dirty="0">
+                <a:solidFill>
+                  <a:schemeClr val="tx1"/>
+                </a:solidFill>
+                <a:latin typeface="Arial"/>
+              </a:rPr>
+              <a:t>”</a:t>
             </a:r>
           </a:p>
           <a:p>
             <a:pPr algn="ctr"/>
             <a:r>
-              <a:rPr sz="1700" b="0" i="0">
+              <a:rPr lang="es-MX" sz="1700" b="0" i="0" noProof="0" dirty="0">
                 <a:solidFill>
                   <a:srgbClr val="505050"/>
                 </a:solidFill>
@@ -17252,19 +17687,34 @@
               </a:spcAft>
             </a:pPr>
             <a:r>
-              <a:rPr sz="1900" b="1" i="0">
+              <a:rPr lang="es-MX" sz="1900" b="1" i="0" noProof="0" dirty="0">
                 <a:solidFill>
                   <a:srgbClr val="000000"/>
                 </a:solidFill>
                 <a:latin typeface="Arial"/>
               </a:rPr>
-              <a:t>Mauricio Nolazco Lonjino</a:t>
+              <a:t>Mauricio Nolazco </a:t>
             </a:r>
+            <a:r>
+              <a:rPr lang="es-MX" sz="1900" b="1" i="0" noProof="0" dirty="0" err="1">
+                <a:solidFill>
+                  <a:srgbClr val="000000"/>
+                </a:solidFill>
+                <a:latin typeface="Arial"/>
+              </a:rPr>
+              <a:t>Lonjino</a:t>
+            </a:r>
+            <a:endParaRPr lang="es-MX" sz="1900" b="1" i="0" noProof="0" dirty="0">
+              <a:solidFill>
+                <a:srgbClr val="000000"/>
+              </a:solidFill>
+              <a:latin typeface="Arial"/>
+            </a:endParaRPr>
           </a:p>
           <a:p>
             <a:pPr algn="ctr"/>
             <a:r>
-              <a:rPr sz="1700" b="0" i="0">
+              <a:rPr lang="es-MX" sz="1700" b="0" i="0" noProof="0" dirty="0">
                 <a:solidFill>
                   <a:srgbClr val="505050"/>
                 </a:solidFill>
@@ -17276,7 +17726,7 @@
           <a:p>
             <a:pPr algn="ctr"/>
             <a:r>
-              <a:rPr sz="1900" b="1" i="0">
+              <a:rPr lang="es-MX" sz="1900" b="1" i="0" noProof="0" dirty="0">
                 <a:solidFill>
                   <a:srgbClr val="000000"/>
                 </a:solidFill>
@@ -17314,7 +17764,7 @@
           <a:p>
             <a:pPr algn="ctr"/>
             <a:r>
-              <a:rPr sz="2400" b="1" i="0">
+              <a:rPr lang="es-MX" sz="2400" b="1" i="0" noProof="0" dirty="0">
                 <a:solidFill>
                   <a:srgbClr val="000000"/>
                 </a:solidFill>
@@ -17324,7 +17774,7 @@
 </a:t>
             </a:r>
             <a:r>
-              <a:rPr sz="2000" b="1" i="0">
+              <a:rPr lang="es-MX" sz="2000" b="1" i="0" noProof="0" dirty="0">
                 <a:solidFill>
                   <a:srgbClr val="000000"/>
                 </a:solidFill>
@@ -17332,7 +17782,7 @@
               </a:rPr>
               <a:t>UNIDAD DE ESTUDIOS SUPERIORES SAN JOSÉ DEL RINCÓN</a:t>
             </a:r>
-            <a:endParaRPr sz="1400" b="0" i="0" u="none" strike="noStrike" cap="none">
+            <a:endParaRPr lang="es-MX" sz="1400" b="0" i="0" u="none" strike="noStrike" cap="none" noProof="0" dirty="0">
               <a:solidFill>
                 <a:srgbClr val="000000"/>
               </a:solidFill>
@@ -17353,503 +17803,6 @@
 </file>
 
 <file path=ppt/slides/slide10.xml><?xml version="1.0" encoding="utf-8"?>
-<p:sld xmlns:a="http://schemas.openxmlformats.org/drawingml/2006/main" xmlns:r="http://schemas.openxmlformats.org/officeDocument/2006/relationships" xmlns:p="http://schemas.openxmlformats.org/presentationml/2006/main">
-  <p:cSld>
-    <p:spTree>
-      <p:nvGrpSpPr>
-        <p:cNvPr id="1" name="Shape 165"/>
-        <p:cNvGrpSpPr/>
-        <p:nvPr/>
-      </p:nvGrpSpPr>
-      <p:grpSpPr>
-        <a:xfrm>
-          <a:off x="0" y="0"/>
-          <a:ext cx="0" cy="0"/>
-          <a:chOff x="0" y="0"/>
-          <a:chExt cx="0" cy="0"/>
-        </a:xfrm>
-      </p:grpSpPr>
-      <p:pic>
-        <p:nvPicPr>
-          <p:cNvPr id="166" name="Google Shape;166;p10"/>
-          <p:cNvPicPr preferRelativeResize="0"/>
-          <p:nvPr/>
-        </p:nvPicPr>
-        <p:blipFill rotWithShape="1">
-          <a:blip r:embed="rId3">
-            <a:alphaModFix/>
-          </a:blip>
-          <a:srcRect/>
-          <a:stretch/>
-        </p:blipFill>
-        <p:spPr>
-          <a:xfrm>
-            <a:off x="0" y="4286256"/>
-            <a:ext cx="9144000" cy="2571744"/>
-          </a:xfrm>
-          <a:prstGeom prst="rect">
-            <a:avLst/>
-          </a:prstGeom>
-          <a:noFill/>
-          <a:ln>
-            <a:noFill/>
-          </a:ln>
-        </p:spPr>
-      </p:pic>
-      <p:sp>
-        <p:nvSpPr>
-          <p:cNvPr id="167" name="Google Shape;167;p10"/>
-          <p:cNvSpPr/>
-          <p:nvPr/>
-        </p:nvSpPr>
-        <p:spPr>
-          <a:xfrm>
-            <a:off x="640080" y="960120"/>
-            <a:ext cx="7863840" cy="548640"/>
-          </a:xfrm>
-          <a:prstGeom prst="rect">
-            <a:avLst/>
-          </a:prstGeom>
-          <a:noFill/>
-          <a:ln>
-            <a:noFill/>
-          </a:ln>
-        </p:spPr>
-        <p:txBody>
-          <a:bodyPr spcFirstLastPara="1" wrap="square" lIns="91425" tIns="45700" rIns="91425" bIns="45700" anchor="t" anchorCtr="0">
-            <a:spAutoFit/>
-          </a:bodyPr>
-          <a:lstStyle/>
-          <a:p>
-            <a:r>
-              <a:rPr sz="1450" b="1" i="0">
-                <a:solidFill>
-                  <a:srgbClr val="000000"/>
-                </a:solidFill>
-                <a:latin typeface="Arial"/>
-              </a:rPr>
-              <a:t>Para el desarrollo de la plataforma web se seleccionó un stack tecnológico desacoplado y orientado a resiliencia:</a:t>
-            </a:r>
-            <a:endParaRPr sz="1400" b="0" i="0" u="none" strike="noStrike" cap="none">
-              <a:solidFill>
-                <a:srgbClr val="000000"/>
-              </a:solidFill>
-              <a:latin typeface="Arial"/>
-              <a:ea typeface="Arial"/>
-              <a:cs typeface="Arial"/>
-              <a:sym typeface="Arial"/>
-            </a:endParaRPr>
-          </a:p>
-        </p:txBody>
-      </p:sp>
-      <p:sp>
-        <p:nvSpPr>
-          <p:cNvPr id="168" name="Google Shape;168;p10"/>
-          <p:cNvSpPr/>
-          <p:nvPr/>
-        </p:nvSpPr>
-        <p:spPr>
-          <a:xfrm>
-            <a:off x="5540128" y="0"/>
-            <a:ext cx="3603872" cy="830997"/>
-          </a:xfrm>
-          <a:prstGeom prst="rect">
-            <a:avLst/>
-          </a:prstGeom>
-          <a:solidFill>
-            <a:schemeClr val="lt1"/>
-          </a:solidFill>
-          <a:ln w="25400" cap="flat" cmpd="sng">
-            <a:solidFill>
-              <a:srgbClr val="76923C"/>
-            </a:solidFill>
-            <a:prstDash val="solid"/>
-            <a:round/>
-            <a:headEnd type="none" w="sm" len="sm"/>
-            <a:tailEnd type="none" w="sm" len="sm"/>
-          </a:ln>
-        </p:spPr>
-        <p:txBody>
-          <a:bodyPr spcFirstLastPara="1" wrap="square" lIns="91425" tIns="45700" rIns="91425" bIns="45700" anchor="t" anchorCtr="0">
-            <a:spAutoFit/>
-          </a:bodyPr>
-          <a:lstStyle/>
-          <a:p>
-            <a:pPr algn="r"/>
-            <a:r>
-              <a:rPr sz="4400" b="0" i="0">
-                <a:solidFill>
-                  <a:srgbClr val="76923C"/>
-                </a:solidFill>
-                <a:latin typeface="Calibri"/>
-              </a:rPr>
-              <a:t>Herramientas</a:t>
-            </a:r>
-            <a:endParaRPr sz="3500" b="0" i="0" u="none" strike="noStrike" cap="none">
-              <a:solidFill>
-                <a:srgbClr val="76923C"/>
-              </a:solidFill>
-              <a:latin typeface="Calibri"/>
-              <a:ea typeface="Calibri"/>
-              <a:cs typeface="Calibri"/>
-              <a:sym typeface="Calibri"/>
-            </a:endParaRPr>
-          </a:p>
-        </p:txBody>
-      </p:sp>
-      <p:sp>
-        <p:nvSpPr>
-          <p:cNvPr id="169" name="Google Shape;169;p10"/>
-          <p:cNvSpPr/>
-          <p:nvPr/>
-        </p:nvSpPr>
-        <p:spPr>
-          <a:xfrm>
-            <a:off x="8461665" y="6519446"/>
-            <a:ext cx="682335" cy="338554"/>
-          </a:xfrm>
-          <a:prstGeom prst="rect">
-            <a:avLst/>
-          </a:prstGeom>
-          <a:solidFill>
-            <a:schemeClr val="lt1"/>
-          </a:solidFill>
-          <a:ln w="25400" cap="flat" cmpd="sng">
-            <a:solidFill>
-              <a:srgbClr val="76923C"/>
-            </a:solidFill>
-            <a:prstDash val="solid"/>
-            <a:round/>
-            <a:headEnd type="none" w="sm" len="sm"/>
-            <a:tailEnd type="none" w="sm" len="sm"/>
-          </a:ln>
-        </p:spPr>
-        <p:txBody>
-          <a:bodyPr spcFirstLastPara="1" wrap="square" lIns="91425" tIns="45700" rIns="91425" bIns="45700" anchor="t" anchorCtr="0">
-            <a:spAutoFit/>
-          </a:bodyPr>
-          <a:lstStyle/>
-          <a:p>
-            <a:r>
-              <a:rPr sz="1600" b="0" i="0">
-                <a:solidFill>
-                  <a:srgbClr val="76923C"/>
-                </a:solidFill>
-                <a:latin typeface="Calibri"/>
-              </a:rPr>
-              <a:t>10/15</a:t>
-            </a:r>
-            <a:endParaRPr sz="1400" b="0" i="0" u="none" strike="noStrike" cap="none">
-              <a:solidFill>
-                <a:srgbClr val="000000"/>
-              </a:solidFill>
-              <a:latin typeface="Arial"/>
-              <a:ea typeface="Arial"/>
-              <a:cs typeface="Arial"/>
-              <a:sym typeface="Arial"/>
-            </a:endParaRPr>
-          </a:p>
-        </p:txBody>
-      </p:sp>
-      <p:pic>
-        <p:nvPicPr>
-          <p:cNvPr id="171" name="Picture 170" descr="fig_herramientas_gpon.png"/>
-          <p:cNvPicPr>
-            <a:picLocks noChangeAspect="1"/>
-          </p:cNvPicPr>
-          <p:nvPr/>
-        </p:nvPicPr>
-        <p:blipFill>
-          <a:blip r:embed="rId4"/>
-          <a:srcRect l="25818"/>
-          <a:stretch>
-            <a:fillRect/>
-          </a:stretch>
-        </p:blipFill>
-        <p:spPr>
-          <a:xfrm>
-            <a:off x="2714624" y="1600200"/>
-            <a:ext cx="5697855" cy="2304288"/>
-          </a:xfrm>
-          <a:prstGeom prst="rect">
-            <a:avLst/>
-          </a:prstGeom>
-        </p:spPr>
-      </p:pic>
-      <p:pic>
-        <p:nvPicPr>
-          <p:cNvPr id="2" name="Imagen 1" descr="Tag: Leaflet">
-            <a:extLst>
-              <a:ext uri="{FF2B5EF4-FFF2-40B4-BE49-F238E27FC236}">
-                <a16:creationId xmlns:a16="http://schemas.microsoft.com/office/drawing/2014/main" id="{78F6BCC0-3617-36B2-93C5-14655A9D9FF0}"/>
-              </a:ext>
-            </a:extLst>
-          </p:cNvPr>
-          <p:cNvPicPr>
-            <a:picLocks noChangeAspect="1"/>
-          </p:cNvPicPr>
-          <p:nvPr/>
-        </p:nvPicPr>
-        <p:blipFill>
-          <a:blip r:embed="rId5"/>
-          <a:stretch>
-            <a:fillRect/>
-          </a:stretch>
-        </p:blipFill>
-        <p:spPr>
-          <a:xfrm>
-            <a:off x="903926" y="1657492"/>
-            <a:ext cx="1440000" cy="964800"/>
-          </a:xfrm>
-          <a:prstGeom prst="rect">
-            <a:avLst/>
-          </a:prstGeom>
-          <a:ln w="38100" cap="sq">
-            <a:solidFill>
-              <a:srgbClr val="000000"/>
-            </a:solidFill>
-            <a:prstDash val="solid"/>
-            <a:miter lim="800000"/>
-          </a:ln>
-          <a:effectLst>
-            <a:outerShdw blurRad="50800" dist="38100" dir="2700000" algn="tl" rotWithShape="0">
-              <a:srgbClr val="000000">
-                <a:alpha val="43000"/>
-              </a:srgbClr>
-            </a:outerShdw>
-          </a:effectLst>
-        </p:spPr>
-      </p:pic>
-      <p:pic>
-        <p:nvPicPr>
-          <p:cNvPr id="3" name="Imagen 2" descr="How to Build Large Scale React Apps">
-            <a:extLst>
-              <a:ext uri="{FF2B5EF4-FFF2-40B4-BE49-F238E27FC236}">
-                <a16:creationId xmlns:a16="http://schemas.microsoft.com/office/drawing/2014/main" id="{4D5B106B-C4A7-E920-E501-8B97A4ECB477}"/>
-              </a:ext>
-            </a:extLst>
-          </p:cNvPr>
-          <p:cNvPicPr>
-            <a:picLocks noChangeAspect="1"/>
-          </p:cNvPicPr>
-          <p:nvPr/>
-        </p:nvPicPr>
-        <p:blipFill>
-          <a:blip r:embed="rId6"/>
-          <a:stretch>
-            <a:fillRect/>
-          </a:stretch>
-        </p:blipFill>
-        <p:spPr>
-          <a:xfrm>
-            <a:off x="2883873" y="3940260"/>
-            <a:ext cx="1440000" cy="1440000"/>
-          </a:xfrm>
-          <a:prstGeom prst="rect">
-            <a:avLst/>
-          </a:prstGeom>
-          <a:ln w="38100" cap="sq">
-            <a:solidFill>
-              <a:srgbClr val="000000"/>
-            </a:solidFill>
-            <a:prstDash val="solid"/>
-            <a:miter lim="800000"/>
-          </a:ln>
-          <a:effectLst>
-            <a:outerShdw blurRad="50800" dist="38100" dir="2700000" algn="tl" rotWithShape="0">
-              <a:srgbClr val="000000">
-                <a:alpha val="43000"/>
-              </a:srgbClr>
-            </a:outerShdw>
-          </a:effectLst>
-        </p:spPr>
-      </p:pic>
-      <p:pic>
-        <p:nvPicPr>
-          <p:cNvPr id="4" name="Imagen 3" descr="Tailwind Css">
-            <a:extLst>
-              <a:ext uri="{FF2B5EF4-FFF2-40B4-BE49-F238E27FC236}">
-                <a16:creationId xmlns:a16="http://schemas.microsoft.com/office/drawing/2014/main" id="{113E8C31-745F-E560-9EB3-5C6C9391D8C0}"/>
-              </a:ext>
-            </a:extLst>
-          </p:cNvPr>
-          <p:cNvPicPr>
-            <a:picLocks noChangeAspect="1"/>
-          </p:cNvPicPr>
-          <p:nvPr/>
-        </p:nvPicPr>
-        <p:blipFill>
-          <a:blip r:embed="rId7"/>
-          <a:stretch>
-            <a:fillRect/>
-          </a:stretch>
-        </p:blipFill>
-        <p:spPr>
-          <a:xfrm>
-            <a:off x="903926" y="4381399"/>
-            <a:ext cx="1440000" cy="860625"/>
-          </a:xfrm>
-          <a:prstGeom prst="rect">
-            <a:avLst/>
-          </a:prstGeom>
-          <a:ln w="38100" cap="sq">
-            <a:solidFill>
-              <a:srgbClr val="000000"/>
-            </a:solidFill>
-            <a:prstDash val="solid"/>
-            <a:miter lim="800000"/>
-          </a:ln>
-          <a:effectLst>
-            <a:outerShdw blurRad="50800" dist="38100" dir="2700000" algn="tl" rotWithShape="0">
-              <a:srgbClr val="000000">
-                <a:alpha val="43000"/>
-              </a:srgbClr>
-            </a:outerShdw>
-          </a:effectLst>
-        </p:spPr>
-      </p:pic>
-      <p:pic>
-        <p:nvPicPr>
-          <p:cNvPr id="6" name="Imagen 5" descr="How to Install React Using Vite - Ty's Web Development Training Blog">
-            <a:extLst>
-              <a:ext uri="{FF2B5EF4-FFF2-40B4-BE49-F238E27FC236}">
-                <a16:creationId xmlns:a16="http://schemas.microsoft.com/office/drawing/2014/main" id="{36A8CCAE-5579-F967-0E3A-F4E67DF59B52}"/>
-              </a:ext>
-            </a:extLst>
-          </p:cNvPr>
-          <p:cNvPicPr>
-            <a:picLocks noChangeAspect="1"/>
-          </p:cNvPicPr>
-          <p:nvPr/>
-        </p:nvPicPr>
-        <p:blipFill>
-          <a:blip r:embed="rId8"/>
-          <a:stretch>
-            <a:fillRect/>
-          </a:stretch>
-        </p:blipFill>
-        <p:spPr>
-          <a:xfrm>
-            <a:off x="6508256" y="3904488"/>
-            <a:ext cx="1440000" cy="1418906"/>
-          </a:xfrm>
-          <a:prstGeom prst="rect">
-            <a:avLst/>
-          </a:prstGeom>
-          <a:ln w="38100" cap="sq">
-            <a:solidFill>
-              <a:srgbClr val="000000"/>
-            </a:solidFill>
-            <a:prstDash val="solid"/>
-            <a:miter lim="800000"/>
-          </a:ln>
-          <a:effectLst>
-            <a:outerShdw blurRad="50800" dist="38100" dir="2700000" algn="tl" rotWithShape="0">
-              <a:srgbClr val="000000">
-                <a:alpha val="43000"/>
-              </a:srgbClr>
-            </a:outerShdw>
-          </a:effectLst>
-        </p:spPr>
-      </p:pic>
-      <p:pic>
-        <p:nvPicPr>
-          <p:cNvPr id="7" name="Imagen 6" descr="dexie-logger | Dexie logger middleware">
-            <a:extLst>
-              <a:ext uri="{FF2B5EF4-FFF2-40B4-BE49-F238E27FC236}">
-                <a16:creationId xmlns:a16="http://schemas.microsoft.com/office/drawing/2014/main" id="{99B6C722-A896-D03E-68C6-FD926DB1CA26}"/>
-              </a:ext>
-            </a:extLst>
-          </p:cNvPr>
-          <p:cNvPicPr>
-            <a:picLocks noChangeAspect="1"/>
-          </p:cNvPicPr>
-          <p:nvPr/>
-        </p:nvPicPr>
-        <p:blipFill>
-          <a:blip r:embed="rId9"/>
-          <a:srcRect l="29601" r="26081"/>
-          <a:stretch>
-            <a:fillRect/>
-          </a:stretch>
-        </p:blipFill>
-        <p:spPr>
-          <a:xfrm>
-            <a:off x="903926" y="2809631"/>
-            <a:ext cx="1440000" cy="1384429"/>
-          </a:xfrm>
-          <a:prstGeom prst="rect">
-            <a:avLst/>
-          </a:prstGeom>
-          <a:ln w="38100" cap="sq">
-            <a:solidFill>
-              <a:srgbClr val="000000"/>
-            </a:solidFill>
-            <a:prstDash val="solid"/>
-            <a:miter lim="800000"/>
-          </a:ln>
-          <a:effectLst>
-            <a:outerShdw blurRad="50800" dist="38100" dir="2700000" algn="tl" rotWithShape="0">
-              <a:srgbClr val="000000">
-                <a:alpha val="43000"/>
-              </a:srgbClr>
-            </a:outerShdw>
-          </a:effectLst>
-        </p:spPr>
-      </p:pic>
-      <p:pic>
-        <p:nvPicPr>
-          <p:cNvPr id="9" name="Imagen 8">
-            <a:extLst>
-              <a:ext uri="{FF2B5EF4-FFF2-40B4-BE49-F238E27FC236}">
-                <a16:creationId xmlns:a16="http://schemas.microsoft.com/office/drawing/2014/main" id="{1E351702-9E63-5341-D8A1-D1F09B0FD65B}"/>
-              </a:ext>
-            </a:extLst>
-          </p:cNvPr>
-          <p:cNvPicPr>
-            <a:picLocks noChangeAspect="1"/>
-          </p:cNvPicPr>
-          <p:nvPr/>
-        </p:nvPicPr>
-        <p:blipFill>
-          <a:blip r:embed="rId10"/>
-          <a:stretch>
-            <a:fillRect/>
-          </a:stretch>
-        </p:blipFill>
-        <p:spPr>
-          <a:xfrm>
-            <a:off x="4604033" y="4141091"/>
-            <a:ext cx="1440000" cy="822928"/>
-          </a:xfrm>
-          <a:prstGeom prst="rect">
-            <a:avLst/>
-          </a:prstGeom>
-          <a:ln w="38100" cap="sq">
-            <a:solidFill>
-              <a:srgbClr val="000000"/>
-            </a:solidFill>
-            <a:prstDash val="solid"/>
-            <a:miter lim="800000"/>
-          </a:ln>
-          <a:effectLst>
-            <a:outerShdw blurRad="50800" dist="38100" dir="2700000" algn="tl" rotWithShape="0">
-              <a:srgbClr val="000000">
-                <a:alpha val="43000"/>
-              </a:srgbClr>
-            </a:outerShdw>
-          </a:effectLst>
-        </p:spPr>
-      </p:pic>
-    </p:spTree>
-  </p:cSld>
-  <p:clrMapOvr>
-    <a:masterClrMapping/>
-  </p:clrMapOvr>
-</p:sld>
-</file>
-
-<file path=ppt/slides/slide11.xml><?xml version="1.0" encoding="utf-8"?>
 <p:sld xmlns:a="http://schemas.openxmlformats.org/drawingml/2006/main" xmlns:r="http://schemas.openxmlformats.org/officeDocument/2006/relationships" xmlns:p="http://schemas.openxmlformats.org/presentationml/2006/main">
   <p:cSld>
     <p:spTree>
@@ -17895,14 +17848,74 @@
       </p:pic>
       <p:sp>
         <p:nvSpPr>
-          <p:cNvPr id="190" name="Google Shape;190;p11"/>
+          <p:cNvPr id="191" name="Rectangle 190"/>
           <p:cNvSpPr/>
           <p:nvPr/>
         </p:nvSpPr>
         <p:spPr>
           <a:xfrm>
-            <a:off x="6242756" y="-6200"/>
-            <a:ext cx="2901219" cy="830956"/>
+            <a:off x="8458200" y="6519672"/>
+            <a:ext cx="685800" cy="338328"/>
+          </a:xfrm>
+          <a:prstGeom prst="rect">
+            <a:avLst/>
+          </a:prstGeom>
+          <a:solidFill>
+            <a:srgbClr val="7A1C35"/>
+          </a:solidFill>
+          <a:ln>
+            <a:solidFill>
+              <a:srgbClr val="7A1C35"/>
+            </a:solidFill>
+          </a:ln>
+        </p:spPr>
+        <p:style>
+          <a:lnRef idx="1">
+            <a:schemeClr val="accent1"/>
+          </a:lnRef>
+          <a:fillRef idx="3">
+            <a:schemeClr val="accent1"/>
+          </a:fillRef>
+          <a:effectRef idx="2">
+            <a:schemeClr val="accent1"/>
+          </a:effectRef>
+          <a:fontRef idx="minor">
+            <a:schemeClr val="lt1"/>
+          </a:fontRef>
+        </p:style>
+        <p:txBody>
+          <a:bodyPr rtlCol="0" anchor="ctr"/>
+          <a:lstStyle/>
+          <a:p>
+            <a:pPr algn="ctr"/>
+            <a:r>
+              <a:rPr lang="es-MX" sz="1000" noProof="0" dirty="0">
+                <a:solidFill>
+                  <a:srgbClr val="FFFFFF"/>
+                </a:solidFill>
+                <a:latin typeface="Arial"/>
+              </a:rPr>
+              <a:t>11/15</a:t>
+            </a:r>
+          </a:p>
+        </p:txBody>
+      </p:sp>
+      <p:sp>
+        <p:nvSpPr>
+          <p:cNvPr id="4" name="Google Shape;152;p8">
+            <a:extLst>
+              <a:ext uri="{FF2B5EF4-FFF2-40B4-BE49-F238E27FC236}">
+                <a16:creationId xmlns:a16="http://schemas.microsoft.com/office/drawing/2014/main" id="{5B702F44-2088-B063-4BD6-B60713F5764E}"/>
+              </a:ext>
+            </a:extLst>
+          </p:cNvPr>
+          <p:cNvSpPr/>
+          <p:nvPr/>
+        </p:nvSpPr>
+        <p:spPr>
+          <a:xfrm>
+            <a:off x="6592725" y="13603"/>
+            <a:ext cx="2551275" cy="769401"/>
           </a:xfrm>
           <a:prstGeom prst="rect">
             <a:avLst/>
@@ -17928,228 +17941,23 @@
           <a:p>
             <a:pPr algn="r"/>
             <a:r>
-              <a:rPr sz="4400" b="0" i="0">
+              <a:rPr lang="es-MX" sz="4400" b="0" i="0" noProof="0" dirty="0">
                 <a:solidFill>
                   <a:srgbClr val="76923C"/>
                 </a:solidFill>
                 <a:latin typeface="Calibri"/>
               </a:rPr>
-              <a:t>Evidencias</a:t>
+              <a:t>Avance</a:t>
             </a:r>
-            <a:endParaRPr sz="1400" b="0" i="0" u="none" strike="noStrike" cap="none">
+            <a:endParaRPr lang="es-MX" sz="3500" b="0" i="0" u="none" strike="noStrike" cap="none" noProof="0" dirty="0">
               <a:solidFill>
-                <a:srgbClr val="000000"/>
+                <a:srgbClr val="76923C"/>
               </a:solidFill>
-              <a:latin typeface="Arial"/>
-              <a:ea typeface="Arial"/>
-              <a:cs typeface="Arial"/>
-              <a:sym typeface="Arial"/>
+              <a:latin typeface="Calibri"/>
+              <a:ea typeface="Calibri"/>
+              <a:cs typeface="Calibri"/>
+              <a:sym typeface="Calibri"/>
             </a:endParaRPr>
-          </a:p>
-        </p:txBody>
-      </p:sp>
-      <p:sp>
-        <p:nvSpPr>
-          <p:cNvPr id="191" name="Google Shape;191;p11"/>
-          <p:cNvSpPr/>
-          <p:nvPr/>
-        </p:nvSpPr>
-        <p:spPr>
-          <a:xfrm>
-            <a:off x="8461665" y="6519446"/>
-            <a:ext cx="682335" cy="338554"/>
-          </a:xfrm>
-          <a:prstGeom prst="rect">
-            <a:avLst/>
-          </a:prstGeom>
-          <a:solidFill>
-            <a:schemeClr val="lt1"/>
-          </a:solidFill>
-          <a:ln w="25400" cap="flat" cmpd="sng">
-            <a:solidFill>
-              <a:srgbClr val="76923C"/>
-            </a:solidFill>
-            <a:prstDash val="solid"/>
-            <a:round/>
-            <a:headEnd type="none" w="sm" len="sm"/>
-            <a:tailEnd type="none" w="sm" len="sm"/>
-          </a:ln>
-        </p:spPr>
-        <p:txBody>
-          <a:bodyPr spcFirstLastPara="1" wrap="square" lIns="91425" tIns="45700" rIns="91425" bIns="45700" anchor="t" anchorCtr="0">
-            <a:spAutoFit/>
-          </a:bodyPr>
-          <a:lstStyle/>
-          <a:p>
-            <a:r>
-              <a:rPr sz="1600" b="0" i="0">
-                <a:solidFill>
-                  <a:srgbClr val="76923C"/>
-                </a:solidFill>
-                <a:latin typeface="Calibri"/>
-              </a:rPr>
-              <a:t>11/15</a:t>
-            </a:r>
-            <a:endParaRPr sz="1400" b="0" i="0" u="none" strike="noStrike" cap="none">
-              <a:solidFill>
-                <a:srgbClr val="000000"/>
-              </a:solidFill>
-              <a:latin typeface="Arial"/>
-              <a:ea typeface="Arial"/>
-              <a:cs typeface="Arial"/>
-              <a:sym typeface="Arial"/>
-            </a:endParaRPr>
-          </a:p>
-        </p:txBody>
-      </p:sp>
-      <p:sp>
-        <p:nvSpPr>
-          <p:cNvPr id="192" name="Google Shape;192;p11"/>
-          <p:cNvSpPr/>
-          <p:nvPr/>
-        </p:nvSpPr>
-        <p:spPr>
-          <a:xfrm>
-            <a:off x="731520" y="1005840"/>
-            <a:ext cx="7680960" cy="3474720"/>
-          </a:xfrm>
-          <a:prstGeom prst="rect">
-            <a:avLst/>
-          </a:prstGeom>
-          <a:noFill/>
-          <a:ln>
-            <a:noFill/>
-          </a:ln>
-        </p:spPr>
-        <p:txBody>
-          <a:bodyPr spcFirstLastPara="1" wrap="square" lIns="91425" tIns="45700" rIns="91425" bIns="45700" anchor="t" anchorCtr="0">
-            <a:spAutoFit/>
-          </a:bodyPr>
-          <a:lstStyle/>
-          <a:p>
-            <a:pPr>
-              <a:spcAft>
-                <a:spcPts val="600"/>
-              </a:spcAft>
-            </a:pPr>
-            <a:r>
-              <a:rPr sz="1800" b="1" i="0">
-                <a:solidFill>
-                  <a:srgbClr val="76923C"/>
-                </a:solidFill>
-                <a:latin typeface="Arial"/>
-              </a:rPr>
-              <a:t>Principales entregables y componentes técnicos implementados:</a:t>
-            </a:r>
-            <a:endParaRPr sz="1400" b="0" i="0" u="none" strike="noStrike" cap="none">
-              <a:solidFill>
-                <a:srgbClr val="000000"/>
-              </a:solidFill>
-              <a:latin typeface="Arial"/>
-              <a:ea typeface="Arial"/>
-              <a:cs typeface="Arial"/>
-              <a:sym typeface="Arial"/>
-            </a:endParaRPr>
-          </a:p>
-          <a:p>
-            <a:pPr>
-              <a:spcAft>
-                <a:spcPts val="500"/>
-              </a:spcAft>
-            </a:pPr>
-            <a:r>
-              <a:rPr sz="1450" b="1" i="0">
-                <a:solidFill>
-                  <a:srgbClr val="000000"/>
-                </a:solidFill>
-                <a:latin typeface="Arial"/>
-              </a:rPr>
-              <a:t>• Documentación Técnica Formal: </a:t>
-            </a:r>
-            <a:r>
-              <a:rPr sz="1450" b="0" i="0">
-                <a:solidFill>
-                  <a:srgbClr val="000000"/>
-                </a:solidFill>
-                <a:latin typeface="Arial"/>
-              </a:rPr>
-              <a:t>Memoria de residencia completa con 66 figuras estandarizadas en blanco y negro, especificación de requerimientos y diagrama de flujo global ANSI/ISO.</a:t>
-            </a:r>
-          </a:p>
-          <a:p>
-            <a:pPr>
-              <a:spcAft>
-                <a:spcPts val="500"/>
-              </a:spcAft>
-            </a:pPr>
-            <a:r>
-              <a:rPr sz="1450" b="1" i="0">
-                <a:solidFill>
-                  <a:srgbClr val="000000"/>
-                </a:solidFill>
-                <a:latin typeface="Arial"/>
-              </a:rPr>
-              <a:t>• Mapeo Cartográfico GIS Interactivo: </a:t>
-            </a:r>
-            <a:r>
-              <a:rPr sz="1450" b="0" i="0">
-                <a:solidFill>
-                  <a:srgbClr val="000000"/>
-                </a:solidFill>
-                <a:latin typeface="Arial"/>
-              </a:rPr>
-              <a:t>Prototipo funcional en React Leaflet con polilíneas de fibra, trazado de rutas, semáforo de saturación en cajas NAP y calibración satelital GPS.</a:t>
-            </a:r>
-          </a:p>
-          <a:p>
-            <a:pPr>
-              <a:spcAft>
-                <a:spcPts val="500"/>
-              </a:spcAft>
-            </a:pPr>
-            <a:r>
-              <a:rPr sz="1450" b="1" i="0">
-                <a:solidFill>
-                  <a:srgbClr val="000000"/>
-                </a:solidFill>
-                <a:latin typeface="Arial"/>
-              </a:rPr>
-              <a:t>• Matriz de Puertos y Bloqueo Concurrente: </a:t>
-            </a:r>
-            <a:r>
-              <a:rPr sz="1450" b="0" i="0">
-                <a:solidFill>
-                  <a:srgbClr val="000000"/>
-                </a:solidFill>
-                <a:latin typeface="Arial"/>
-              </a:rPr>
-              <a:t>Chasis interactivo de 16 puertos SC-APC con resolución de colisiones mediante transacciones pesimistas (SELECT ... FOR UPDATE) en PostgreSQL.</a:t>
-            </a:r>
-          </a:p>
-          <a:p>
-            <a:pPr>
-              <a:spcAft>
-                <a:spcPts val="500"/>
-              </a:spcAft>
-            </a:pPr>
-            <a:r>
-              <a:rPr sz="1450" b="1" i="0">
-                <a:solidFill>
-                  <a:srgbClr val="000000"/>
-                </a:solidFill>
-                <a:latin typeface="Arial"/>
-              </a:rPr>
-              <a:t>• Repositorio de Código y Motor Offline: </a:t>
-            </a:r>
-            <a:r>
-              <a:rPr sz="1450" b="0" i="0">
-                <a:solidFill>
-                  <a:srgbClr val="000000"/>
-                </a:solidFill>
-                <a:latin typeface="Arial"/>
-              </a:rPr>
-              <a:t>Base de código estructurada en TypeScript, modelos Sequelize y base de datos local Dexie.js (IndexedDB) para operación continua en campo.</a:t>
-            </a:r>
           </a:p>
         </p:txBody>
       </p:sp>
@@ -18161,7 +17969,7 @@
 </p:sld>
 </file>
 
-<file path=ppt/slides/slide12.xml><?xml version="1.0" encoding="utf-8"?>
+<file path=ppt/slides/slide11.xml><?xml version="1.0" encoding="utf-8"?>
 <p:sld xmlns:a="http://schemas.openxmlformats.org/drawingml/2006/main" xmlns:r="http://schemas.openxmlformats.org/officeDocument/2006/relationships" xmlns:p="http://schemas.openxmlformats.org/presentationml/2006/main">
   <p:cSld>
     <p:spTree>
@@ -18240,7 +18048,7 @@
           <a:p>
             <a:pPr algn="r"/>
             <a:r>
-              <a:rPr sz="4400" b="0" i="0">
+              <a:rPr lang="es-MX" sz="4400" b="0" i="0" noProof="0" dirty="0">
                 <a:solidFill>
                   <a:srgbClr val="76923C"/>
                 </a:solidFill>
@@ -18248,7 +18056,7 @@
               </a:rPr>
               <a:t>Cronograma</a:t>
             </a:r>
-            <a:endParaRPr sz="1400" b="0" i="0" u="none" strike="noStrike" cap="none">
+            <a:endParaRPr lang="es-MX" sz="1400" b="0" i="0" u="none" strike="noStrike" cap="none" noProof="0" dirty="0">
               <a:solidFill>
                 <a:srgbClr val="000000"/>
               </a:solidFill>
@@ -18294,7 +18102,7 @@
           <a:lstStyle/>
           <a:p>
             <a:r>
-              <a:rPr sz="1600" b="0" i="0">
+              <a:rPr lang="es-MX" sz="1600" b="0" i="0" noProof="0" dirty="0">
                 <a:solidFill>
                   <a:srgbClr val="76923C"/>
                 </a:solidFill>
@@ -18302,7 +18110,7 @@
               </a:rPr>
               <a:t>12/15</a:t>
             </a:r>
-            <a:endParaRPr sz="1400" b="0" i="0" u="none" strike="noStrike" cap="none">
+            <a:endParaRPr lang="es-MX" sz="1400" b="0" i="0" u="none" strike="noStrike" cap="none" noProof="0" dirty="0">
               <a:solidFill>
                 <a:srgbClr val="000000"/>
               </a:solidFill>
@@ -18366,25 +18174,15 @@
           </a:bodyPr>
           <a:lstStyle/>
           <a:p>
-            <a:pPr algn="ctr"/>
             <a:r>
-              <a:rPr sz="1350" b="0" i="0">
-                <a:solidFill>
-                  <a:srgbClr val="505050"/>
-                </a:solidFill>
-                <a:latin typeface="Calibri"/>
+              <a:rPr lang="es-MX" sz="1000" noProof="0" dirty="0">
+                <a:solidFill>
+                  <a:srgbClr val="7A1C35"/>
+                </a:solidFill>
+                <a:latin typeface="Arial"/>
               </a:rPr>
-              <a:t>Figura 4. Cronograma de actividades del proyecto de residencia profesional (Corte al 20 de septiembre de 2026).</a:t>
+              <a:t>Figura 4. Cronograma de actividades del proyecto de residencia profesional (Corte: 40% de avance físico y metodológico).</a:t>
             </a:r>
-            <a:endParaRPr sz="1400" b="0" i="0" u="none" strike="noStrike" cap="none">
-              <a:solidFill>
-                <a:srgbClr val="000000"/>
-              </a:solidFill>
-              <a:latin typeface="Arial"/>
-              <a:ea typeface="Arial"/>
-              <a:cs typeface="Arial"/>
-              <a:sym typeface="Arial"/>
-            </a:endParaRPr>
           </a:p>
         </p:txBody>
       </p:sp>
@@ -18396,7 +18194,7 @@
 </p:sld>
 </file>
 
-<file path=ppt/slides/slide13.xml><?xml version="1.0" encoding="utf-8"?>
+<file path=ppt/slides/slide12.xml><?xml version="1.0" encoding="utf-8"?>
 <p:sld xmlns:a="http://schemas.openxmlformats.org/drawingml/2006/main" xmlns:r="http://schemas.openxmlformats.org/officeDocument/2006/relationships" xmlns:p="http://schemas.openxmlformats.org/presentationml/2006/main">
   <p:cSld>
     <p:spTree>
@@ -18465,16 +18263,45 @@
           </a:bodyPr>
           <a:lstStyle/>
           <a:p>
-            <a:pPr>
-              <a:spcAft>
-                <a:spcPts val="500"/>
-              </a:spcAft>
+            <a:pPr algn="l">
+              <a:lnSpc>
+                <a:spcPct val="135000"/>
+              </a:lnSpc>
+              <a:defRPr sz="1500" b="0" i="0">
+                <a:solidFill>
+                  <a:srgbClr val="1F2937"/>
+                </a:solidFill>
+                <a:latin typeface="Arial"/>
+              </a:defRPr>
             </a:pPr>
             <a:r>
-              <a:rPr lang="es-MX" b="1" dirty="0"/>
-              <a:t>Con base al cronograma de actividades se ha llegado al avance de un 40% siendo un gran avance con tiempo y forma.</a:t>
+              <a:rPr lang="es-MX" sz="1250" noProof="0" dirty="0">
+                <a:solidFill>
+                  <a:srgbClr val="1E293B"/>
+                </a:solidFill>
+                <a:latin typeface="Arial"/>
+              </a:rPr>
+              <a:t>Con base en el cronograma de actividades planificado, el proyecto registra actualmente un avance físico y metodológico del 40%, cumpliendo satisfactoriamente en tiempo y forma con las fases de levantamiento de infraestructura, análisis formal de requerimientos, diseño arquitectónico del software y prototipado del visor cartográfico y del </a:t>
             </a:r>
-            <a:endParaRPr sz="1400" b="0" i="0" dirty="0">
+            <a:r>
+              <a:rPr lang="es-MX" sz="1250" noProof="0" dirty="0" err="1">
+                <a:solidFill>
+                  <a:srgbClr val="1E293B"/>
+                </a:solidFill>
+                <a:latin typeface="Arial"/>
+              </a:rPr>
+              <a:t>backend</a:t>
+            </a:r>
+            <a:r>
+              <a:rPr lang="es-MX" sz="1250" noProof="0" dirty="0">
+                <a:solidFill>
+                  <a:srgbClr val="1E293B"/>
+                </a:solidFill>
+                <a:latin typeface="Arial"/>
+              </a:rPr>
+              <a:t> transaccional. Los resultados preliminares confirman la viabilidad técnica y operativa de la plataforma web, resolviendo la trazabilidad geoespacial de planta externa y sentando las bases sólidas para culminar con éxito la implementación en campo y la validación con las cuadrillas técnicas en las semanas restantes.</a:t>
+            </a:r>
+            <a:endParaRPr lang="es-MX" sz="1400" b="0" i="0" noProof="0" dirty="0">
               <a:solidFill>
                 <a:srgbClr val="000000"/>
               </a:solidFill>
@@ -18518,7 +18345,7 @@
           <a:p>
             <a:pPr algn="r"/>
             <a:r>
-              <a:rPr sz="3800" b="0" i="0">
+              <a:rPr lang="es-MX" sz="3800" b="0" i="0" noProof="0" dirty="0">
                 <a:solidFill>
                   <a:srgbClr val="76923C"/>
                 </a:solidFill>
@@ -18526,7 +18353,7 @@
               </a:rPr>
               <a:t>Conclusiones Preliminares</a:t>
             </a:r>
-            <a:endParaRPr sz="1400" b="0" i="0" u="none" strike="noStrike" cap="none">
+            <a:endParaRPr lang="es-MX" sz="1400" b="0" i="0" u="none" strike="noStrike" cap="none" noProof="0" dirty="0">
               <a:solidFill>
                 <a:srgbClr val="000000"/>
               </a:solidFill>
@@ -18572,7 +18399,7 @@
           <a:lstStyle/>
           <a:p>
             <a:r>
-              <a:rPr sz="1600" b="0" i="0">
+              <a:rPr lang="es-MX" sz="1600" b="0" i="0" noProof="0" dirty="0">
                 <a:solidFill>
                   <a:srgbClr val="76923C"/>
                 </a:solidFill>
@@ -18580,7 +18407,7 @@
               </a:rPr>
               <a:t>13/15</a:t>
             </a:r>
-            <a:endParaRPr sz="1400" b="0" i="0" u="none" strike="noStrike" cap="none">
+            <a:endParaRPr lang="es-MX" sz="1400" b="0" i="0" u="none" strike="noStrike" cap="none" noProof="0" dirty="0">
               <a:solidFill>
                 <a:srgbClr val="000000"/>
               </a:solidFill>
@@ -18600,7 +18427,7 @@
 </p:sld>
 </file>
 
-<file path=ppt/slides/slide14.xml><?xml version="1.0" encoding="utf-8"?>
+<file path=ppt/slides/slide13.xml><?xml version="1.0" encoding="utf-8"?>
 <p:sld xmlns:a="http://schemas.openxmlformats.org/drawingml/2006/main" xmlns:r="http://schemas.openxmlformats.org/officeDocument/2006/relationships" xmlns:p="http://schemas.openxmlformats.org/presentationml/2006/main">
   <p:cSld>
     <p:spTree>
@@ -18669,21 +18496,30 @@
           </a:bodyPr>
           <a:lstStyle/>
           <a:p>
-            <a:pPr>
-              <a:spcAft>
-                <a:spcPts val="500"/>
-              </a:spcAft>
+            <a:pPr algn="l">
+              <a:lnSpc>
+                <a:spcPct val="115000"/>
+              </a:lnSpc>
+              <a:defRPr sz="1150" b="0" i="0">
+                <a:solidFill>
+                  <a:srgbClr val="1F2937"/>
+                </a:solidFill>
+                <a:latin typeface="Arial"/>
+              </a:defRPr>
             </a:pPr>
             <a:r>
-              <a:rPr sz="1350" b="0" i="0">
-                <a:solidFill>
-                  <a:srgbClr val="000000"/>
-                </a:solidFill>
-                <a:latin typeface="Arial"/>
-              </a:rPr>
-              <a:t>• International Telecommunication Union. (2003). Recomendación ITU-T G.984.1 / G.984.2: Redes ópticas pasivas con capacidad de gigabit (GPON). Ginebra: ITU.</a:t>
+              <a:rPr lang="es-MX" noProof="0" dirty="0"/>
+              <a:t>International </a:t>
             </a:r>
-            <a:endParaRPr sz="1400" b="0" i="0" u="none" strike="noStrike" cap="none">
+            <a:r>
+              <a:rPr lang="es-MX" noProof="0" dirty="0" err="1"/>
+              <a:t>Telecommunication</a:t>
+            </a:r>
+            <a:r>
+              <a:rPr lang="es-MX" noProof="0" dirty="0"/>
+              <a:t> Union. (2003). Recomendación ITU-T G.984.1 / G.984.2: Redes ópticas pasivas con capacidad de gigabit (GPON). Ginebra: ITU.</a:t>
+            </a:r>
+            <a:endParaRPr lang="es-MX" sz="1400" b="0" i="0" u="none" strike="noStrike" cap="none" noProof="0" dirty="0">
               <a:solidFill>
                 <a:schemeClr val="dk1"/>
               </a:solidFill>
@@ -18694,67 +18530,199 @@
             </a:endParaRPr>
           </a:p>
           <a:p>
-            <a:pPr>
-              <a:spcAft>
-                <a:spcPts val="500"/>
-              </a:spcAft>
+            <a:pPr algn="l">
+              <a:lnSpc>
+                <a:spcPct val="115000"/>
+              </a:lnSpc>
+              <a:spcBef>
+                <a:spcPts val="0"/>
+              </a:spcBef>
+              <a:spcAft>
+                <a:spcPts val="600"/>
+              </a:spcAft>
+              <a:defRPr sz="1150" b="0" i="0">
+                <a:solidFill>
+                  <a:srgbClr val="1F2937"/>
+                </a:solidFill>
+                <a:latin typeface="Arial"/>
+              </a:defRPr>
             </a:pPr>
             <a:r>
-              <a:rPr sz="1350" b="0" i="0">
-                <a:solidFill>
-                  <a:srgbClr val="000000"/>
-                </a:solidFill>
-                <a:latin typeface="Arial"/>
-              </a:rPr>
-              <a:t>• Tanenbaum, A. S., &amp; Wetherall, D. J. (2014). Redes de computadoras (5.ª ed.). Ciudad de México: Pearson Educación.</a:t>
+              <a:rPr lang="es-MX" noProof="0" dirty="0"/>
+              <a:t>Tanenbaum, A. S., &amp; Wetherall, D. J. (2014). Redes de computadoras (5.ª ed.). Ciudad de México: Pearson Educación.</a:t>
             </a:r>
           </a:p>
           <a:p>
-            <a:pPr>
-              <a:spcAft>
-                <a:spcPts val="500"/>
-              </a:spcAft>
+            <a:pPr algn="l">
+              <a:lnSpc>
+                <a:spcPct val="115000"/>
+              </a:lnSpc>
+              <a:spcBef>
+                <a:spcPts val="0"/>
+              </a:spcBef>
+              <a:spcAft>
+                <a:spcPts val="600"/>
+              </a:spcAft>
+              <a:defRPr sz="1150" b="0" i="0">
+                <a:solidFill>
+                  <a:srgbClr val="1F2937"/>
+                </a:solidFill>
+                <a:latin typeface="Arial"/>
+              </a:defRPr>
             </a:pPr>
             <a:r>
-              <a:rPr sz="1350" b="0" i="0">
-                <a:solidFill>
-                  <a:srgbClr val="000000"/>
-                </a:solidFill>
-                <a:latin typeface="Arial"/>
-              </a:rPr>
-              <a:t>• Silberschatz, A., Korth, H. F., &amp; Sudarshan, S. (2019). Database System Concepts (7th ed.). Nueva York: McGraw-Hill.</a:t>
+              <a:rPr lang="es-MX" noProof="0" dirty="0"/>
+              <a:t>Silberschatz, A., Korth, H. F., &amp; Sudarshan, S. (2019). </a:t>
+            </a:r>
+            <a:r>
+              <a:rPr lang="es-MX" noProof="0" dirty="0" err="1"/>
+              <a:t>Database</a:t>
+            </a:r>
+            <a:r>
+              <a:rPr lang="es-MX" noProof="0" dirty="0"/>
+              <a:t> </a:t>
+            </a:r>
+            <a:r>
+              <a:rPr lang="es-MX" noProof="0" dirty="0" err="1"/>
+              <a:t>System</a:t>
+            </a:r>
+            <a:r>
+              <a:rPr lang="es-MX" noProof="0" dirty="0"/>
+              <a:t> </a:t>
+            </a:r>
+            <a:r>
+              <a:rPr lang="es-MX" noProof="0" dirty="0" err="1"/>
+              <a:t>Concepts</a:t>
+            </a:r>
+            <a:r>
+              <a:rPr lang="es-MX" noProof="0" dirty="0"/>
+              <a:t> (7th ed.). Nueva York: McGraw-Hill.</a:t>
             </a:r>
           </a:p>
           <a:p>
-            <a:pPr>
-              <a:spcAft>
-                <a:spcPts val="500"/>
-              </a:spcAft>
+            <a:pPr algn="l">
+              <a:lnSpc>
+                <a:spcPct val="115000"/>
+              </a:lnSpc>
+              <a:spcBef>
+                <a:spcPts val="0"/>
+              </a:spcBef>
+              <a:spcAft>
+                <a:spcPts val="600"/>
+              </a:spcAft>
+              <a:defRPr sz="1150" b="0" i="0">
+                <a:solidFill>
+                  <a:srgbClr val="1F2937"/>
+                </a:solidFill>
+                <a:latin typeface="Arial"/>
+              </a:defRPr>
             </a:pPr>
             <a:r>
-              <a:rPr sz="1350" b="0" i="0">
-                <a:solidFill>
-                  <a:srgbClr val="000000"/>
-                </a:solidFill>
-                <a:latin typeface="Arial"/>
-              </a:rPr>
-              <a:t>• World Wide Web Consortium (W3C). (2018). Web Content Accessibility Guidelines (WCAG) 2.1. W3C Recommendation. https://www.w3.org/TR/WCAG21/</a:t>
+              <a:rPr lang="es-MX" noProof="0" dirty="0"/>
+              <a:t>World Wide Web </a:t>
+            </a:r>
+            <a:r>
+              <a:rPr lang="es-MX" noProof="0" dirty="0" err="1"/>
+              <a:t>Consortium</a:t>
+            </a:r>
+            <a:r>
+              <a:rPr lang="es-MX" noProof="0" dirty="0"/>
+              <a:t> (W3C). (2018). Web Content </a:t>
+            </a:r>
+            <a:r>
+              <a:rPr lang="es-MX" noProof="0" dirty="0" err="1"/>
+              <a:t>Accessibility</a:t>
+            </a:r>
+            <a:r>
+              <a:rPr lang="es-MX" noProof="0" dirty="0"/>
+              <a:t> </a:t>
+            </a:r>
+            <a:r>
+              <a:rPr lang="es-MX" noProof="0" dirty="0" err="1"/>
+              <a:t>Guidelines</a:t>
+            </a:r>
+            <a:r>
+              <a:rPr lang="es-MX" noProof="0" dirty="0"/>
+              <a:t> (WCAG) 2.1. W3C </a:t>
+            </a:r>
+            <a:r>
+              <a:rPr lang="es-MX" noProof="0" dirty="0" err="1"/>
+              <a:t>Recommendation</a:t>
+            </a:r>
+            <a:r>
+              <a:rPr lang="es-MX" noProof="0" dirty="0"/>
+              <a:t>. https://www.w3.org/TR/WCAG21/</a:t>
             </a:r>
           </a:p>
           <a:p>
-            <a:pPr>
-              <a:spcAft>
-                <a:spcPts val="500"/>
-              </a:spcAft>
+            <a:pPr algn="l">
+              <a:lnSpc>
+                <a:spcPct val="115000"/>
+              </a:lnSpc>
+              <a:spcBef>
+                <a:spcPts val="0"/>
+              </a:spcBef>
+              <a:spcAft>
+                <a:spcPts val="600"/>
+              </a:spcAft>
+              <a:defRPr sz="1150" b="0" i="0">
+                <a:solidFill>
+                  <a:srgbClr val="1F2937"/>
+                </a:solidFill>
+                <a:latin typeface="Arial"/>
+              </a:defRPr>
             </a:pPr>
             <a:r>
-              <a:rPr sz="1350" b="0" i="0">
-                <a:solidFill>
-                  <a:srgbClr val="000000"/>
-                </a:solidFill>
-                <a:latin typeface="Arial"/>
-              </a:rPr>
-              <a:t>• PostgreSQL Global Development Group. (2024). PostgreSQL 16.0 Documentation: Explicit Locking and Transaction Isolation. https://www.postgresql.org/docs/16/</a:t>
+              <a:rPr lang="es-MX" noProof="0" dirty="0"/>
+              <a:t>PostgreSQL Global </a:t>
+            </a:r>
+            <a:r>
+              <a:rPr lang="es-MX" noProof="0" dirty="0" err="1"/>
+              <a:t>Development</a:t>
+            </a:r>
+            <a:r>
+              <a:rPr lang="es-MX" noProof="0" dirty="0"/>
+              <a:t> Group. (2024). PostgreSQL 16.0 </a:t>
+            </a:r>
+            <a:r>
+              <a:rPr lang="es-MX" noProof="0" dirty="0" err="1"/>
+              <a:t>Documentation</a:t>
+            </a:r>
+            <a:r>
+              <a:rPr lang="es-MX" noProof="0" dirty="0"/>
+              <a:t>: </a:t>
+            </a:r>
+            <a:r>
+              <a:rPr lang="es-MX" noProof="0" dirty="0" err="1"/>
+              <a:t>Explicit</a:t>
+            </a:r>
+            <a:r>
+              <a:rPr lang="es-MX" noProof="0" dirty="0"/>
+              <a:t> </a:t>
+            </a:r>
+            <a:r>
+              <a:rPr lang="es-MX" noProof="0" dirty="0" err="1"/>
+              <a:t>Locking</a:t>
+            </a:r>
+            <a:r>
+              <a:rPr lang="es-MX" noProof="0" dirty="0"/>
+              <a:t> and </a:t>
+            </a:r>
+            <a:r>
+              <a:rPr lang="es-MX" noProof="0" dirty="0" err="1"/>
+              <a:t>Transaction</a:t>
+            </a:r>
+            <a:r>
+              <a:rPr lang="es-MX" noProof="0" dirty="0"/>
+              <a:t> </a:t>
+            </a:r>
+            <a:r>
+              <a:rPr lang="es-MX" noProof="0" dirty="0" err="1"/>
+              <a:t>Isolation</a:t>
+            </a:r>
+            <a:r>
+              <a:rPr lang="es-MX" noProof="0" dirty="0"/>
+              <a:t>. https://www.postgresql.org/docs/16/</a:t>
             </a:r>
           </a:p>
         </p:txBody>
@@ -18794,7 +18762,7 @@
           <a:p>
             <a:pPr algn="r"/>
             <a:r>
-              <a:rPr sz="3800" b="0" i="0">
+              <a:rPr lang="es-MX" sz="3800" b="0" i="0" noProof="0" dirty="0">
                 <a:solidFill>
                   <a:srgbClr val="76923C"/>
                 </a:solidFill>
@@ -18802,7 +18770,7 @@
               </a:rPr>
               <a:t>Bibliografía y Referencias</a:t>
             </a:r>
-            <a:endParaRPr sz="1400" b="0" i="0" u="none" strike="noStrike" cap="none">
+            <a:endParaRPr lang="es-MX" sz="1400" b="0" i="0" u="none" strike="noStrike" cap="none" noProof="0" dirty="0">
               <a:solidFill>
                 <a:srgbClr val="000000"/>
               </a:solidFill>
@@ -18848,7 +18816,7 @@
           <a:lstStyle/>
           <a:p>
             <a:r>
-              <a:rPr sz="1600" b="0" i="0">
+              <a:rPr lang="es-MX" sz="1600" b="0" i="0" noProof="0" dirty="0">
                 <a:solidFill>
                   <a:srgbClr val="76923C"/>
                 </a:solidFill>
@@ -18856,7 +18824,7 @@
               </a:rPr>
               <a:t>14/15</a:t>
             </a:r>
-            <a:endParaRPr sz="1400" b="0" i="0" u="none" strike="noStrike" cap="none">
+            <a:endParaRPr lang="es-MX" sz="1400" b="0" i="0" u="none" strike="noStrike" cap="none" noProof="0" dirty="0">
               <a:solidFill>
                 <a:srgbClr val="000000"/>
               </a:solidFill>
@@ -18876,7 +18844,7 @@
 </p:sld>
 </file>
 
-<file path=ppt/slides/slide15.xml><?xml version="1.0" encoding="utf-8"?>
+<file path=ppt/slides/slide14.xml><?xml version="1.0" encoding="utf-8"?>
 <p:sld xmlns:a="http://schemas.openxmlformats.org/drawingml/2006/main" xmlns:r="http://schemas.openxmlformats.org/officeDocument/2006/relationships" xmlns:p="http://schemas.openxmlformats.org/presentationml/2006/main">
   <p:cSld>
     <p:spTree>
@@ -19001,15 +18969,15 @@
           <a:p>
             <a:pPr algn="r"/>
             <a:r>
-              <a:rPr sz="1800" b="0" i="0">
-                <a:solidFill>
-                  <a:srgbClr val="505050"/>
-                </a:solidFill>
-                <a:latin typeface="Calibri"/>
+              <a:rPr lang="es-MX" sz="1400" noProof="0" dirty="0">
+                <a:solidFill>
+                  <a:srgbClr val="7A1C35"/>
+                </a:solidFill>
+                <a:latin typeface="Arial"/>
               </a:rPr>
-              <a:t>Septiembre de 2026</a:t>
+              <a:t>Octubre de 2026</a:t>
             </a:r>
-            <a:endParaRPr sz="1400" b="0" i="0" u="none" strike="noStrike" cap="none">
+            <a:endParaRPr lang="es-MX" sz="1400" b="0" i="0" u="none" strike="noStrike" cap="none" noProof="0" dirty="0">
               <a:solidFill>
                 <a:srgbClr val="000000"/>
               </a:solidFill>
@@ -19050,7 +19018,7 @@
           <a:p>
             <a:pPr algn="ctr"/>
             <a:r>
-              <a:rPr sz="5600" b="0" i="0">
+              <a:rPr lang="es-MX" sz="5600" b="0" i="0" noProof="0" dirty="0">
                 <a:solidFill>
                   <a:srgbClr val="76923C"/>
                 </a:solidFill>
@@ -19058,7 +19026,7 @@
               </a:rPr>
               <a:t>¡Muchas Gracias!</a:t>
             </a:r>
-            <a:endParaRPr sz="1400" b="0" i="0" u="none" strike="noStrike" cap="none">
+            <a:endParaRPr lang="es-MX" sz="1400" b="0" i="0" u="none" strike="noStrike" cap="none" noProof="0" dirty="0">
               <a:solidFill>
                 <a:srgbClr val="000000"/>
               </a:solidFill>
@@ -19104,7 +19072,7 @@
           <a:lstStyle/>
           <a:p>
             <a:r>
-              <a:rPr sz="1600" b="0" i="0">
+              <a:rPr lang="es-MX" sz="1600" b="0" i="0" noProof="0" dirty="0">
                 <a:solidFill>
                   <a:srgbClr val="76923C"/>
                 </a:solidFill>
@@ -19112,7 +19080,7 @@
               </a:rPr>
               <a:t>15/15</a:t>
             </a:r>
-            <a:endParaRPr sz="1400" b="0" i="0" u="none" strike="noStrike" cap="none">
+            <a:endParaRPr lang="es-MX" sz="1400" b="0" i="0" u="none" strike="noStrike" cap="none" noProof="0" dirty="0">
               <a:solidFill>
                 <a:srgbClr val="000000"/>
               </a:solidFill>
@@ -19153,52 +19121,16 @@
           <a:p>
             <a:pPr algn="ctr"/>
             <a:r>
-              <a:rPr sz="4200" b="0" i="0" dirty="0">
+              <a:rPr lang="es-MX" sz="4200" b="0" i="0" noProof="0" dirty="0">
                 <a:solidFill>
                   <a:srgbClr val="76923C"/>
                 </a:solidFill>
                 <a:latin typeface="Calibri"/>
               </a:rPr>
-              <a:t>¿</a:t>
-            </a:r>
-            <a:r>
-              <a:rPr sz="4200" b="0" i="0" dirty="0" err="1">
-                <a:solidFill>
-                  <a:srgbClr val="76923C"/>
-                </a:solidFill>
-                <a:latin typeface="Calibri"/>
-              </a:rPr>
-              <a:t>Preguntas</a:t>
-            </a:r>
-            <a:r>
-              <a:rPr sz="4200" b="0" i="0" dirty="0">
-                <a:solidFill>
-                  <a:srgbClr val="76923C"/>
-                </a:solidFill>
-                <a:latin typeface="Calibri"/>
-              </a:rPr>
-              <a:t> o </a:t>
-            </a:r>
-            <a:r>
-              <a:rPr sz="4200" b="0" i="0" dirty="0" err="1">
-                <a:solidFill>
-                  <a:srgbClr val="76923C"/>
-                </a:solidFill>
-                <a:latin typeface="Calibri"/>
-              </a:rPr>
-              <a:t>Comentarios</a:t>
-            </a:r>
-            <a:r>
-              <a:rPr sz="4200" b="0" i="0" dirty="0">
-                <a:solidFill>
-                  <a:srgbClr val="76923C"/>
-                </a:solidFill>
-                <a:latin typeface="Calibri"/>
-              </a:rPr>
-              <a:t>?
+              <a:t>¿Preguntas o Comentarios?
 </a:t>
             </a:r>
-            <a:endParaRPr sz="1400" b="0" i="0" u="none" strike="noStrike" cap="none" dirty="0">
+            <a:endParaRPr lang="es-MX" sz="1400" b="0" i="0" u="none" strike="noStrike" cap="none" noProof="0" dirty="0">
               <a:solidFill>
                 <a:srgbClr val="000000"/>
               </a:solidFill>
@@ -19297,7 +19229,7 @@
           <a:p>
             <a:pPr algn="r"/>
             <a:r>
-              <a:rPr sz="4400" b="0" i="0">
+              <a:rPr lang="es-MX" sz="4400" b="0" i="0" noProof="0" dirty="0">
                 <a:solidFill>
                   <a:srgbClr val="76923C"/>
                 </a:solidFill>
@@ -19305,7 +19237,7 @@
               </a:rPr>
               <a:t>Agenda</a:t>
             </a:r>
-            <a:endParaRPr sz="1400" b="0" i="0" u="none" strike="noStrike" cap="none">
+            <a:endParaRPr lang="es-MX" sz="1400" b="0" i="0" u="none" strike="noStrike" cap="none" noProof="0" dirty="0">
               <a:solidFill>
                 <a:srgbClr val="000000"/>
               </a:solidFill>
@@ -19342,21 +19274,22 @@
           </a:bodyPr>
           <a:lstStyle/>
           <a:p>
-            <a:pPr>
-              <a:spcAft>
-                <a:spcPts val="500"/>
-              </a:spcAft>
+            <a:pPr algn="l">
+              <a:lnSpc>
+                <a:spcPct val="120000"/>
+              </a:lnSpc>
+              <a:defRPr sz="1400" b="0" i="0">
+                <a:solidFill>
+                  <a:srgbClr val="1F2937"/>
+                </a:solidFill>
+                <a:latin typeface="Arial"/>
+              </a:defRPr>
             </a:pPr>
             <a:r>
-              <a:rPr sz="1600" b="1" i="0">
-                <a:solidFill>
-                  <a:srgbClr val="000000"/>
-                </a:solidFill>
-                <a:latin typeface="Arial"/>
-              </a:rPr>
+              <a:rPr lang="es-MX" noProof="0" dirty="0"/>
               <a:t>1. Empresa (Ubicación Geográfica y Organigrama)</a:t>
             </a:r>
-            <a:endParaRPr sz="1400" b="0" i="0" u="none" strike="noStrike" cap="none">
+            <a:endParaRPr lang="es-MX" sz="1400" b="0" i="0" u="none" strike="noStrike" cap="none" noProof="0" dirty="0">
               <a:solidFill>
                 <a:srgbClr val="000000"/>
               </a:solidFill>
@@ -19367,146 +19300,209 @@
             </a:endParaRPr>
           </a:p>
           <a:p>
-            <a:pPr>
-              <a:spcAft>
-                <a:spcPts val="500"/>
-              </a:spcAft>
+            <a:pPr algn="l">
+              <a:lnSpc>
+                <a:spcPct val="120000"/>
+              </a:lnSpc>
+              <a:spcBef>
+                <a:spcPts val="0"/>
+              </a:spcBef>
+              <a:spcAft>
+                <a:spcPts val="400"/>
+              </a:spcAft>
+              <a:defRPr sz="1400" b="0" i="0">
+                <a:solidFill>
+                  <a:srgbClr val="1F2937"/>
+                </a:solidFill>
+                <a:latin typeface="Arial"/>
+              </a:defRPr>
             </a:pPr>
             <a:r>
-              <a:rPr sz="1600" b="1" i="0">
-                <a:solidFill>
-                  <a:srgbClr val="000000"/>
-                </a:solidFill>
-                <a:latin typeface="Arial"/>
-              </a:rPr>
+              <a:rPr lang="es-MX" noProof="0" dirty="0"/>
               <a:t>2. Introducción al Proyecto</a:t>
             </a:r>
           </a:p>
           <a:p>
-            <a:pPr>
-              <a:spcAft>
-                <a:spcPts val="500"/>
-              </a:spcAft>
+            <a:pPr algn="l">
+              <a:lnSpc>
+                <a:spcPct val="120000"/>
+              </a:lnSpc>
+              <a:spcBef>
+                <a:spcPts val="0"/>
+              </a:spcBef>
+              <a:spcAft>
+                <a:spcPts val="400"/>
+              </a:spcAft>
+              <a:defRPr sz="1400" b="0" i="0">
+                <a:solidFill>
+                  <a:srgbClr val="1F2937"/>
+                </a:solidFill>
+                <a:latin typeface="Arial"/>
+              </a:defRPr>
             </a:pPr>
             <a:r>
-              <a:rPr sz="1600" b="1" i="0">
-                <a:solidFill>
-                  <a:srgbClr val="000000"/>
-                </a:solidFill>
-                <a:latin typeface="Arial"/>
-              </a:rPr>
-              <a:t>3. Planteamiento del Problema y Pregunta Generadora</a:t>
+              <a:rPr lang="es-MX" noProof="0" dirty="0"/>
+              <a:t>3. Planteamiento del Problema y Pregunta de Investigación</a:t>
             </a:r>
           </a:p>
           <a:p>
-            <a:pPr>
-              <a:spcAft>
-                <a:spcPts val="500"/>
-              </a:spcAft>
+            <a:pPr algn="l">
+              <a:lnSpc>
+                <a:spcPct val="120000"/>
+              </a:lnSpc>
+              <a:spcBef>
+                <a:spcPts val="0"/>
+              </a:spcBef>
+              <a:spcAft>
+                <a:spcPts val="400"/>
+              </a:spcAft>
+              <a:defRPr sz="1400" b="0" i="0">
+                <a:solidFill>
+                  <a:srgbClr val="1F2937"/>
+                </a:solidFill>
+                <a:latin typeface="Arial"/>
+              </a:defRPr>
             </a:pPr>
             <a:r>
-              <a:rPr sz="1600" b="1" i="0">
-                <a:solidFill>
-                  <a:srgbClr val="000000"/>
-                </a:solidFill>
-                <a:latin typeface="Arial"/>
-              </a:rPr>
+              <a:rPr lang="es-MX" noProof="0" dirty="0"/>
               <a:t>4. Justificación Técnica y Operativa</a:t>
             </a:r>
           </a:p>
           <a:p>
-            <a:pPr>
-              <a:spcAft>
-                <a:spcPts val="500"/>
-              </a:spcAft>
+            <a:pPr algn="l">
+              <a:lnSpc>
+                <a:spcPct val="120000"/>
+              </a:lnSpc>
+              <a:spcBef>
+                <a:spcPts val="0"/>
+              </a:spcBef>
+              <a:spcAft>
+                <a:spcPts val="400"/>
+              </a:spcAft>
+              <a:defRPr sz="1400" b="0" i="0">
+                <a:solidFill>
+                  <a:srgbClr val="1F2937"/>
+                </a:solidFill>
+                <a:latin typeface="Arial"/>
+              </a:defRPr>
             </a:pPr>
             <a:r>
-              <a:rPr sz="1600" b="1" i="0">
-                <a:solidFill>
-                  <a:srgbClr val="000000"/>
-                </a:solidFill>
-                <a:latin typeface="Arial"/>
-              </a:rPr>
+              <a:rPr lang="es-MX" noProof="0" dirty="0"/>
               <a:t>5. Objetivos del Proyecto (General y Específicos)</a:t>
             </a:r>
           </a:p>
           <a:p>
-            <a:pPr>
-              <a:spcAft>
-                <a:spcPts val="500"/>
-              </a:spcAft>
+            <a:pPr algn="l">
+              <a:lnSpc>
+                <a:spcPct val="120000"/>
+              </a:lnSpc>
+              <a:spcBef>
+                <a:spcPts val="0"/>
+              </a:spcBef>
+              <a:spcAft>
+                <a:spcPts val="400"/>
+              </a:spcAft>
+              <a:defRPr sz="1400" b="0" i="0">
+                <a:solidFill>
+                  <a:srgbClr val="1F2937"/>
+                </a:solidFill>
+                <a:latin typeface="Arial"/>
+              </a:defRPr>
             </a:pPr>
             <a:r>
-              <a:rPr sz="1600" b="1" i="0">
-                <a:solidFill>
-                  <a:srgbClr val="000000"/>
-                </a:solidFill>
-                <a:latin typeface="Arial"/>
-              </a:rPr>
+              <a:rPr lang="es-MX" noProof="0" dirty="0"/>
               <a:t>6. Herramientas Tecnológicas (Stack de Software)</a:t>
             </a:r>
           </a:p>
           <a:p>
-            <a:pPr>
-              <a:spcAft>
-                <a:spcPts val="500"/>
-              </a:spcAft>
+            <a:pPr algn="l">
+              <a:lnSpc>
+                <a:spcPct val="120000"/>
+              </a:lnSpc>
+              <a:spcBef>
+                <a:spcPts val="0"/>
+              </a:spcBef>
+              <a:spcAft>
+                <a:spcPts val="400"/>
+              </a:spcAft>
+              <a:defRPr sz="1400" b="0" i="0">
+                <a:solidFill>
+                  <a:srgbClr val="1F2937"/>
+                </a:solidFill>
+                <a:latin typeface="Arial"/>
+              </a:defRPr>
             </a:pPr>
             <a:r>
-              <a:rPr sz="1600" b="1" i="0">
-                <a:solidFill>
-                  <a:srgbClr val="000000"/>
-                </a:solidFill>
-                <a:latin typeface="Arial"/>
-              </a:rPr>
+              <a:rPr lang="es-MX" noProof="0" dirty="0"/>
               <a:t>7. Evidencias de Avance Técnico</a:t>
             </a:r>
           </a:p>
           <a:p>
-            <a:pPr>
-              <a:spcAft>
-                <a:spcPts val="500"/>
-              </a:spcAft>
+            <a:pPr algn="l">
+              <a:lnSpc>
+                <a:spcPct val="120000"/>
+              </a:lnSpc>
+              <a:spcBef>
+                <a:spcPts val="0"/>
+              </a:spcBef>
+              <a:spcAft>
+                <a:spcPts val="400"/>
+              </a:spcAft>
+              <a:defRPr sz="1400" b="0" i="0">
+                <a:solidFill>
+                  <a:srgbClr val="1F2937"/>
+                </a:solidFill>
+                <a:latin typeface="Arial"/>
+              </a:defRPr>
             </a:pPr>
             <a:r>
-              <a:rPr sz="1600" b="1" i="0">
-                <a:solidFill>
-                  <a:srgbClr val="000000"/>
-                </a:solidFill>
-                <a:latin typeface="Arial"/>
-              </a:rPr>
+              <a:rPr lang="es-MX" noProof="0" dirty="0"/>
               <a:t>8. Cronograma de Actividades</a:t>
             </a:r>
           </a:p>
           <a:p>
-            <a:pPr>
-              <a:spcAft>
-                <a:spcPts val="500"/>
-              </a:spcAft>
+            <a:pPr algn="l">
+              <a:lnSpc>
+                <a:spcPct val="120000"/>
+              </a:lnSpc>
+              <a:spcBef>
+                <a:spcPts val="0"/>
+              </a:spcBef>
+              <a:spcAft>
+                <a:spcPts val="400"/>
+              </a:spcAft>
+              <a:defRPr sz="1400" b="0" i="0">
+                <a:solidFill>
+                  <a:srgbClr val="1F2937"/>
+                </a:solidFill>
+                <a:latin typeface="Arial"/>
+              </a:defRPr>
             </a:pPr>
             <a:r>
-              <a:rPr sz="1600" b="1" i="0">
-                <a:solidFill>
-                  <a:srgbClr val="000000"/>
-                </a:solidFill>
-                <a:latin typeface="Arial"/>
-              </a:rPr>
+              <a:rPr lang="es-MX" noProof="0" dirty="0"/>
               <a:t>9. Conclusiones Preliminares (Avance)</a:t>
             </a:r>
           </a:p>
           <a:p>
-            <a:pPr>
-              <a:spcAft>
-                <a:spcPts val="500"/>
-              </a:spcAft>
+            <a:pPr algn="l">
+              <a:lnSpc>
+                <a:spcPct val="120000"/>
+              </a:lnSpc>
+              <a:spcBef>
+                <a:spcPts val="0"/>
+              </a:spcBef>
+              <a:spcAft>
+                <a:spcPts val="400"/>
+              </a:spcAft>
+              <a:defRPr sz="1400" b="0" i="0">
+                <a:solidFill>
+                  <a:srgbClr val="1F2937"/>
+                </a:solidFill>
+                <a:latin typeface="Arial"/>
+              </a:defRPr>
             </a:pPr>
             <a:r>
-              <a:rPr sz="1600" b="1" i="0">
-                <a:solidFill>
-                  <a:srgbClr val="000000"/>
-                </a:solidFill>
-                <a:latin typeface="Arial"/>
-              </a:rPr>
+              <a:rPr lang="es-MX" noProof="0" dirty="0"/>
               <a:t>10. Bibliografía y Referencias</a:t>
             </a:r>
           </a:p>
@@ -19546,7 +19542,7 @@
           <a:lstStyle/>
           <a:p>
             <a:r>
-              <a:rPr sz="1600" b="0" i="0">
+              <a:rPr lang="es-MX" sz="1600" b="0" i="0" noProof="0" dirty="0">
                 <a:solidFill>
                   <a:srgbClr val="76923C"/>
                 </a:solidFill>
@@ -19554,7 +19550,7 @@
               </a:rPr>
               <a:t>2/15</a:t>
             </a:r>
-            <a:endParaRPr sz="1400" b="0" i="0" u="none" strike="noStrike" cap="none">
+            <a:endParaRPr lang="es-MX" sz="1400" b="0" i="0" u="none" strike="noStrike" cap="none" noProof="0" dirty="0">
               <a:solidFill>
                 <a:srgbClr val="000000"/>
               </a:solidFill>
@@ -19616,53 +19612,26 @@
         </p:spPr>
         <p:txBody>
           <a:bodyPr spcFirstLastPara="1" wrap="square" lIns="91425" tIns="45700" rIns="91425" bIns="45700" anchor="t" anchorCtr="0">
-            <a:normAutofit/>
+            <a:normAutofit fontScale="92500" lnSpcReduction="10000"/>
           </a:bodyPr>
           <a:lstStyle/>
           <a:p>
-            <a:pPr>
-              <a:spcAft>
-                <a:spcPts val="400"/>
-              </a:spcAft>
+            <a:pPr marL="114300" indent="0" algn="l">
+              <a:lnSpc>
+                <a:spcPct val="130000"/>
+              </a:lnSpc>
+              <a:buNone/>
+              <a:defRPr sz="1500" b="0" i="0">
+                <a:solidFill>
+                  <a:srgbClr val="1F2937"/>
+                </a:solidFill>
+                <a:latin typeface="Arial"/>
+              </a:defRPr>
             </a:pPr>
             <a:r>
-              <a:rPr sz="1500" b="1" i="0">
-                <a:solidFill>
-                  <a:srgbClr val="000000"/>
-                </a:solidFill>
-                <a:latin typeface="Arial"/>
-              </a:rPr>
-              <a:t>• GPON TELECOM S.A. de C.V.: </a:t>
+              <a:rPr lang="es-MX" noProof="0" dirty="0"/>
+              <a:t>GPON TELECOM S.A. de C.V. es una empresa proveedora de servicios de telecomunicaciones e Internet de alta velocidad mediante fibra óptica y antena, ubicada en Ejido San José del Rincón, Estado de México, cuya misión operativa se enfoca en brindar conectividad digital confiable a comunidades urbanas y rurales mediante infraestructura pasiva GPON de última generación.</a:t>
             </a:r>
-            <a:r>
-              <a:rPr sz="1500" b="0" i="0">
-                <a:solidFill>
-                  <a:srgbClr val="000000"/>
-                </a:solidFill>
-                <a:latin typeface="Arial"/>
-              </a:rPr>
-              <a:t>Empresa proveedora de servicios de telecomunicaciones e Internet de alta velocidad mediante fibra óptica (ISP regional).
-</a:t>
-            </a:r>
-            <a:r>
-              <a:rPr sz="1500" b="1" i="0">
-                <a:solidFill>
-                  <a:srgbClr val="000000"/>
-                </a:solidFill>
-                <a:latin typeface="Arial"/>
-              </a:rPr>
-              <a:t>• Ubicación Geográfica: </a:t>
-            </a:r>
-            <a:r>
-              <a:rPr sz="1500" b="0" i="0">
-                <a:solidFill>
-                  <a:srgbClr val="000000"/>
-                </a:solidFill>
-                <a:latin typeface="Arial"/>
-              </a:rPr>
-              <a:t>Sede operativa y nodo central (NOC) en San José del Rincón, Estado de México, abasteciendo conectividad GPON/FTTx urbana y rural.</a:t>
-            </a:r>
-            <a:endParaRPr/>
           </a:p>
         </p:txBody>
       </p:sp>
@@ -19728,7 +19697,7 @@
           <a:p>
             <a:pPr algn="r"/>
             <a:r>
-              <a:rPr sz="4400" b="0" i="0">
+              <a:rPr lang="es-MX" sz="4400" b="0" i="0" noProof="0" dirty="0">
                 <a:solidFill>
                   <a:srgbClr val="76923C"/>
                 </a:solidFill>
@@ -19736,7 +19705,7 @@
               </a:rPr>
               <a:t>Empresa</a:t>
             </a:r>
-            <a:endParaRPr sz="3500" b="0" i="0" u="none" strike="noStrike" cap="none">
+            <a:endParaRPr lang="es-MX" sz="3500" b="0" i="0" u="none" strike="noStrike" cap="none" noProof="0" dirty="0">
               <a:solidFill>
                 <a:srgbClr val="76923C"/>
               </a:solidFill>
@@ -19782,7 +19751,7 @@
           <a:lstStyle/>
           <a:p>
             <a:r>
-              <a:rPr sz="1600" b="0" i="0">
+              <a:rPr lang="es-MX" sz="1600" b="0" i="0" noProof="0" dirty="0">
                 <a:solidFill>
                   <a:srgbClr val="76923C"/>
                 </a:solidFill>
@@ -19790,7 +19759,7 @@
               </a:rPr>
               <a:t>3/15</a:t>
             </a:r>
-            <a:endParaRPr sz="1400" b="0" i="0" u="none" strike="noStrike" cap="none">
+            <a:endParaRPr lang="es-MX" sz="1400" b="0" i="0" u="none" strike="noStrike" cap="none" noProof="0" dirty="0">
               <a:solidFill>
                 <a:srgbClr val="000000"/>
               </a:solidFill>
@@ -19835,53 +19804,6 @@
           </a:ln>
         </p:spPr>
       </p:pic>
-      <p:sp>
-        <p:nvSpPr>
-          <p:cNvPr id="111" name="Google Shape;111;p3"/>
-          <p:cNvSpPr txBox="1"/>
-          <p:nvPr/>
-        </p:nvSpPr>
-        <p:spPr>
-          <a:xfrm>
-            <a:off x="731520" y="4892040"/>
-            <a:ext cx="7680960" cy="307777"/>
-          </a:xfrm>
-          <a:prstGeom prst="rect">
-            <a:avLst/>
-          </a:prstGeom>
-          <a:noFill/>
-          <a:ln>
-            <a:noFill/>
-          </a:ln>
-        </p:spPr>
-        <p:txBody>
-          <a:bodyPr spcFirstLastPara="1" wrap="square" lIns="91425" tIns="45700" rIns="91425" bIns="45700" anchor="t" anchorCtr="0">
-            <a:spAutoFit/>
-          </a:bodyPr>
-          <a:lstStyle/>
-          <a:p>
-            <a:pPr algn="ctr"/>
-            <a:r>
-              <a:rPr sz="1400" b="0" i="0">
-                <a:solidFill>
-                  <a:srgbClr val="505050"/>
-                </a:solidFill>
-                <a:latin typeface="Calibri"/>
-              </a:rPr>
-              <a:t>Figura 1. Localización geográfica de la empresa GPON TELECOM S.A. de C.V.</a:t>
-            </a:r>
-            <a:endParaRPr sz="1400" b="0" i="0" u="none" strike="noStrike" cap="none">
-              <a:solidFill>
-                <a:srgbClr val="000000"/>
-              </a:solidFill>
-              <a:latin typeface="Arial"/>
-              <a:ea typeface="Arial"/>
-              <a:cs typeface="Arial"/>
-              <a:sym typeface="Arial"/>
-            </a:endParaRPr>
-          </a:p>
-        </p:txBody>
-      </p:sp>
     </p:spTree>
   </p:cSld>
   <p:clrMapOvr>
@@ -19969,7 +19891,7 @@
           <a:p>
             <a:pPr algn="r"/>
             <a:r>
-              <a:rPr sz="4400" b="0" i="0">
+              <a:rPr lang="es-MX" sz="4400" b="0" i="0" noProof="0" dirty="0">
                 <a:solidFill>
                   <a:srgbClr val="76923C"/>
                 </a:solidFill>
@@ -19977,7 +19899,7 @@
               </a:rPr>
               <a:t>Empresa</a:t>
             </a:r>
-            <a:endParaRPr sz="3500" b="0" i="0" u="none" strike="noStrike" cap="none">
+            <a:endParaRPr lang="es-MX" sz="3500" b="0" i="0" u="none" strike="noStrike" cap="none" noProof="0" dirty="0">
               <a:solidFill>
                 <a:srgbClr val="76923C"/>
               </a:solidFill>
@@ -20023,7 +19945,7 @@
           <a:lstStyle/>
           <a:p>
             <a:r>
-              <a:rPr sz="1600" b="0" i="0">
+              <a:rPr lang="es-MX" sz="1600" b="0" i="0" noProof="0" dirty="0">
                 <a:solidFill>
                   <a:srgbClr val="76923C"/>
                 </a:solidFill>
@@ -20031,7 +19953,7 @@
               </a:rPr>
               <a:t>4/15</a:t>
             </a:r>
-            <a:endParaRPr sz="1400" b="0" i="0" u="none" strike="noStrike" cap="none">
+            <a:endParaRPr lang="es-MX" sz="1400" b="0" i="0" u="none" strike="noStrike" cap="none" noProof="0" dirty="0">
               <a:solidFill>
                 <a:srgbClr val="000000"/>
               </a:solidFill>
@@ -20074,53 +19996,6 @@
           </a:ln>
         </p:spPr>
       </p:pic>
-      <p:sp>
-        <p:nvSpPr>
-          <p:cNvPr id="121" name="Google Shape;121;p4"/>
-          <p:cNvSpPr txBox="1"/>
-          <p:nvPr/>
-        </p:nvSpPr>
-        <p:spPr>
-          <a:xfrm>
-            <a:off x="731520" y="4956048"/>
-            <a:ext cx="7680960" cy="369332"/>
-          </a:xfrm>
-          <a:prstGeom prst="rect">
-            <a:avLst/>
-          </a:prstGeom>
-          <a:noFill/>
-          <a:ln>
-            <a:noFill/>
-          </a:ln>
-        </p:spPr>
-        <p:txBody>
-          <a:bodyPr spcFirstLastPara="1" wrap="square" lIns="91425" tIns="45700" rIns="91425" bIns="45700" anchor="t" anchorCtr="0">
-            <a:spAutoFit/>
-          </a:bodyPr>
-          <a:lstStyle/>
-          <a:p>
-            <a:pPr algn="ctr"/>
-            <a:r>
-              <a:rPr sz="1400" b="0" i="0">
-                <a:solidFill>
-                  <a:srgbClr val="505050"/>
-                </a:solidFill>
-                <a:latin typeface="Calibri"/>
-              </a:rPr>
-              <a:t>Figura 2. Organigrama de la empresa GPON TELECOM S.A. de C.V.</a:t>
-            </a:r>
-            <a:endParaRPr sz="1400" b="0" i="0" u="none" strike="noStrike" cap="none">
-              <a:solidFill>
-                <a:srgbClr val="000000"/>
-              </a:solidFill>
-              <a:latin typeface="Arial"/>
-              <a:ea typeface="Arial"/>
-              <a:cs typeface="Arial"/>
-              <a:sym typeface="Arial"/>
-            </a:endParaRPr>
-          </a:p>
-        </p:txBody>
-      </p:sp>
     </p:spTree>
   </p:cSld>
   <p:clrMapOvr>
@@ -20161,7 +20036,7 @@
         </p:blipFill>
         <p:spPr>
           <a:xfrm>
-            <a:off x="0" y="4286256"/>
+            <a:off x="0" y="4260498"/>
             <a:ext cx="9144000" cy="2571744"/>
           </a:xfrm>
           <a:prstGeom prst="rect">
@@ -20182,7 +20057,7 @@
         <p:spPr>
           <a:xfrm>
             <a:off x="731520" y="1005840"/>
-            <a:ext cx="7680960" cy="3474720"/>
+            <a:ext cx="7680960" cy="1778652"/>
           </a:xfrm>
           <a:prstGeom prst="rect">
             <a:avLst/>
@@ -20198,30 +20073,36 @@
           </a:bodyPr>
           <a:lstStyle/>
           <a:p>
-            <a:pPr>
-              <a:spcAft>
-                <a:spcPts val="600"/>
-              </a:spcAft>
+            <a:pPr algn="l">
+              <a:lnSpc>
+                <a:spcPct val="135000"/>
+              </a:lnSpc>
+              <a:spcBef>
+                <a:spcPts val="0"/>
+              </a:spcBef>
+              <a:spcAft>
+                <a:spcPts val="1000"/>
+              </a:spcAft>
+              <a:defRPr sz="1500" b="0" i="0">
+                <a:solidFill>
+                  <a:srgbClr val="1F2937"/>
+                </a:solidFill>
+                <a:latin typeface="Arial"/>
+              </a:defRPr>
             </a:pPr>
             <a:r>
-              <a:rPr sz="1500" b="1" i="0">
-                <a:solidFill>
-                  <a:srgbClr val="000000"/>
-                </a:solidFill>
-                <a:latin typeface="Arial"/>
-              </a:rPr>
-              <a:t>• Propósito General: </a:t>
+              <a:rPr lang="es-MX" noProof="0" dirty="0"/>
+              <a:t>El presente proyecto de residencia comprende el desarrollo de una plataforma web integral para el inventario centralizado y mapeo geoespacial de la red de fibra óptica GPON/</a:t>
             </a:r>
             <a:r>
-              <a:rPr sz="1500" b="0" i="0">
-                <a:solidFill>
-                  <a:srgbClr val="000000"/>
-                </a:solidFill>
-                <a:latin typeface="Arial"/>
-              </a:rPr>
-              <a:t>Desarrollo de una plataforma web para el inventario centralizado y mapeo lógico de la red de fibra óptica GPON/FTTx en GPON TELECOM S.A. de C.V.</a:t>
+              <a:rPr lang="es-MX" noProof="0" dirty="0" err="1"/>
+              <a:t>FTTx</a:t>
             </a:r>
-            <a:endParaRPr sz="2400" b="0" i="0" u="none" strike="noStrike" cap="none">
+            <a:r>
+              <a:rPr lang="es-MX" noProof="0" dirty="0"/>
+              <a:t> de la empresa GPON TELECOM S.A. de C.V. Su propósito fundamental es modernizar y reemplazar la gestión manual desarticulada en campo, previniendo colisiones en la asignación de puertos y saturación imprevista en cajas NAP.</a:t>
+            </a:r>
+            <a:endParaRPr lang="es-MX" sz="2400" b="0" i="0" u="none" strike="noStrike" cap="none" noProof="0" dirty="0">
               <a:solidFill>
                 <a:schemeClr val="dk1"/>
               </a:solidFill>
@@ -20230,81 +20111,6 @@
               <a:cs typeface="Tahoma"/>
               <a:sym typeface="Tahoma"/>
             </a:endParaRPr>
-          </a:p>
-          <a:p>
-            <a:pPr>
-              <a:spcAft>
-                <a:spcPts val="600"/>
-              </a:spcAft>
-            </a:pPr>
-            <a:r>
-              <a:rPr sz="1500" b="1" i="0">
-                <a:solidFill>
-                  <a:srgbClr val="000000"/>
-                </a:solidFill>
-                <a:latin typeface="Arial"/>
-              </a:rPr>
-              <a:t>• Problemática Atendida: </a:t>
-            </a:r>
-            <a:r>
-              <a:rPr sz="1500" b="0" i="0">
-                <a:solidFill>
-                  <a:srgbClr val="000000"/>
-                </a:solidFill>
-                <a:latin typeface="Arial"/>
-              </a:rPr>
-              <a:t>Reemplazar la gestión manual y desarticulada en campo, previniendo la colisión de puertos y la saturación imprevista en cajas NAP.</a:t>
-            </a:r>
-          </a:p>
-          <a:p>
-            <a:pPr>
-              <a:spcAft>
-                <a:spcPts val="600"/>
-              </a:spcAft>
-            </a:pPr>
-            <a:r>
-              <a:rPr sz="1500" b="1" i="0">
-                <a:solidFill>
-                  <a:srgbClr val="000000"/>
-                </a:solidFill>
-                <a:latin typeface="Arial"/>
-              </a:rPr>
-              <a:t>• Arquitectura Desacoplada: </a:t>
-            </a:r>
-            <a:r>
-              <a:rPr sz="1500" b="0" i="0">
-                <a:solidFill>
-                  <a:srgbClr val="000000"/>
-                </a:solidFill>
-                <a:latin typeface="Arial"/>
-              </a:rPr>
-              <a:t>Integración de visor cartográfico geoespacial (React 18 + Leaflet), backend seguro (Node.js + Express) y base de datos relacional (PostgreSQL 16).</a:t>
-            </a:r>
-          </a:p>
-          <a:p>
-            <a:pPr>
-              <a:spcAft>
-                <a:spcPts val="600"/>
-              </a:spcAft>
-            </a:pPr>
-            <a:r>
-              <a:rPr sz="1500" b="1" i="0">
-                <a:solidFill>
-                  <a:srgbClr val="000000"/>
-                </a:solidFill>
-                <a:latin typeface="Arial"/>
-              </a:rPr>
-              <a:t>• Resiliencia Operativa: </a:t>
-            </a:r>
-            <a:r>
-              <a:rPr sz="1500" b="0" i="0">
-                <a:solidFill>
-                  <a:srgbClr val="000000"/>
-                </a:solidFill>
-                <a:latin typeface="Arial"/>
-              </a:rPr>
-              <a:t>Modelo Offline-First (IndexedDB con Dexie.js) que faculta a los técnicos para continuar registrando operaciones en zonas sin cobertura móvil.</a:t>
-            </a:r>
           </a:p>
         </p:txBody>
       </p:sp>
@@ -20343,7 +20149,7 @@
           <a:p>
             <a:pPr algn="r"/>
             <a:r>
-              <a:rPr sz="4400" b="0" i="0">
+              <a:rPr lang="es-MX" sz="4400" b="0" i="0" noProof="0" dirty="0">
                 <a:solidFill>
                   <a:srgbClr val="76923C"/>
                 </a:solidFill>
@@ -20351,7 +20157,7 @@
               </a:rPr>
               <a:t>Introducción</a:t>
             </a:r>
-            <a:endParaRPr sz="3500" b="0" i="0" u="none" strike="noStrike" cap="none">
+            <a:endParaRPr lang="es-MX" sz="3500" b="0" i="0" u="none" strike="noStrike" cap="none" noProof="0" dirty="0">
               <a:solidFill>
                 <a:srgbClr val="76923C"/>
               </a:solidFill>
@@ -20397,7 +20203,7 @@
           <a:lstStyle/>
           <a:p>
             <a:r>
-              <a:rPr sz="1600" b="0" i="0">
+              <a:rPr lang="es-MX" sz="1600" b="0" i="0" noProof="0" dirty="0">
                 <a:solidFill>
                   <a:srgbClr val="76923C"/>
                 </a:solidFill>
@@ -20405,7 +20211,7 @@
               </a:rPr>
               <a:t>5/15</a:t>
             </a:r>
-            <a:endParaRPr sz="1400" b="0" i="0" u="none" strike="noStrike" cap="none">
+            <a:endParaRPr lang="es-MX" sz="1400" b="0" i="0" u="none" strike="noStrike" cap="none" noProof="0" dirty="0">
               <a:solidFill>
                 <a:srgbClr val="000000"/>
               </a:solidFill>
@@ -20478,7 +20284,7 @@
         <p:spPr>
           <a:xfrm>
             <a:off x="731520" y="960120"/>
-            <a:ext cx="7680960" cy="3566160"/>
+            <a:ext cx="7680960" cy="3568629"/>
           </a:xfrm>
           <a:prstGeom prst="rect">
             <a:avLst/>
@@ -20494,30 +20300,28 @@
           </a:bodyPr>
           <a:lstStyle/>
           <a:p>
-            <a:pPr>
-              <a:spcAft>
-                <a:spcPts val="400"/>
-              </a:spcAft>
+            <a:pPr algn="l">
+              <a:lnSpc>
+                <a:spcPct val="130000"/>
+              </a:lnSpc>
+              <a:spcBef>
+                <a:spcPts val="0"/>
+              </a:spcBef>
+              <a:spcAft>
+                <a:spcPts val="1200"/>
+              </a:spcAft>
+              <a:defRPr sz="1450" b="0" i="0">
+                <a:solidFill>
+                  <a:srgbClr val="1F2937"/>
+                </a:solidFill>
+                <a:latin typeface="Arial"/>
+              </a:defRPr>
             </a:pPr>
             <a:r>
-              <a:rPr sz="1450" b="1" i="0">
-                <a:solidFill>
-                  <a:srgbClr val="000000"/>
-                </a:solidFill>
-                <a:latin typeface="Arial"/>
-              </a:rPr>
-              <a:t>• Carencia de Inventario Centralizado: </a:t>
+              <a:rPr lang="es-MX" noProof="0" dirty="0"/>
+              <a:t>Actualmente, la empresa GPON TELECOM S.A. de C.V. enfrenta severas dificultades operativas derivadas de la gestión manual y desarticulada en el inventario de su red de fibra óptica pasiva. La carencia de un registro digital centralizado provoca frecuentes colisiones por asignación concurrente de puertos entre cuadrillas de campo y personal de NOC, saturación inadvertida en cajas terminales NAP y demoras críticas en la provisión de nuevos suscriptores, dificultando la supervisión técnica y la toma de decisiones sobre la infraestructura de telecomunicaciones.</a:t>
             </a:r>
-            <a:r>
-              <a:rPr sz="1450" b="0" i="0">
-                <a:solidFill>
-                  <a:srgbClr val="000000"/>
-                </a:solidFill>
-                <a:latin typeface="Arial"/>
-              </a:rPr>
-              <a:t>Falta de control físico y lógico de splitters, cajas NAP y puertos SC-APC, provocando retrasos en la atención de nuevas altas.</a:t>
-            </a:r>
-            <a:endParaRPr sz="1400" b="0" i="0" u="none" strike="noStrike" cap="none">
+            <a:endParaRPr lang="es-MX" sz="1400" b="0" i="0" u="none" strike="noStrike" cap="none" noProof="0" dirty="0">
               <a:solidFill>
                 <a:srgbClr val="000000"/>
               </a:solidFill>
@@ -20528,93 +20332,100 @@
             </a:endParaRPr>
           </a:p>
           <a:p>
-            <a:pPr>
+            <a:pPr algn="l">
+              <a:lnSpc>
+                <a:spcPct val="120000"/>
+              </a:lnSpc>
+              <a:spcBef>
+                <a:spcPts val="0"/>
+              </a:spcBef>
               <a:spcAft>
                 <a:spcPts val="400"/>
               </a:spcAft>
+              <a:defRPr sz="1450" b="1" i="0">
+                <a:solidFill>
+                  <a:srgbClr val="111827"/>
+                </a:solidFill>
+                <a:latin typeface="Arial"/>
+              </a:defRPr>
             </a:pPr>
             <a:r>
-              <a:rPr sz="1450" b="1" i="0">
-                <a:solidFill>
-                  <a:srgbClr val="000000"/>
-                </a:solidFill>
-                <a:latin typeface="Arial"/>
+              <a:rPr lang="es-MX" noProof="0" dirty="0">
+                <a:solidFill>
+                  <a:schemeClr val="tx1"/>
+                </a:solidFill>
               </a:rPr>
-              <a:t>• Colisión por Asignación Concurrente: </a:t>
+              <a:t>Pregunta </a:t>
             </a:r>
             <a:r>
-              <a:rPr sz="1450" b="0" i="0">
-                <a:solidFill>
-                  <a:srgbClr val="000000"/>
-                </a:solidFill>
-                <a:latin typeface="Arial"/>
+              <a:rPr lang="es-MX" dirty="0">
+                <a:solidFill>
+                  <a:schemeClr val="tx1"/>
+                </a:solidFill>
               </a:rPr>
-              <a:t>La asignación simultánea y manual de puertos por diferentes técnicos genera conflictos de servicio y saturación invisible para el NOC.</a:t>
+              <a:t>generadora</a:t>
+            </a:r>
+            <a:r>
+              <a:rPr lang="es-MX" noProof="0" dirty="0">
+                <a:solidFill>
+                  <a:schemeClr val="tx1"/>
+                </a:solidFill>
+              </a:rPr>
+              <a:t>:</a:t>
             </a:r>
           </a:p>
           <a:p>
             <a:pPr>
-              <a:spcAft>
-                <a:spcPts val="400"/>
-              </a:spcAft>
+              <a:lnSpc>
+                <a:spcPct val="130000"/>
+              </a:lnSpc>
+              <a:spcAft>
+                <a:spcPts val="800"/>
+              </a:spcAft>
+              <a:defRPr sz="1450" b="0" i="1">
+                <a:solidFill>
+                  <a:srgbClr val="1F2937"/>
+                </a:solidFill>
+                <a:latin typeface="Arial"/>
+              </a:defRPr>
             </a:pPr>
             <a:r>
-              <a:rPr sz="1450" b="1" i="0">
-                <a:solidFill>
-                  <a:srgbClr val="000000"/>
-                </a:solidFill>
-                <a:latin typeface="Arial"/>
+              <a:rPr lang="es-MX" b="1" noProof="0" dirty="0">
+                <a:solidFill>
+                  <a:schemeClr val="tx1"/>
+                </a:solidFill>
               </a:rPr>
-              <a:t>• Aislamiento en Campo: </a:t>
+              <a:t>¿El </a:t>
             </a:r>
             <a:r>
-              <a:rPr sz="1450" b="0" i="0">
-                <a:solidFill>
-                  <a:srgbClr val="000000"/>
-                </a:solidFill>
-                <a:latin typeface="Arial"/>
+              <a:rPr lang="es-MX" b="1" dirty="0">
+                <a:solidFill>
+                  <a:schemeClr val="tx1"/>
+                </a:solidFill>
               </a:rPr>
-              <a:t>Pérdida de conectividad celular en cuadrillas rurales, imposibilitando la consulta o actualización de la red en tiempo real.</a:t>
-            </a:r>
-          </a:p>
-          <a:p>
-            <a:pPr>
-              <a:spcBef>
-                <a:spcPts val="800"/>
-              </a:spcBef>
-              <a:spcAft>
-                <a:spcPts val="200"/>
-              </a:spcAft>
-            </a:pPr>
-            <a:r>
-              <a:rPr sz="1500" b="1" i="0">
-                <a:solidFill>
-                  <a:srgbClr val="76923C"/>
-                </a:solidFill>
-                <a:latin typeface="Arial"/>
-              </a:rPr>
-              <a:t>Pregunta Generadora:
-</a:t>
+              <a:t>desarrollo de un sistema web integral de inventario y mapeo lógico permitirá  modernizar la gestión operativa y optimizar la administración de la red de fibra óptica GPON/</a:t>
             </a:r>
             <a:r>
-              <a:rPr sz="1450" b="1" i="1">
-                <a:solidFill>
-                  <a:srgbClr val="000000"/>
-                </a:solidFill>
-                <a:latin typeface="Arial"/>
+              <a:rPr lang="es-MX" b="1" dirty="0" err="1">
+                <a:solidFill>
+                  <a:schemeClr val="tx1"/>
+                </a:solidFill>
               </a:rPr>
-              <a:t>“¿Es viable optimizar la gestión de inventario y la trazabilidad técnica de la red GPON/FTTx mediante una plataforma web georreferenciada con arquitectura Offline-First?”
-</a:t>
+              <a:t>FTTx</a:t>
             </a:r>
             <a:r>
-              <a:rPr sz="1700" b="1" i="0">
-                <a:solidFill>
-                  <a:srgbClr val="76923C"/>
-                </a:solidFill>
-                <a:latin typeface="Arial"/>
+              <a:rPr lang="es-MX" b="1" dirty="0">
+                <a:solidFill>
+                  <a:schemeClr val="tx1"/>
+                </a:solidFill>
               </a:rPr>
-              <a:t>Respuesta: Sí.</a:t>
+              <a:t> en la empresa GPON TELECOM S.A. de C.V.?</a:t>
             </a:r>
+            <a:endParaRPr lang="es-MX" b="1" noProof="0" dirty="0">
+              <a:solidFill>
+                <a:schemeClr val="tx1"/>
+              </a:solidFill>
+            </a:endParaRPr>
           </a:p>
         </p:txBody>
       </p:sp>
@@ -20653,7 +20464,7 @@
           <a:p>
             <a:pPr algn="r"/>
             <a:r>
-              <a:rPr sz="4400" b="0" i="0">
+              <a:rPr lang="es-MX" sz="4400" b="0" i="0" noProof="0" dirty="0">
                 <a:solidFill>
                   <a:srgbClr val="76923C"/>
                 </a:solidFill>
@@ -20661,7 +20472,7 @@
               </a:rPr>
               <a:t>Planteamiento del problema</a:t>
             </a:r>
-            <a:endParaRPr sz="3500" b="0" i="0" u="none" strike="noStrike" cap="none">
+            <a:endParaRPr lang="es-MX" sz="3500" b="0" i="0" u="none" strike="noStrike" cap="none" noProof="0" dirty="0">
               <a:solidFill>
                 <a:srgbClr val="76923C"/>
               </a:solidFill>
@@ -20707,7 +20518,7 @@
           <a:lstStyle/>
           <a:p>
             <a:r>
-              <a:rPr sz="1600" b="0" i="0">
+              <a:rPr lang="es-MX" sz="1600" b="0" i="0" noProof="0" dirty="0">
                 <a:solidFill>
                   <a:srgbClr val="76923C"/>
                 </a:solidFill>
@@ -20715,7 +20526,7 @@
               </a:rPr>
               <a:t>6/15</a:t>
             </a:r>
-            <a:endParaRPr sz="1400" b="0" i="0" u="none" strike="noStrike" cap="none">
+            <a:endParaRPr lang="es-MX" sz="1400" b="0" i="0" u="none" strike="noStrike" cap="none" noProof="0" dirty="0">
               <a:solidFill>
                 <a:srgbClr val="000000"/>
               </a:solidFill>
@@ -20814,7 +20625,7 @@
           <a:p>
             <a:pPr algn="r"/>
             <a:r>
-              <a:rPr sz="4400" b="0" i="0">
+              <a:rPr lang="es-MX" sz="4400" b="0" i="0" noProof="0" dirty="0">
                 <a:solidFill>
                   <a:srgbClr val="76923C"/>
                 </a:solidFill>
@@ -20822,7 +20633,7 @@
               </a:rPr>
               <a:t>Justificación</a:t>
             </a:r>
-            <a:endParaRPr sz="1400" b="0" i="0" u="none" strike="noStrike" cap="none">
+            <a:endParaRPr lang="es-MX" sz="1400" b="0" i="0" u="none" strike="noStrike" cap="none" noProof="0" dirty="0">
               <a:solidFill>
                 <a:srgbClr val="000000"/>
               </a:solidFill>
@@ -20868,7 +20679,7 @@
           <a:lstStyle/>
           <a:p>
             <a:r>
-              <a:rPr sz="1600" b="0" i="0">
+              <a:rPr lang="es-MX" sz="1600" b="0" i="0" noProof="0" dirty="0">
                 <a:solidFill>
                   <a:srgbClr val="76923C"/>
                 </a:solidFill>
@@ -20876,7 +20687,7 @@
               </a:rPr>
               <a:t>7/15</a:t>
             </a:r>
-            <a:endParaRPr sz="1400" b="0" i="0" u="none" strike="noStrike" cap="none">
+            <a:endParaRPr lang="es-MX" sz="1400" b="0" i="0" u="none" strike="noStrike" cap="none" noProof="0" dirty="0">
               <a:solidFill>
                 <a:srgbClr val="000000"/>
               </a:solidFill>
@@ -20897,7 +20708,7 @@
         <p:spPr>
           <a:xfrm>
             <a:off x="731520" y="1005840"/>
-            <a:ext cx="7680960" cy="3474720"/>
+            <a:ext cx="7680960" cy="2713523"/>
           </a:xfrm>
           <a:prstGeom prst="rect">
             <a:avLst/>
@@ -20913,30 +20724,36 @@
           </a:bodyPr>
           <a:lstStyle/>
           <a:p>
-            <a:pPr>
-              <a:spcAft>
-                <a:spcPts val="600"/>
-              </a:spcAft>
+            <a:pPr algn="l">
+              <a:lnSpc>
+                <a:spcPct val="135000"/>
+              </a:lnSpc>
+              <a:spcBef>
+                <a:spcPts val="0"/>
+              </a:spcBef>
+              <a:spcAft>
+                <a:spcPts val="1000"/>
+              </a:spcAft>
+              <a:defRPr sz="1500" b="0" i="0">
+                <a:solidFill>
+                  <a:srgbClr val="1F2937"/>
+                </a:solidFill>
+                <a:latin typeface="Arial"/>
+              </a:defRPr>
             </a:pPr>
             <a:r>
-              <a:rPr sz="1500" b="1" i="0">
-                <a:solidFill>
-                  <a:srgbClr val="000000"/>
-                </a:solidFill>
-                <a:latin typeface="Arial"/>
-              </a:rPr>
-              <a:t>• Eficiencia Operativa: </a:t>
+              <a:rPr lang="es-MX"/>
+              <a:t>El desarrollo</a:t>
             </a:r>
             <a:r>
-              <a:rPr sz="1500" b="0" i="0">
-                <a:solidFill>
-                  <a:srgbClr val="000000"/>
-                </a:solidFill>
-                <a:latin typeface="Arial"/>
-              </a:rPr>
-              <a:t>Automatiza la asignación y liberación de puertos SC-APC, reduciendo el tiempo de atención técnica de 45 a 15 minutos por suscriptor.</a:t>
+              <a:rPr lang="es-MX" noProof="0"/>
+              <a:t> </a:t>
             </a:r>
-            <a:endParaRPr sz="1400" b="0" i="0" u="none" strike="noStrike" cap="none">
+            <a:r>
+              <a:rPr lang="es-MX" noProof="0" dirty="0"/>
+              <a:t>de este sistema se justifica al transformar integralmente la operatividad y rentabilidad de GPON TELECOM S.A. de C.V., automatizando la asignación y liberación de puertos SC-APC para reducir los tiempos de atención técnica de 45 a tan solo 15 minutos por suscriptor. Asimismo, faculta al centro de operaciones y cuadrillas para disponer de trazabilidad geoespacial en tiempo real con semaforización de saturación, disminuyendo en un 80% los traslados técnicos fallidos por cajas saturadas y protegiendo de forma sustentable la inversión en la infraestructura pasiva de fibra óptica.</a:t>
+            </a:r>
+            <a:endParaRPr lang="es-MX" sz="1400" i="0" u="none" strike="noStrike" cap="none" noProof="0" dirty="0">
               <a:solidFill>
                 <a:srgbClr val="000000"/>
               </a:solidFill>
@@ -20945,81 +20762,6 @@
               <a:cs typeface="Arial"/>
               <a:sym typeface="Arial"/>
             </a:endParaRPr>
-          </a:p>
-          <a:p>
-            <a:pPr>
-              <a:spcAft>
-                <a:spcPts val="600"/>
-              </a:spcAft>
-            </a:pPr>
-            <a:r>
-              <a:rPr sz="1500" b="1" i="0">
-                <a:solidFill>
-                  <a:srgbClr val="000000"/>
-                </a:solidFill>
-                <a:latin typeface="Arial"/>
-              </a:rPr>
-              <a:t>• Trazabilidad Geoespacial: </a:t>
-            </a:r>
-            <a:r>
-              <a:rPr sz="1500" b="0" i="0">
-                <a:solidFill>
-                  <a:srgbClr val="000000"/>
-                </a:solidFill>
-                <a:latin typeface="Arial"/>
-              </a:rPr>
-              <a:t>Faculta al personal de soporte y NOC para visualizar la red mediante cartografía satelital y semáforos de saturación en tiempo real.</a:t>
-            </a:r>
-          </a:p>
-          <a:p>
-            <a:pPr>
-              <a:spcAft>
-                <a:spcPts val="600"/>
-              </a:spcAft>
-            </a:pPr>
-            <a:r>
-              <a:rPr sz="1500" b="1" i="0">
-                <a:solidFill>
-                  <a:srgbClr val="000000"/>
-                </a:solidFill>
-                <a:latin typeface="Arial"/>
-              </a:rPr>
-              <a:t>• Resiliencia en Terreno: </a:t>
-            </a:r>
-            <a:r>
-              <a:rPr sz="1500" b="0" i="0">
-                <a:solidFill>
-                  <a:srgbClr val="000000"/>
-                </a:solidFill>
-                <a:latin typeface="Arial"/>
-              </a:rPr>
-              <a:t>El esquema Offline-First con IndexedDB garantiza continuidad operativa en zonas sin cobertura, sincronizando datos al reconectar.</a:t>
-            </a:r>
-          </a:p>
-          <a:p>
-            <a:pPr>
-              <a:spcAft>
-                <a:spcPts val="600"/>
-              </a:spcAft>
-            </a:pPr>
-            <a:r>
-              <a:rPr sz="1500" b="1" i="0">
-                <a:solidFill>
-                  <a:srgbClr val="000000"/>
-                </a:solidFill>
-                <a:latin typeface="Arial"/>
-              </a:rPr>
-              <a:t>• Reducción de Costos: </a:t>
-            </a:r>
-            <a:r>
-              <a:rPr sz="1500" b="0" i="0">
-                <a:solidFill>
-                  <a:srgbClr val="000000"/>
-                </a:solidFill>
-                <a:latin typeface="Arial"/>
-              </a:rPr>
-              <a:t>Disminuye en un 80% los traslados técnicos fallidos por saturación de cajas NAP y protege la inversión en infraestructura pasiva.</a:t>
-            </a:r>
           </a:p>
         </p:txBody>
       </p:sp>
@@ -21084,7 +20826,7 @@
         <p:spPr>
           <a:xfrm>
             <a:off x="731520" y="1005840"/>
-            <a:ext cx="7680960" cy="3474720"/>
+            <a:ext cx="7680960" cy="3653780"/>
           </a:xfrm>
           <a:prstGeom prst="rect">
             <a:avLst/>
@@ -21100,23 +20842,35 @@
           </a:bodyPr>
           <a:lstStyle/>
           <a:p>
-            <a:pPr>
-              <a:spcAft>
-                <a:spcPts val="600"/>
-              </a:spcAft>
+            <a:pPr algn="l">
+              <a:lnSpc>
+                <a:spcPct val="120000"/>
+              </a:lnSpc>
+              <a:spcBef>
+                <a:spcPts val="0"/>
+              </a:spcBef>
+              <a:spcAft>
+                <a:spcPts val="200"/>
+              </a:spcAft>
+              <a:defRPr sz="1600" b="1" i="0">
+                <a:solidFill>
+                  <a:srgbClr val="111827"/>
+                </a:solidFill>
+                <a:latin typeface="Arial"/>
+              </a:defRPr>
             </a:pPr>
             <a:r>
-              <a:rPr sz="2000" b="1" i="0">
-                <a:solidFill>
-                  <a:srgbClr val="76923C"/>
+              <a:rPr lang="es-MX" sz="1800" noProof="0" dirty="0">
+                <a:solidFill>
+                  <a:schemeClr val="tx1"/>
                 </a:solidFill>
                 <a:latin typeface="Arial"/>
               </a:rPr>
               <a:t>Objetivo General:</a:t>
             </a:r>
-            <a:endParaRPr sz="2400" b="0" i="0" u="none" strike="noStrike" cap="none">
+            <a:endParaRPr lang="es-MX" sz="3200" b="0" i="0" u="none" strike="noStrike" cap="none" noProof="0" dirty="0">
               <a:solidFill>
-                <a:schemeClr val="dk1"/>
+                <a:schemeClr val="tx1"/>
               </a:solidFill>
               <a:latin typeface="Arial"/>
               <a:ea typeface="Arial"/>
@@ -21127,92 +20881,135 @@
           <a:p>
             <a:pPr>
               <a:spcAft>
-                <a:spcPts val="1000"/>
+                <a:spcPts val="1200"/>
               </a:spcAft>
             </a:pPr>
             <a:r>
-              <a:rPr sz="1550" b="0" i="0">
-                <a:solidFill>
-                  <a:srgbClr val="000000"/>
+              <a:rPr lang="es-MX" noProof="0" dirty="0">
+                <a:solidFill>
+                  <a:schemeClr val="tx1"/>
                 </a:solidFill>
                 <a:latin typeface="Arial"/>
               </a:rPr>
-              <a:t>Desarrollar e implementar un sistema web para el inventario y mapeo lógico de la infraestructura de red GPON/FTTx de la empresa GPON TELECOM S.A. de C.V., mediante arquitectura cliente-servidor, bases de datos relacionales y visualización geoespacial, optimizando la asignación de puertos y la trazabilidad técnica en campo.</a:t>
+              <a:t>Desarrollar una aplicación web para el inventario y mapeo lógico de redes GPON/</a:t>
+            </a:r>
+            <a:r>
+              <a:rPr lang="es-MX" noProof="0" dirty="0" err="1">
+                <a:solidFill>
+                  <a:schemeClr val="tx1"/>
+                </a:solidFill>
+                <a:latin typeface="Arial"/>
+              </a:rPr>
+              <a:t>FTTx</a:t>
+            </a:r>
+            <a:r>
+              <a:rPr lang="es-MX" noProof="0" dirty="0">
+                <a:solidFill>
+                  <a:schemeClr val="tx1"/>
+                </a:solidFill>
+                <a:latin typeface="Arial"/>
+              </a:rPr>
+              <a:t>, mediante el diseño de vistas tabulares y diagramas lógicos simples, para optimizar el control de la infraestructura por parte del equipo técnico y de soporte.</a:t>
             </a:r>
           </a:p>
           <a:p>
             <a:pPr>
               <a:spcAft>
-                <a:spcPts val="400"/>
+                <a:spcPts val="200"/>
               </a:spcAft>
             </a:pPr>
             <a:r>
-              <a:rPr sz="1450" b="1" i="0">
-                <a:solidFill>
-                  <a:srgbClr val="000000"/>
+              <a:rPr lang="es-MX" sz="1600" b="1" noProof="0" dirty="0">
+                <a:solidFill>
+                  <a:schemeClr val="tx1"/>
                 </a:solidFill>
                 <a:latin typeface="Arial"/>
               </a:rPr>
-              <a:t>• Alcance de Dominio: </a:t>
-            </a:r>
-            <a:r>
-              <a:rPr sz="1450" b="0" i="0">
-                <a:solidFill>
-                  <a:srgbClr val="000000"/>
-                </a:solidFill>
-                <a:latin typeface="Arial"/>
-              </a:rPr>
-              <a:t>Control pasivo integral desde el ODF central hasta cajas NAP terminales de 16 puertos.</a:t>
+              <a:t>Objetivos Específicos:</a:t>
             </a:r>
           </a:p>
           <a:p>
             <a:pPr>
               <a:spcAft>
-                <a:spcPts val="400"/>
+                <a:spcPts val="500"/>
               </a:spcAft>
             </a:pPr>
             <a:r>
-              <a:rPr sz="1450" b="1" i="0">
-                <a:solidFill>
-                  <a:srgbClr val="000000"/>
+              <a:rPr lang="es-MX" noProof="0" dirty="0">
+                <a:solidFill>
+                  <a:schemeClr val="tx1"/>
                 </a:solidFill>
                 <a:latin typeface="Arial"/>
               </a:rPr>
-              <a:t>• Concurrencia Robusta: </a:t>
-            </a:r>
-            <a:r>
-              <a:rPr sz="1450" b="0" i="0">
-                <a:solidFill>
-                  <a:srgbClr val="000000"/>
-                </a:solidFill>
-                <a:latin typeface="Arial"/>
-              </a:rPr>
-              <a:t>Bloqueo pesimista de registros para garantizar consistencia transaccional ACID.</a:t>
+              <a:t>1. Analizar los requerimientos operativos de la red de fibra óptica mediante el levantamiento de información sobre el hardware (NAP/ODF), para diseñar la arquitectura del sistema y el modelo de la base de datos.</a:t>
             </a:r>
           </a:p>
           <a:p>
             <a:pPr>
               <a:spcAft>
-                <a:spcPts val="400"/>
+                <a:spcPts val="500"/>
               </a:spcAft>
             </a:pPr>
             <a:r>
-              <a:rPr sz="1450" b="1" i="0">
-                <a:solidFill>
-                  <a:srgbClr val="000000"/>
+              <a:rPr lang="es-MX" noProof="0" dirty="0">
+                <a:solidFill>
+                  <a:schemeClr val="tx1"/>
                 </a:solidFill>
                 <a:latin typeface="Arial"/>
               </a:rPr>
-              <a:t>• Disponibilidad Móvil: </a:t>
+              <a:t>2. Construir una interfaz web responsiva a través del uso de tecnologías de desarrollo </a:t>
             </a:r>
             <a:r>
-              <a:rPr sz="1450" b="0" i="0">
-                <a:solidFill>
-                  <a:srgbClr val="000000"/>
+              <a:rPr lang="es-MX" noProof="0" dirty="0" err="1">
+                <a:solidFill>
+                  <a:schemeClr val="tx1"/>
                 </a:solidFill>
                 <a:latin typeface="Arial"/>
               </a:rPr>
-              <a:t>Sincronización diferida y operación continua en cuadrillas técnicas de campo.</a:t>
+              <a:t>frontend</a:t>
+            </a:r>
+            <a:r>
+              <a:rPr lang="es-MX" noProof="0" dirty="0">
+                <a:solidFill>
+                  <a:schemeClr val="tx1"/>
+                </a:solidFill>
+                <a:latin typeface="Arial"/>
+              </a:rPr>
+              <a:t>, para que los técnicos de campo actualicen desde su celular el estado de los puertos (libres, ocupados, dañados).</a:t>
+            </a:r>
+          </a:p>
+          <a:p>
+            <a:pPr>
+              <a:spcAft>
+                <a:spcPts val="500"/>
+              </a:spcAft>
+            </a:pPr>
+            <a:r>
+              <a:rPr lang="es-MX" noProof="0" dirty="0">
+                <a:solidFill>
+                  <a:schemeClr val="tx1"/>
+                </a:solidFill>
+                <a:latin typeface="Arial"/>
+              </a:rPr>
+              <a:t>3. Programar el </a:t>
+            </a:r>
+            <a:r>
+              <a:rPr lang="es-MX" noProof="0" dirty="0" err="1">
+                <a:solidFill>
+                  <a:schemeClr val="tx1"/>
+                </a:solidFill>
+                <a:latin typeface="Arial"/>
+              </a:rPr>
+              <a:t>backend</a:t>
+            </a:r>
+            <a:r>
+              <a:rPr lang="es-MX" noProof="0" dirty="0">
+                <a:solidFill>
+                  <a:schemeClr val="tx1"/>
+                </a:solidFill>
+                <a:latin typeface="Arial"/>
+              </a:rPr>
+              <a:t> del sistema mediante la creación de una API centralizada, para gestionar la información de los activos y vincular los puertos de red correspondientes a los datos de los clientes.</a:t>
             </a:r>
           </a:p>
         </p:txBody>
@@ -21252,7 +21049,7 @@
           <a:p>
             <a:pPr algn="r"/>
             <a:r>
-              <a:rPr sz="4400" b="0" i="0">
+              <a:rPr lang="es-MX" sz="4400" b="0" i="0" noProof="0" dirty="0">
                 <a:solidFill>
                   <a:srgbClr val="76923C"/>
                 </a:solidFill>
@@ -21260,7 +21057,7 @@
               </a:rPr>
               <a:t>Objetivos</a:t>
             </a:r>
-            <a:endParaRPr sz="3500" b="0" i="0" u="none" strike="noStrike" cap="none">
+            <a:endParaRPr lang="es-MX" sz="3500" b="0" i="0" u="none" strike="noStrike" cap="none" noProof="0" dirty="0">
               <a:solidFill>
                 <a:srgbClr val="76923C"/>
               </a:solidFill>
@@ -21306,7 +21103,7 @@
           <a:lstStyle/>
           <a:p>
             <a:r>
-              <a:rPr sz="1600" b="0" i="0">
+              <a:rPr lang="es-MX" sz="1600" b="0" i="0" noProof="0" dirty="0">
                 <a:solidFill>
                   <a:srgbClr val="76923C"/>
                 </a:solidFill>
@@ -21314,7 +21111,7 @@
               </a:rPr>
               <a:t>8/15</a:t>
             </a:r>
-            <a:endParaRPr sz="1400" b="0" i="0" u="none" strike="noStrike" cap="none">
+            <a:endParaRPr lang="es-MX" sz="1400" b="0" i="0" u="none" strike="noStrike" cap="none" noProof="0" dirty="0">
               <a:solidFill>
                 <a:srgbClr val="000000"/>
               </a:solidFill>
@@ -21380,215 +21177,14 @@
       </p:pic>
       <p:sp>
         <p:nvSpPr>
-          <p:cNvPr id="159" name="Google Shape;159;p9"/>
-          <p:cNvSpPr/>
-          <p:nvPr/>
-        </p:nvSpPr>
-        <p:spPr>
-          <a:xfrm>
-            <a:off x="731520" y="960120"/>
-            <a:ext cx="7680960" cy="3566160"/>
-          </a:xfrm>
-          <a:prstGeom prst="rect">
-            <a:avLst/>
-          </a:prstGeom>
-          <a:noFill/>
-          <a:ln>
-            <a:noFill/>
-          </a:ln>
-        </p:spPr>
-        <p:txBody>
-          <a:bodyPr spcFirstLastPara="1" wrap="square" lIns="91425" tIns="45700" rIns="91425" bIns="45700" anchor="t" anchorCtr="0">
-            <a:spAutoFit/>
-          </a:bodyPr>
-          <a:lstStyle/>
-          <a:p>
-            <a:pPr>
-              <a:spcAft>
-                <a:spcPts val="400"/>
-              </a:spcAft>
-            </a:pPr>
-            <a:r>
-              <a:rPr sz="1900" b="1" i="0">
-                <a:solidFill>
-                  <a:srgbClr val="76923C"/>
-                </a:solidFill>
-                <a:latin typeface="Arial"/>
-              </a:rPr>
-              <a:t>Objetivos Específicos:</a:t>
-            </a:r>
-            <a:endParaRPr sz="1400" b="0" i="0" u="none" strike="noStrike" cap="none">
-              <a:solidFill>
-                <a:srgbClr val="000000"/>
-              </a:solidFill>
-              <a:latin typeface="Arial"/>
-              <a:ea typeface="Arial"/>
-              <a:cs typeface="Arial"/>
-              <a:sym typeface="Arial"/>
-            </a:endParaRPr>
-          </a:p>
-          <a:p>
-            <a:pPr>
-              <a:spcAft>
-                <a:spcPts val="300"/>
-              </a:spcAft>
-            </a:pPr>
-            <a:r>
-              <a:rPr sz="1400" b="1" i="0">
-                <a:solidFill>
-                  <a:srgbClr val="000000"/>
-                </a:solidFill>
-                <a:latin typeface="Arial"/>
-              </a:rPr>
-              <a:t>1. Levantamiento e Infraestructura: </a:t>
-            </a:r>
-            <a:r>
-              <a:rPr sz="1400" b="0" i="0">
-                <a:solidFill>
-                  <a:srgbClr val="000000"/>
-                </a:solidFill>
-                <a:latin typeface="Arial"/>
-              </a:rPr>
-              <a:t>Caracterizar la red GPON pasiva (ODF, splitters PLC 1:4 y 1:16, cajas NAP y acometidas de fibra).</a:t>
-            </a:r>
-          </a:p>
-          <a:p>
-            <a:pPr>
-              <a:spcAft>
-                <a:spcPts val="300"/>
-              </a:spcAft>
-            </a:pPr>
-            <a:r>
-              <a:rPr sz="1400" b="1" i="0">
-                <a:solidFill>
-                  <a:srgbClr val="000000"/>
-                </a:solidFill>
-                <a:latin typeface="Arial"/>
-              </a:rPr>
-              <a:t>2. Modelado de Datos y Arquitectura: </a:t>
-            </a:r>
-            <a:r>
-              <a:rPr sz="1400" b="0" i="0">
-                <a:solidFill>
-                  <a:srgbClr val="000000"/>
-                </a:solidFill>
-                <a:latin typeface="Arial"/>
-              </a:rPr>
-              <a:t>Diseñar la base de datos relacional y los diagramas estructurales (DER notación Chen, casos de uso y secuencia UML).</a:t>
-            </a:r>
-          </a:p>
-          <a:p>
-            <a:pPr>
-              <a:spcAft>
-                <a:spcPts val="300"/>
-              </a:spcAft>
-            </a:pPr>
-            <a:r>
-              <a:rPr sz="1400" b="1" i="0">
-                <a:solidFill>
-                  <a:srgbClr val="000000"/>
-                </a:solidFill>
-                <a:latin typeface="Arial"/>
-              </a:rPr>
-              <a:t>3. Cartografía Web Responsiva: </a:t>
-            </a:r>
-            <a:r>
-              <a:rPr sz="1400" b="0" i="0">
-                <a:solidFill>
-                  <a:srgbClr val="000000"/>
-                </a:solidFill>
-                <a:latin typeface="Arial"/>
-              </a:rPr>
-              <a:t>Maquetar e implementar interfaces de usuario optimizadas para móviles con mapas satelitales en React Leaflet.</a:t>
-            </a:r>
-          </a:p>
-          <a:p>
-            <a:pPr>
-              <a:spcAft>
-                <a:spcPts val="300"/>
-              </a:spcAft>
-            </a:pPr>
-            <a:r>
-              <a:rPr sz="1400" b="1" i="0">
-                <a:solidFill>
-                  <a:srgbClr val="000000"/>
-                </a:solidFill>
-                <a:latin typeface="Arial"/>
-              </a:rPr>
-              <a:t>4. Backend Transaccional: </a:t>
-            </a:r>
-            <a:r>
-              <a:rPr sz="1400" b="0" i="0">
-                <a:solidFill>
-                  <a:srgbClr val="000000"/>
-                </a:solidFill>
-                <a:latin typeface="Arial"/>
-              </a:rPr>
-              <a:t>Programar la API REST en Node.js/PostgreSQL con bloqueo pesimista (SELECT ... FOR UPDATE) y autenticación JWT.</a:t>
-            </a:r>
-          </a:p>
-          <a:p>
-            <a:pPr>
-              <a:spcAft>
-                <a:spcPts val="300"/>
-              </a:spcAft>
-            </a:pPr>
-            <a:r>
-              <a:rPr sz="1400" b="1" i="0">
-                <a:solidFill>
-                  <a:srgbClr val="000000"/>
-                </a:solidFill>
-                <a:latin typeface="Arial"/>
-              </a:rPr>
-              <a:t>5. Motor Offline-First: </a:t>
-            </a:r>
-            <a:r>
-              <a:rPr sz="1400" b="0" i="0">
-                <a:solidFill>
-                  <a:srgbClr val="000000"/>
-                </a:solidFill>
-                <a:latin typeface="Arial"/>
-              </a:rPr>
-              <a:t>Desarrollar persistencia local en Dexie.js (IndexedDB) para sincronización automática de operaciones en campo.</a:t>
-            </a:r>
-          </a:p>
-          <a:p>
-            <a:pPr>
-              <a:spcAft>
-                <a:spcPts val="300"/>
-              </a:spcAft>
-            </a:pPr>
-            <a:r>
-              <a:rPr sz="1400" b="1" i="0">
-                <a:solidFill>
-                  <a:srgbClr val="000000"/>
-                </a:solidFill>
-                <a:latin typeface="Arial"/>
-              </a:rPr>
-              <a:t>6. Validación y Reportes: </a:t>
-            </a:r>
-            <a:r>
-              <a:rPr sz="1400" b="0" i="0">
-                <a:solidFill>
-                  <a:srgbClr val="000000"/>
-                </a:solidFill>
-                <a:latin typeface="Arial"/>
-              </a:rPr>
-              <a:t>Ejecutar pruebas de consistencia concurrente, contrastes WCAG 2.1 y generación de reportes técnicos PDF.</a:t>
-            </a:r>
-          </a:p>
-        </p:txBody>
-      </p:sp>
-      <p:sp>
-        <p:nvSpPr>
           <p:cNvPr id="160" name="Google Shape;160;p9"/>
           <p:cNvSpPr/>
           <p:nvPr/>
         </p:nvSpPr>
         <p:spPr>
           <a:xfrm>
-            <a:off x="6592725" y="13603"/>
-            <a:ext cx="2551275" cy="830997"/>
+            <a:off x="5261549" y="13603"/>
+            <a:ext cx="3882452" cy="769401"/>
           </a:xfrm>
           <a:prstGeom prst="rect">
             <a:avLst/>
@@ -21612,25 +21208,15 @@
           </a:bodyPr>
           <a:lstStyle/>
           <a:p>
-            <a:pPr algn="r"/>
             <a:r>
-              <a:rPr sz="4400" b="0" i="0">
-                <a:solidFill>
-                  <a:srgbClr val="76923C"/>
-                </a:solidFill>
-                <a:latin typeface="Calibri"/>
+              <a:rPr lang="es-MX" sz="4400" noProof="0" dirty="0">
+                <a:solidFill>
+                  <a:schemeClr val="accent3"/>
+                </a:solidFill>
+                <a:latin typeface="Arial"/>
               </a:rPr>
-              <a:t>Objetivos</a:t>
+              <a:t>Herramientas</a:t>
             </a:r>
-            <a:endParaRPr sz="3500" b="0" i="0" u="none" strike="noStrike" cap="none">
-              <a:solidFill>
-                <a:srgbClr val="76923C"/>
-              </a:solidFill>
-              <a:latin typeface="Calibri"/>
-              <a:ea typeface="Calibri"/>
-              <a:cs typeface="Calibri"/>
-              <a:sym typeface="Calibri"/>
-            </a:endParaRPr>
           </a:p>
         </p:txBody>
       </p:sp>
@@ -21668,26 +21254,412 @@
           <a:lstStyle/>
           <a:p>
             <a:r>
-              <a:rPr sz="1600" b="0" i="0">
-                <a:solidFill>
-                  <a:srgbClr val="76923C"/>
-                </a:solidFill>
-                <a:latin typeface="Calibri"/>
-              </a:rPr>
+              <a:rPr lang="es-MX" noProof="0" dirty="0"/>
               <a:t>9/15</a:t>
             </a:r>
-            <a:endParaRPr sz="1400" b="0" i="0" u="none" strike="noStrike" cap="none">
-              <a:solidFill>
-                <a:srgbClr val="000000"/>
-              </a:solidFill>
-              <a:latin typeface="Arial"/>
-              <a:ea typeface="Arial"/>
-              <a:cs typeface="Arial"/>
-              <a:sym typeface="Arial"/>
-            </a:endParaRPr>
           </a:p>
         </p:txBody>
       </p:sp>
+      <p:pic>
+        <p:nvPicPr>
+          <p:cNvPr id="164" name="Picture 163" descr="image.png"/>
+          <p:cNvPicPr>
+            <a:picLocks noChangeAspect="1"/>
+          </p:cNvPicPr>
+          <p:nvPr/>
+        </p:nvPicPr>
+        <p:blipFill>
+          <a:blip r:embed="rId4"/>
+          <a:stretch>
+            <a:fillRect/>
+          </a:stretch>
+        </p:blipFill>
+        <p:spPr>
+          <a:xfrm>
+            <a:off x="251463" y="1555337"/>
+            <a:ext cx="1080000" cy="723600"/>
+          </a:xfrm>
+          <a:prstGeom prst="rect">
+            <a:avLst/>
+          </a:prstGeom>
+        </p:spPr>
+      </p:pic>
+      <p:pic>
+        <p:nvPicPr>
+          <p:cNvPr id="165" name="Picture 164" descr="image.png"/>
+          <p:cNvPicPr>
+            <a:picLocks noChangeAspect="1"/>
+          </p:cNvPicPr>
+          <p:nvPr/>
+        </p:nvPicPr>
+        <p:blipFill>
+          <a:blip r:embed="rId5"/>
+          <a:stretch>
+            <a:fillRect/>
+          </a:stretch>
+        </p:blipFill>
+        <p:spPr>
+          <a:xfrm>
+            <a:off x="3223506" y="2497675"/>
+            <a:ext cx="1080000" cy="1080000"/>
+          </a:xfrm>
+          <a:prstGeom prst="rect">
+            <a:avLst/>
+          </a:prstGeom>
+        </p:spPr>
+      </p:pic>
+      <p:pic>
+        <p:nvPicPr>
+          <p:cNvPr id="166" name="Picture 165" descr="image.png"/>
+          <p:cNvPicPr>
+            <a:picLocks noChangeAspect="1"/>
+          </p:cNvPicPr>
+          <p:nvPr/>
+        </p:nvPicPr>
+        <p:blipFill>
+          <a:blip r:embed="rId6"/>
+          <a:stretch>
+            <a:fillRect/>
+          </a:stretch>
+        </p:blipFill>
+        <p:spPr>
+          <a:xfrm>
+            <a:off x="1403109" y="2781095"/>
+            <a:ext cx="1080000" cy="645469"/>
+          </a:xfrm>
+          <a:prstGeom prst="rect">
+            <a:avLst/>
+          </a:prstGeom>
+        </p:spPr>
+      </p:pic>
+      <p:pic>
+        <p:nvPicPr>
+          <p:cNvPr id="167" name="Picture 166" descr="image.png"/>
+          <p:cNvPicPr>
+            <a:picLocks noChangeAspect="1"/>
+          </p:cNvPicPr>
+          <p:nvPr/>
+        </p:nvPicPr>
+        <p:blipFill>
+          <a:blip r:embed="rId7"/>
+          <a:stretch>
+            <a:fillRect/>
+          </a:stretch>
+        </p:blipFill>
+        <p:spPr>
+          <a:xfrm>
+            <a:off x="139269" y="2571744"/>
+            <a:ext cx="1080000" cy="1064180"/>
+          </a:xfrm>
+          <a:prstGeom prst="rect">
+            <a:avLst/>
+          </a:prstGeom>
+        </p:spPr>
+      </p:pic>
+      <p:pic>
+        <p:nvPicPr>
+          <p:cNvPr id="168" name="Picture 167" descr="image.png"/>
+          <p:cNvPicPr>
+            <a:picLocks noChangeAspect="1"/>
+          </p:cNvPicPr>
+          <p:nvPr/>
+        </p:nvPicPr>
+        <p:blipFill>
+          <a:blip r:embed="rId8"/>
+          <a:stretch>
+            <a:fillRect/>
+          </a:stretch>
+        </p:blipFill>
+        <p:spPr>
+          <a:xfrm>
+            <a:off x="1219269" y="1372292"/>
+            <a:ext cx="1080000" cy="1038322"/>
+          </a:xfrm>
+          <a:prstGeom prst="rect">
+            <a:avLst/>
+          </a:prstGeom>
+        </p:spPr>
+      </p:pic>
+      <p:pic>
+        <p:nvPicPr>
+          <p:cNvPr id="169" name="Picture 168" descr="image.png"/>
+          <p:cNvPicPr>
+            <a:picLocks noChangeAspect="1"/>
+          </p:cNvPicPr>
+          <p:nvPr/>
+        </p:nvPicPr>
+        <p:blipFill>
+          <a:blip r:embed="rId9"/>
+          <a:stretch>
+            <a:fillRect/>
+          </a:stretch>
+        </p:blipFill>
+        <p:spPr>
+          <a:xfrm>
+            <a:off x="3075956" y="1608836"/>
+            <a:ext cx="1080000" cy="617196"/>
+          </a:xfrm>
+          <a:prstGeom prst="rect">
+            <a:avLst/>
+          </a:prstGeom>
+        </p:spPr>
+      </p:pic>
+      <p:pic>
+        <p:nvPicPr>
+          <p:cNvPr id="170" name="Picture 169" descr="image.png"/>
+          <p:cNvPicPr>
+            <a:picLocks noChangeAspect="1"/>
+          </p:cNvPicPr>
+          <p:nvPr/>
+        </p:nvPicPr>
+        <p:blipFill>
+          <a:blip r:embed="rId10"/>
+          <a:stretch>
+            <a:fillRect/>
+          </a:stretch>
+        </p:blipFill>
+        <p:spPr>
+          <a:xfrm>
+            <a:off x="3223506" y="3784424"/>
+            <a:ext cx="1080000" cy="295082"/>
+          </a:xfrm>
+          <a:prstGeom prst="rect">
+            <a:avLst/>
+          </a:prstGeom>
+        </p:spPr>
+      </p:pic>
+      <p:pic>
+        <p:nvPicPr>
+          <p:cNvPr id="171" name="Picture 170" descr="image.png"/>
+          <p:cNvPicPr>
+            <a:picLocks noChangeAspect="1"/>
+          </p:cNvPicPr>
+          <p:nvPr/>
+        </p:nvPicPr>
+        <p:blipFill>
+          <a:blip r:embed="rId11"/>
+          <a:stretch>
+            <a:fillRect/>
+          </a:stretch>
+        </p:blipFill>
+        <p:spPr>
+          <a:xfrm>
+            <a:off x="4032000" y="4305664"/>
+            <a:ext cx="1080000" cy="1080000"/>
+          </a:xfrm>
+          <a:prstGeom prst="rect">
+            <a:avLst/>
+          </a:prstGeom>
+        </p:spPr>
+      </p:pic>
+      <p:pic>
+        <p:nvPicPr>
+          <p:cNvPr id="172" name="Picture 171" descr="image.png"/>
+          <p:cNvPicPr>
+            <a:picLocks noChangeAspect="1"/>
+          </p:cNvPicPr>
+          <p:nvPr/>
+        </p:nvPicPr>
+        <p:blipFill>
+          <a:blip r:embed="rId12"/>
+          <a:stretch>
+            <a:fillRect/>
+          </a:stretch>
+        </p:blipFill>
+        <p:spPr>
+          <a:xfrm>
+            <a:off x="4370128" y="1575834"/>
+            <a:ext cx="1080000" cy="675000"/>
+          </a:xfrm>
+          <a:prstGeom prst="rect">
+            <a:avLst/>
+          </a:prstGeom>
+        </p:spPr>
+      </p:pic>
+      <p:pic>
+        <p:nvPicPr>
+          <p:cNvPr id="173" name="Picture 172" descr="image.png"/>
+          <p:cNvPicPr>
+            <a:picLocks noChangeAspect="1"/>
+          </p:cNvPicPr>
+          <p:nvPr/>
+        </p:nvPicPr>
+        <p:blipFill>
+          <a:blip r:embed="rId13"/>
+          <a:stretch>
+            <a:fillRect/>
+          </a:stretch>
+        </p:blipFill>
+        <p:spPr>
+          <a:xfrm>
+            <a:off x="4370128" y="2470277"/>
+            <a:ext cx="1080000" cy="1080000"/>
+          </a:xfrm>
+          <a:prstGeom prst="rect">
+            <a:avLst/>
+          </a:prstGeom>
+        </p:spPr>
+      </p:pic>
+      <p:pic>
+        <p:nvPicPr>
+          <p:cNvPr id="174" name="Picture 173" descr="image.png"/>
+          <p:cNvPicPr>
+            <a:picLocks noChangeAspect="1"/>
+          </p:cNvPicPr>
+          <p:nvPr/>
+        </p:nvPicPr>
+        <p:blipFill>
+          <a:blip r:embed="rId14"/>
+          <a:stretch>
+            <a:fillRect/>
+          </a:stretch>
+        </p:blipFill>
+        <p:spPr>
+          <a:xfrm>
+            <a:off x="4472570" y="3635497"/>
+            <a:ext cx="1080000" cy="474188"/>
+          </a:xfrm>
+          <a:prstGeom prst="rect">
+            <a:avLst/>
+          </a:prstGeom>
+        </p:spPr>
+      </p:pic>
+      <p:sp>
+        <p:nvSpPr>
+          <p:cNvPr id="2" name="CuadroTexto 1">
+            <a:extLst>
+              <a:ext uri="{FF2B5EF4-FFF2-40B4-BE49-F238E27FC236}">
+                <a16:creationId xmlns:a16="http://schemas.microsoft.com/office/drawing/2014/main" id="{A749F498-D431-C86C-B805-9F6D5C9B938B}"/>
+              </a:ext>
+            </a:extLst>
+          </p:cNvPr>
+          <p:cNvSpPr txBox="1"/>
+          <p:nvPr/>
+        </p:nvSpPr>
+        <p:spPr>
+          <a:xfrm>
+            <a:off x="804000" y="1022397"/>
+            <a:ext cx="1304925" cy="523220"/>
+          </a:xfrm>
+          <a:prstGeom prst="rect">
+            <a:avLst/>
+          </a:prstGeom>
+          <a:noFill/>
+        </p:spPr>
+        <p:txBody>
+          <a:bodyPr wrap="square" rtlCol="0">
+            <a:spAutoFit/>
+          </a:bodyPr>
+          <a:lstStyle/>
+          <a:p>
+            <a:r>
+              <a:rPr lang="es-MX" sz="2800" dirty="0"/>
+              <a:t>Diseño</a:t>
+            </a:r>
+          </a:p>
+        </p:txBody>
+      </p:sp>
+      <p:sp>
+        <p:nvSpPr>
+          <p:cNvPr id="3" name="CuadroTexto 2">
+            <a:extLst>
+              <a:ext uri="{FF2B5EF4-FFF2-40B4-BE49-F238E27FC236}">
+                <a16:creationId xmlns:a16="http://schemas.microsoft.com/office/drawing/2014/main" id="{F4C40722-6710-9592-D786-497A053D4FC2}"/>
+              </a:ext>
+            </a:extLst>
+          </p:cNvPr>
+          <p:cNvSpPr txBox="1"/>
+          <p:nvPr/>
+        </p:nvSpPr>
+        <p:spPr>
+          <a:xfrm>
+            <a:off x="3223506" y="1026297"/>
+            <a:ext cx="2498128" cy="523220"/>
+          </a:xfrm>
+          <a:prstGeom prst="rect">
+            <a:avLst/>
+          </a:prstGeom>
+          <a:noFill/>
+        </p:spPr>
+        <p:txBody>
+          <a:bodyPr wrap="square" rtlCol="0">
+            <a:spAutoFit/>
+          </a:bodyPr>
+          <a:lstStyle/>
+          <a:p>
+            <a:r>
+              <a:rPr lang="es-MX" sz="2800" dirty="0"/>
+              <a:t>Funcionalidad</a:t>
+            </a:r>
+          </a:p>
+        </p:txBody>
+      </p:sp>
+      <p:sp>
+        <p:nvSpPr>
+          <p:cNvPr id="5" name="CuadroTexto 4">
+            <a:extLst>
+              <a:ext uri="{FF2B5EF4-FFF2-40B4-BE49-F238E27FC236}">
+                <a16:creationId xmlns:a16="http://schemas.microsoft.com/office/drawing/2014/main" id="{8ED9B067-6DFA-C3BC-FA82-AC8BDFF41E33}"/>
+              </a:ext>
+            </a:extLst>
+          </p:cNvPr>
+          <p:cNvSpPr txBox="1"/>
+          <p:nvPr/>
+        </p:nvSpPr>
+        <p:spPr>
+          <a:xfrm>
+            <a:off x="6379171" y="1026297"/>
+            <a:ext cx="2498128" cy="523220"/>
+          </a:xfrm>
+          <a:prstGeom prst="rect">
+            <a:avLst/>
+          </a:prstGeom>
+          <a:noFill/>
+        </p:spPr>
+        <p:txBody>
+          <a:bodyPr wrap="square" rtlCol="0">
+            <a:spAutoFit/>
+          </a:bodyPr>
+          <a:lstStyle/>
+          <a:p>
+            <a:r>
+              <a:rPr lang="es-MX" sz="2800" dirty="0"/>
+              <a:t>Base de datos</a:t>
+            </a:r>
+          </a:p>
+        </p:txBody>
+      </p:sp>
+      <p:pic>
+        <p:nvPicPr>
+          <p:cNvPr id="6" name="Imagen 5" descr="The Best in Open Source Database Software: Top 10 Picks">
+            <a:extLst>
+              <a:ext uri="{FF2B5EF4-FFF2-40B4-BE49-F238E27FC236}">
+                <a16:creationId xmlns:a16="http://schemas.microsoft.com/office/drawing/2014/main" id="{EA1A0C59-E598-1339-5263-2944F0B67279}"/>
+              </a:ext>
+            </a:extLst>
+          </p:cNvPr>
+          <p:cNvPicPr>
+            <a:picLocks noChangeAspect="1"/>
+          </p:cNvPicPr>
+          <p:nvPr/>
+        </p:nvPicPr>
+        <p:blipFill>
+          <a:blip r:embed="rId15"/>
+          <a:srcRect l="25474" r="20743"/>
+          <a:stretch>
+            <a:fillRect/>
+          </a:stretch>
+        </p:blipFill>
+        <p:spPr>
+          <a:xfrm>
+            <a:off x="6715758" y="1978514"/>
+            <a:ext cx="1824953" cy="1038322"/>
+          </a:xfrm>
+          <a:prstGeom prst="rect">
+            <a:avLst/>
+          </a:prstGeom>
+        </p:spPr>
+      </p:pic>
     </p:spTree>
   </p:cSld>
   <p:clrMapOvr>

</xml_diff>